<commit_message>
Clarify Lecture 2 evidence and add optional explanations
</commit_message>
<xml_diff>
--- a/teaching/macro-applications/downloads/lecture_2.pptx
+++ b/teaching/macro-applications/downloads/lecture_2.pptx
@@ -2,38 +2,38 @@
 <file path=ppt/presentation.xml><?xml version="1.0" encoding="utf-8"?>
 <p:presentation xmlns:p="http://schemas.openxmlformats.org/presentationml/2006/main">
   <p:sldMasterIdLst>
-    <p:sldMasterId xmlns:r="http://schemas.openxmlformats.org/officeDocument/2006/relationships" id="2147483648" r:id="Rd9690fe74b764841"/>
+    <p:sldMasterId xmlns:r="http://schemas.openxmlformats.org/officeDocument/2006/relationships" id="2147483648" r:id="Re48a85af298d4d2a"/>
   </p:sldMasterIdLst>
   <p:notesMasterIdLst>
-    <p:notesMasterId xmlns:r="http://schemas.openxmlformats.org/officeDocument/2006/relationships" r:id="R9bc79d9e60354bf0"/>
+    <p:notesMasterId xmlns:r="http://schemas.openxmlformats.org/officeDocument/2006/relationships" r:id="Rc0c15c0c06c84900"/>
   </p:notesMasterIdLst>
   <p:sldIdLst>
-    <p:sldId xmlns:r="http://schemas.openxmlformats.org/officeDocument/2006/relationships" id="256" r:id="Rb54ae1d72b3643e6"/>
-    <p:sldId xmlns:r="http://schemas.openxmlformats.org/officeDocument/2006/relationships" id="257" r:id="R0c601c12a98147c8"/>
-    <p:sldId xmlns:r="http://schemas.openxmlformats.org/officeDocument/2006/relationships" id="258" r:id="Rd11f7fd3465c443e"/>
-    <p:sldId xmlns:r="http://schemas.openxmlformats.org/officeDocument/2006/relationships" id="259" r:id="R6a4e44ad002f4d8c"/>
-    <p:sldId xmlns:r="http://schemas.openxmlformats.org/officeDocument/2006/relationships" id="260" r:id="Rc78d647bdbad45dd"/>
-    <p:sldId xmlns:r="http://schemas.openxmlformats.org/officeDocument/2006/relationships" id="261" r:id="R63ee30153ce348bd"/>
-    <p:sldId xmlns:r="http://schemas.openxmlformats.org/officeDocument/2006/relationships" id="262" r:id="R3ac25aee9aa149bd"/>
-    <p:sldId xmlns:r="http://schemas.openxmlformats.org/officeDocument/2006/relationships" id="263" r:id="Rc385e8137a804336"/>
-    <p:sldId xmlns:r="http://schemas.openxmlformats.org/officeDocument/2006/relationships" id="264" r:id="Rccc2ebd6e6da4aa0"/>
-    <p:sldId xmlns:r="http://schemas.openxmlformats.org/officeDocument/2006/relationships" id="265" r:id="R9a7fc1776d404b8f"/>
-    <p:sldId xmlns:r="http://schemas.openxmlformats.org/officeDocument/2006/relationships" id="266" r:id="R547032906ccd4228"/>
-    <p:sldId xmlns:r="http://schemas.openxmlformats.org/officeDocument/2006/relationships" id="267" r:id="R1154f56f805343aa"/>
-    <p:sldId xmlns:r="http://schemas.openxmlformats.org/officeDocument/2006/relationships" id="268" r:id="Rff787f2a283d4ac1"/>
-    <p:sldId xmlns:r="http://schemas.openxmlformats.org/officeDocument/2006/relationships" id="269" r:id="R645c6f848e24435f"/>
-    <p:sldId xmlns:r="http://schemas.openxmlformats.org/officeDocument/2006/relationships" id="270" r:id="R0857d348ed6047d9"/>
-    <p:sldId xmlns:r="http://schemas.openxmlformats.org/officeDocument/2006/relationships" id="271" r:id="Rd02182f822604552"/>
-    <p:sldId xmlns:r="http://schemas.openxmlformats.org/officeDocument/2006/relationships" id="272" r:id="Rae713525d91e4a30"/>
-    <p:sldId xmlns:r="http://schemas.openxmlformats.org/officeDocument/2006/relationships" id="273" r:id="Re6aa295cac8c4b16"/>
-    <p:sldId xmlns:r="http://schemas.openxmlformats.org/officeDocument/2006/relationships" id="274" r:id="Ref1be14a6f6e47dc"/>
-    <p:sldId xmlns:r="http://schemas.openxmlformats.org/officeDocument/2006/relationships" id="275" r:id="R83416acaa35b4282"/>
-    <p:sldId xmlns:r="http://schemas.openxmlformats.org/officeDocument/2006/relationships" id="276" r:id="R7b2744aacaed4f4c"/>
-    <p:sldId xmlns:r="http://schemas.openxmlformats.org/officeDocument/2006/relationships" id="277" r:id="R37c0e373f9ee4c0d"/>
-    <p:sldId xmlns:r="http://schemas.openxmlformats.org/officeDocument/2006/relationships" id="278" r:id="R8cd0717d8d2e4053"/>
-    <p:sldId xmlns:r="http://schemas.openxmlformats.org/officeDocument/2006/relationships" id="279" r:id="R32081dca19c0454e"/>
-    <p:sldId xmlns:r="http://schemas.openxmlformats.org/officeDocument/2006/relationships" id="280" r:id="R02644cbb1fe6431e"/>
-    <p:sldId xmlns:r="http://schemas.openxmlformats.org/officeDocument/2006/relationships" id="281" r:id="Rc76ac836efc346c6"/>
+    <p:sldId xmlns:r="http://schemas.openxmlformats.org/officeDocument/2006/relationships" id="256" r:id="R4db49d6fca9346ef"/>
+    <p:sldId xmlns:r="http://schemas.openxmlformats.org/officeDocument/2006/relationships" id="257" r:id="Re67f627f0c9e47ba"/>
+    <p:sldId xmlns:r="http://schemas.openxmlformats.org/officeDocument/2006/relationships" id="258" r:id="R9b75f86c2f3e45ea"/>
+    <p:sldId xmlns:r="http://schemas.openxmlformats.org/officeDocument/2006/relationships" id="259" r:id="R412fc51bdaf941d8"/>
+    <p:sldId xmlns:r="http://schemas.openxmlformats.org/officeDocument/2006/relationships" id="260" r:id="R6a608acd17af4c58"/>
+    <p:sldId xmlns:r="http://schemas.openxmlformats.org/officeDocument/2006/relationships" id="261" r:id="Rafa03f3c18ad4e05"/>
+    <p:sldId xmlns:r="http://schemas.openxmlformats.org/officeDocument/2006/relationships" id="262" r:id="R57e72d556e734f79"/>
+    <p:sldId xmlns:r="http://schemas.openxmlformats.org/officeDocument/2006/relationships" id="263" r:id="R3453f64f3f254491"/>
+    <p:sldId xmlns:r="http://schemas.openxmlformats.org/officeDocument/2006/relationships" id="264" r:id="R4d0f6cc0538d45fa"/>
+    <p:sldId xmlns:r="http://schemas.openxmlformats.org/officeDocument/2006/relationships" id="265" r:id="R5df99b1a126c492d"/>
+    <p:sldId xmlns:r="http://schemas.openxmlformats.org/officeDocument/2006/relationships" id="266" r:id="R1f9dfadadff04f3f"/>
+    <p:sldId xmlns:r="http://schemas.openxmlformats.org/officeDocument/2006/relationships" id="267" r:id="R4bf47a9baa884cd5"/>
+    <p:sldId xmlns:r="http://schemas.openxmlformats.org/officeDocument/2006/relationships" id="268" r:id="R56b382d6c9a6466c"/>
+    <p:sldId xmlns:r="http://schemas.openxmlformats.org/officeDocument/2006/relationships" id="269" r:id="R9d9f04b366b44ce1"/>
+    <p:sldId xmlns:r="http://schemas.openxmlformats.org/officeDocument/2006/relationships" id="270" r:id="Rf832e2377eff4c82"/>
+    <p:sldId xmlns:r="http://schemas.openxmlformats.org/officeDocument/2006/relationships" id="271" r:id="Rcd3bc5877a0045a4"/>
+    <p:sldId xmlns:r="http://schemas.openxmlformats.org/officeDocument/2006/relationships" id="272" r:id="R1d243698a0a34e1b"/>
+    <p:sldId xmlns:r="http://schemas.openxmlformats.org/officeDocument/2006/relationships" id="273" r:id="Rfc57c986a1f74c28"/>
+    <p:sldId xmlns:r="http://schemas.openxmlformats.org/officeDocument/2006/relationships" id="274" r:id="R25528e12af1e45b7"/>
+    <p:sldId xmlns:r="http://schemas.openxmlformats.org/officeDocument/2006/relationships" id="275" r:id="R93de46bfc94e4d64"/>
+    <p:sldId xmlns:r="http://schemas.openxmlformats.org/officeDocument/2006/relationships" id="276" r:id="Rb3e9936b7a0843ba"/>
+    <p:sldId xmlns:r="http://schemas.openxmlformats.org/officeDocument/2006/relationships" id="277" r:id="R8f2358e7fafc4493"/>
+    <p:sldId xmlns:r="http://schemas.openxmlformats.org/officeDocument/2006/relationships" id="278" r:id="R28889b9a48254c5c"/>
+    <p:sldId xmlns:r="http://schemas.openxmlformats.org/officeDocument/2006/relationships" id="279" r:id="R7d19cb1fec594002"/>
+    <p:sldId xmlns:r="http://schemas.openxmlformats.org/officeDocument/2006/relationships" id="280" r:id="Re7122338afeb4627"/>
+    <p:sldId xmlns:r="http://schemas.openxmlformats.org/officeDocument/2006/relationships" id="281" r:id="R41d14dcd69474537"/>
   </p:sldIdLst>
   <p:sldSz cx="12192000" cy="6858000"/>
   <p:notesSz cx="6858000" cy="9144000"/>
@@ -535,6 +535,16 @@
               <a:t/>
             </a:r>
           </a:p>
+          <a:p xmlns:a="http://schemas.openxmlformats.org/drawingml/2006/main">
+            <a:r>
+              <a:t/>
+            </a:r>
+          </a:p>
+          <a:p xmlns:a="http://schemas.openxmlformats.org/drawingml/2006/main">
+            <a:r>
+              <a:t/>
+            </a:r>
+          </a:p>
         </p:txBody>
       </p:sp>
       <p:sp>
@@ -715,6 +725,16 @@
               <a:t/>
             </a:r>
           </a:p>
+          <a:p xmlns:a="http://schemas.openxmlformats.org/drawingml/2006/main">
+            <a:r>
+              <a:t/>
+            </a:r>
+          </a:p>
+          <a:p xmlns:a="http://schemas.openxmlformats.org/drawingml/2006/main">
+            <a:r>
+              <a:t/>
+            </a:r>
+          </a:p>
         </p:txBody>
       </p:sp>
       <p:sp>
@@ -990,6 +1010,16 @@
               <a:t/>
             </a:r>
           </a:p>
+          <a:p xmlns:a="http://schemas.openxmlformats.org/drawingml/2006/main">
+            <a:r>
+              <a:t/>
+            </a:r>
+          </a:p>
+          <a:p xmlns:a="http://schemas.openxmlformats.org/drawingml/2006/main">
+            <a:r>
+              <a:t/>
+            </a:r>
+          </a:p>
         </p:txBody>
       </p:sp>
       <p:sp>
@@ -1107,6 +1137,36 @@
           </a:p>
           <a:p xmlns:a="http://schemas.openxmlformats.org/drawingml/2006/main">
             <a:r>
+              <a:t>CU: Customs union</a:t>
+            </a:r>
+          </a:p>
+          <a:p xmlns:a="http://schemas.openxmlformats.org/drawingml/2006/main">
+            <a:r>
+              <a:t>RoW: Rest of the world</a:t>
+            </a:r>
+          </a:p>
+          <a:p xmlns:a="http://schemas.openxmlformats.org/drawingml/2006/main">
+            <a:r>
+              <a:t>GATT: General Agreement on Tariffs and Trade</a:t>
+            </a:r>
+          </a:p>
+          <a:p xmlns:a="http://schemas.openxmlformats.org/drawingml/2006/main">
+            <a:r>
+              <a:t>WTO: World Trade Organization</a:t>
+            </a:r>
+          </a:p>
+          <a:p xmlns:a="http://schemas.openxmlformats.org/drawingml/2006/main">
+            <a:r>
+              <a:t>MFN: Most-favoured-nation</a:t>
+            </a:r>
+          </a:p>
+          <a:p xmlns:a="http://schemas.openxmlformats.org/drawingml/2006/main">
+            <a:r>
+              <a:t/>
+            </a:r>
+          </a:p>
+          <a:p xmlns:a="http://schemas.openxmlformats.org/drawingml/2006/main">
+            <a:r>
               <a:t/>
             </a:r>
           </a:p>
@@ -1242,6 +1302,16 @@
           </a:p>
           <a:p xmlns:a="http://schemas.openxmlformats.org/drawingml/2006/main">
             <a:r>
+              <a:t>MFN: Most-favoured-nation</a:t>
+            </a:r>
+          </a:p>
+          <a:p xmlns:a="http://schemas.openxmlformats.org/drawingml/2006/main">
+            <a:r>
+              <a:t/>
+            </a:r>
+          </a:p>
+          <a:p xmlns:a="http://schemas.openxmlformats.org/drawingml/2006/main">
+            <a:r>
               <a:t/>
             </a:r>
           </a:p>
@@ -1377,6 +1447,21 @@
           </a:p>
           <a:p xmlns:a="http://schemas.openxmlformats.org/drawingml/2006/main">
             <a:r>
+              <a:t>CU: Customs union</a:t>
+            </a:r>
+          </a:p>
+          <a:p xmlns:a="http://schemas.openxmlformats.org/drawingml/2006/main">
+            <a:r>
+              <a:t>RoW: Rest of the world</a:t>
+            </a:r>
+          </a:p>
+          <a:p xmlns:a="http://schemas.openxmlformats.org/drawingml/2006/main">
+            <a:r>
+              <a:t/>
+            </a:r>
+          </a:p>
+          <a:p xmlns:a="http://schemas.openxmlformats.org/drawingml/2006/main">
+            <a:r>
               <a:t/>
             </a:r>
           </a:p>
@@ -1662,6 +1747,16 @@
           </a:p>
           <a:p xmlns:a="http://schemas.openxmlformats.org/drawingml/2006/main">
             <a:r>
+              <a:t>RoW: Rest of the world</a:t>
+            </a:r>
+          </a:p>
+          <a:p xmlns:a="http://schemas.openxmlformats.org/drawingml/2006/main">
+            <a:r>
+              <a:t/>
+            </a:r>
+          </a:p>
+          <a:p xmlns:a="http://schemas.openxmlformats.org/drawingml/2006/main">
+            <a:r>
               <a:t/>
             </a:r>
           </a:p>
@@ -2055,6 +2150,16 @@
               <a:t/>
             </a:r>
           </a:p>
+          <a:p xmlns:a="http://schemas.openxmlformats.org/drawingml/2006/main">
+            <a:r>
+              <a:t/>
+            </a:r>
+          </a:p>
+          <a:p xmlns:a="http://schemas.openxmlformats.org/drawingml/2006/main">
+            <a:r>
+              <a:t/>
+            </a:r>
+          </a:p>
         </p:txBody>
       </p:sp>
       <p:sp>
@@ -2682,6 +2787,16 @@
           </a:p>
           <a:p xmlns:a="http://schemas.openxmlformats.org/drawingml/2006/main">
             <a:r>
+              <a:t>RoW: Rest of the world</a:t>
+            </a:r>
+          </a:p>
+          <a:p xmlns:a="http://schemas.openxmlformats.org/drawingml/2006/main">
+            <a:r>
+              <a:t/>
+            </a:r>
+          </a:p>
+          <a:p xmlns:a="http://schemas.openxmlformats.org/drawingml/2006/main">
+            <a:r>
               <a:t/>
             </a:r>
           </a:p>
@@ -2907,6 +3022,16 @@
           </a:p>
           <a:p xmlns:a="http://schemas.openxmlformats.org/drawingml/2006/main">
             <a:r>
+              <a:t>RoW: Rest of the world</a:t>
+            </a:r>
+          </a:p>
+          <a:p xmlns:a="http://schemas.openxmlformats.org/drawingml/2006/main">
+            <a:r>
+              <a:t/>
+            </a:r>
+          </a:p>
+          <a:p xmlns:a="http://schemas.openxmlformats.org/drawingml/2006/main">
+            <a:r>
               <a:t/>
             </a:r>
           </a:p>
@@ -3035,6 +3160,16 @@
               <a:t/>
             </a:r>
           </a:p>
+          <a:p xmlns:a="http://schemas.openxmlformats.org/drawingml/2006/main">
+            <a:r>
+              <a:t/>
+            </a:r>
+          </a:p>
+          <a:p xmlns:a="http://schemas.openxmlformats.org/drawingml/2006/main">
+            <a:r>
+              <a:t/>
+            </a:r>
+          </a:p>
         </p:txBody>
       </p:sp>
       <p:sp>
@@ -3145,6 +3280,16 @@
               <a:t/>
             </a:r>
           </a:p>
+          <a:p xmlns:a="http://schemas.openxmlformats.org/drawingml/2006/main">
+            <a:r>
+              <a:t/>
+            </a:r>
+          </a:p>
+          <a:p xmlns:a="http://schemas.openxmlformats.org/drawingml/2006/main">
+            <a:r>
+              <a:t/>
+            </a:r>
+          </a:p>
         </p:txBody>
       </p:sp>
       <p:sp>
@@ -3250,6 +3395,16 @@
               <a:t/>
             </a:r>
           </a:p>
+          <a:p xmlns:a="http://schemas.openxmlformats.org/drawingml/2006/main">
+            <a:r>
+              <a:t/>
+            </a:r>
+          </a:p>
+          <a:p xmlns:a="http://schemas.openxmlformats.org/drawingml/2006/main">
+            <a:r>
+              <a:t/>
+            </a:r>
+          </a:p>
         </p:txBody>
       </p:sp>
       <p:sp>
@@ -3515,6 +3670,16 @@
               <a:t/>
             </a:r>
           </a:p>
+          <a:p xmlns:a="http://schemas.openxmlformats.org/drawingml/2006/main">
+            <a:r>
+              <a:t/>
+            </a:r>
+          </a:p>
+          <a:p xmlns:a="http://schemas.openxmlformats.org/drawingml/2006/main">
+            <a:r>
+              <a:t/>
+            </a:r>
+          </a:p>
         </p:txBody>
       </p:sp>
       <p:sp>
@@ -3837,6 +4002,16 @@
           </a:p>
           <a:p xmlns:a="http://schemas.openxmlformats.org/drawingml/2006/main">
             <a:r>
+              <a:t>RoW: Rest of the world</a:t>
+            </a:r>
+          </a:p>
+          <a:p xmlns:a="http://schemas.openxmlformats.org/drawingml/2006/main">
+            <a:r>
+              <a:t/>
+            </a:r>
+          </a:p>
+          <a:p xmlns:a="http://schemas.openxmlformats.org/drawingml/2006/main">
+            <a:r>
               <a:t/>
             </a:r>
           </a:p>
@@ -3992,6 +4167,16 @@
           </a:p>
           <a:p xmlns:a="http://schemas.openxmlformats.org/drawingml/2006/main">
             <a:r>
+              <a:t>CU: Customs union</a:t>
+            </a:r>
+          </a:p>
+          <a:p xmlns:a="http://schemas.openxmlformats.org/drawingml/2006/main">
+            <a:r>
+              <a:t/>
+            </a:r>
+          </a:p>
+          <a:p xmlns:a="http://schemas.openxmlformats.org/drawingml/2006/main">
+            <a:r>
               <a:t/>
             </a:r>
           </a:p>
@@ -4077,27 +4262,37 @@
           </a:p>
           <a:p xmlns:a="http://schemas.openxmlformats.org/drawingml/2006/main">
             <a:r>
-              <a:t>Empirical evidence</a:t>
-            </a:r>
-          </a:p>
-          <a:p xmlns:a="http://schemas.openxmlformats.org/drawingml/2006/main">
-            <a:r>
-              <a:t>Findings</a:t>
-            </a:r>
-          </a:p>
-          <a:p xmlns:a="http://schemas.openxmlformats.org/drawingml/2006/main">
-            <a:r>
-              <a:t/>
-            </a:r>
-          </a:p>
-          <a:p xmlns:a="http://schemas.openxmlformats.org/drawingml/2006/main">
-            <a:r>
-              <a:t>Trade creation exceeded trade diversion in Europe, but the gains were small (Baldwin and Venables, 1995).</a:t>
-            </a:r>
-          </a:p>
-          <a:p xmlns:a="http://schemas.openxmlformats.org/drawingml/2006/main">
-            <a:r>
-              <a:t/>
+              <a:t>What did the early studies find?</a:t>
+            </a:r>
+          </a:p>
+          <a:p xmlns:a="http://schemas.openxmlformats.org/drawingml/2006/main">
+            <a:r>
+              <a:t/>
+            </a:r>
+          </a:p>
+          <a:p xmlns:a="http://schemas.openxmlformats.org/drawingml/2006/main">
+            <a:r>
+              <a:t>Trade creation exceeded trade diversion in Europe, but the estimated gains were small.</a:t>
+            </a:r>
+          </a:p>
+          <a:p xmlns:a="http://schemas.openxmlformats.org/drawingml/2006/main">
+            <a:r>
+              <a:t/>
+            </a:r>
+          </a:p>
+          <a:p xmlns:a="http://schemas.openxmlformats.org/drawingml/2006/main">
+            <a:r>
+              <a:t>Baldwin and Venables (1995).</a:t>
+            </a:r>
+          </a:p>
+          <a:p xmlns:a="http://schemas.openxmlformats.org/drawingml/2006/main">
+            <a:r>
+              <a:t/>
+            </a:r>
+          </a:p>
+          <a:p xmlns:a="http://schemas.openxmlformats.org/drawingml/2006/main">
+            <a:r>
+              <a:t>Findings in context</a:t>
             </a:r>
           </a:p>
           <a:p xmlns:a="http://schemas.openxmlformats.org/drawingml/2006/main">
@@ -4138,6 +4333,16 @@
           <a:p xmlns:a="http://schemas.openxmlformats.org/drawingml/2006/main">
             <a:r>
               <a:t/>
+            </a:r>
+          </a:p>
+          <a:p xmlns:a="http://schemas.openxmlformats.org/drawingml/2006/main">
+            <a:r>
+              <a:t/>
+            </a:r>
+          </a:p>
+          <a:p xmlns:a="http://schemas.openxmlformats.org/drawingml/2006/main">
+            <a:r>
+              <a:t>RoW: Rest of the world</a:t>
             </a:r>
           </a:p>
           <a:p xmlns:a="http://schemas.openxmlformats.org/drawingml/2006/main">
@@ -4265,6 +4470,16 @@
               <a:t/>
             </a:r>
           </a:p>
+          <a:p xmlns:a="http://schemas.openxmlformats.org/drawingml/2006/main">
+            <a:r>
+              <a:t/>
+            </a:r>
+          </a:p>
+          <a:p xmlns:a="http://schemas.openxmlformats.org/drawingml/2006/main">
+            <a:r>
+              <a:t/>
+            </a:r>
+          </a:p>
         </p:txBody>
       </p:sp>
       <p:sp>
@@ -4402,6 +4617,16 @@
           </a:p>
           <a:p xmlns:a="http://schemas.openxmlformats.org/drawingml/2006/main">
             <a:r>
+              <a:t>EEC: European Economic Community</a:t>
+            </a:r>
+          </a:p>
+          <a:p xmlns:a="http://schemas.openxmlformats.org/drawingml/2006/main">
+            <a:r>
+              <a:t/>
+            </a:r>
+          </a:p>
+          <a:p xmlns:a="http://schemas.openxmlformats.org/drawingml/2006/main">
+            <a:r>
               <a:t/>
             </a:r>
           </a:p>
@@ -4550,6 +4775,16 @@
               <a:t/>
             </a:r>
           </a:p>
+          <a:p xmlns:a="http://schemas.openxmlformats.org/drawingml/2006/main">
+            <a:r>
+              <a:t/>
+            </a:r>
+          </a:p>
+          <a:p xmlns:a="http://schemas.openxmlformats.org/drawingml/2006/main">
+            <a:r>
+              <a:t/>
+            </a:r>
+          </a:p>
         </p:txBody>
       </p:sp>
       <p:sp>
@@ -4812,6 +5047,16 @@
           </a:p>
           <a:p xmlns:a="http://schemas.openxmlformats.org/drawingml/2006/main">
             <a:r>
+              <a:t/>
+            </a:r>
+          </a:p>
+          <a:p xmlns:a="http://schemas.openxmlformats.org/drawingml/2006/main">
+            <a:r>
+              <a:t/>
+            </a:r>
+          </a:p>
+          <a:p xmlns:a="http://schemas.openxmlformats.org/drawingml/2006/main">
+            <a:r>
               <a:t>https://commons.wikimedia.org/wiki/File:Customs_Unions_World.svg</a:t>
             </a:r>
           </a:p>
@@ -4935,6 +5180,16 @@
               <a:t/>
             </a:r>
           </a:p>
+          <a:p xmlns:a="http://schemas.openxmlformats.org/drawingml/2006/main">
+            <a:r>
+              <a:t/>
+            </a:r>
+          </a:p>
+          <a:p xmlns:a="http://schemas.openxmlformats.org/drawingml/2006/main">
+            <a:r>
+              <a:t/>
+            </a:r>
+          </a:p>
         </p:txBody>
       </p:sp>
       <p:sp>
@@ -5070,6 +5325,16 @@
               <a:t/>
             </a:r>
           </a:p>
+          <a:p xmlns:a="http://schemas.openxmlformats.org/drawingml/2006/main">
+            <a:r>
+              <a:t/>
+            </a:r>
+          </a:p>
+          <a:p xmlns:a="http://schemas.openxmlformats.org/drawingml/2006/main">
+            <a:r>
+              <a:t/>
+            </a:r>
+          </a:p>
         </p:txBody>
       </p:sp>
       <p:sp>
@@ -5235,6 +5500,16 @@
               <a:t/>
             </a:r>
           </a:p>
+          <a:p xmlns:a="http://schemas.openxmlformats.org/drawingml/2006/main">
+            <a:r>
+              <a:t/>
+            </a:r>
+          </a:p>
+          <a:p xmlns:a="http://schemas.openxmlformats.org/drawingml/2006/main">
+            <a:r>
+              <a:t/>
+            </a:r>
+          </a:p>
         </p:txBody>
       </p:sp>
       <p:sp>
@@ -5405,6 +5680,16 @@
               <a:t/>
             </a:r>
           </a:p>
+          <a:p xmlns:a="http://schemas.openxmlformats.org/drawingml/2006/main">
+            <a:r>
+              <a:t/>
+            </a:r>
+          </a:p>
+          <a:p xmlns:a="http://schemas.openxmlformats.org/drawingml/2006/main">
+            <a:r>
+              <a:t/>
+            </a:r>
+          </a:p>
         </p:txBody>
       </p:sp>
       <p:sp>
@@ -5563,6 +5848,16 @@
           <a:p xmlns:a="http://schemas.openxmlformats.org/drawingml/2006/main">
             <a:r>
               <a:t>Deriving Partner export supply from domestic supply and demand. Continuous horizontal guides align the autarky and free-trade prices across both panels. At the autarky price, exports are zero. At the free-trade price, the highlighted gap between supply and demand is exactly as wide as exports in the right panel. Export supply slopes upwards.</a:t>
+            </a:r>
+          </a:p>
+          <a:p xmlns:a="http://schemas.openxmlformats.org/drawingml/2006/main">
+            <a:r>
+              <a:t/>
+            </a:r>
+          </a:p>
+          <a:p xmlns:a="http://schemas.openxmlformats.org/drawingml/2006/main">
+            <a:r>
+              <a:t/>
             </a:r>
           </a:p>
           <a:p xmlns:a="http://schemas.openxmlformats.org/drawingml/2006/main">
@@ -5640,7 +5935,7 @@
   </p:cSld>
   <p:clrMap bg1="lt1" tx1="dk1" bg2="lt2" tx2="dk2" accent1="accent1" accent2="accent2" accent3="accent3" accent4="accent4" accent5="accent5" accent6="accent6" hlink="hlink" folHlink="folHlink"/>
   <p:sldLayoutIdLst>
-    <p:sldLayoutId xmlns:r="http://schemas.openxmlformats.org/officeDocument/2006/relationships" id="2147483649" r:id="R1c768df96d9a40b8"/>
+    <p:sldLayoutId xmlns:r="http://schemas.openxmlformats.org/officeDocument/2006/relationships" id="2147483649" r:id="R08167d3d2bd844b9"/>
   </p:sldLayoutIdLst>
   <p:txStyles>
     <p:titleStyle>
@@ -6188,7 +6483,7 @@
           <p:nvPr/>
         </p:nvPicPr>
         <p:blipFill>
-          <a:blip xmlns:r="http://schemas.openxmlformats.org/officeDocument/2006/relationships" xmlns:a="http://schemas.openxmlformats.org/drawingml/2006/main" r:embed="Rbeb1ac85b9054fbc"/>
+          <a:blip xmlns:r="http://schemas.openxmlformats.org/officeDocument/2006/relationships" xmlns:a="http://schemas.openxmlformats.org/drawingml/2006/main" r:embed="R0cb6c42f6ae449b9"/>
           <a:stretch xmlns:a="http://schemas.openxmlformats.org/drawingml/2006/main"/>
         </p:blipFill>
         <p:spPr>
@@ -6204,7 +6499,7 @@
     </p:spTree>
     <p:extLst>
       <p:ext uri="{BB962C8B-B14F-4D97-AF65-F5344CB8AC3E}">
-        <p14:creationId xmlns:p14="http://schemas.microsoft.com/office/powerpoint/2010/main" val="1720168713"/>
+        <p14:creationId xmlns:p14="http://schemas.microsoft.com/office/powerpoint/2010/main" val="2052902077"/>
       </p:ext>
     </p:extLst>
   </p:cSld>
@@ -6232,7 +6527,7 @@
           <p:nvPr/>
         </p:nvPicPr>
         <p:blipFill>
-          <a:blip xmlns:r="http://schemas.openxmlformats.org/officeDocument/2006/relationships" xmlns:a="http://schemas.openxmlformats.org/drawingml/2006/main" r:embed="R6bc6a9558eaf4edb"/>
+          <a:blip xmlns:r="http://schemas.openxmlformats.org/officeDocument/2006/relationships" xmlns:a="http://schemas.openxmlformats.org/drawingml/2006/main" r:embed="Rda78d6e6df26420c"/>
           <a:stretch xmlns:a="http://schemas.openxmlformats.org/drawingml/2006/main"/>
         </p:blipFill>
         <p:spPr>
@@ -6248,7 +6543,7 @@
     </p:spTree>
     <p:extLst>
       <p:ext uri="{BB962C8B-B14F-4D97-AF65-F5344CB8AC3E}">
-        <p14:creationId xmlns:p14="http://schemas.microsoft.com/office/powerpoint/2010/main" val="1819286800"/>
+        <p14:creationId xmlns:p14="http://schemas.microsoft.com/office/powerpoint/2010/main" val="1746304369"/>
       </p:ext>
     </p:extLst>
   </p:cSld>
@@ -6276,7 +6571,7 @@
           <p:nvPr/>
         </p:nvPicPr>
         <p:blipFill>
-          <a:blip xmlns:r="http://schemas.openxmlformats.org/officeDocument/2006/relationships" xmlns:a="http://schemas.openxmlformats.org/drawingml/2006/main" r:embed="Ra1b60da98a2240f2"/>
+          <a:blip xmlns:r="http://schemas.openxmlformats.org/officeDocument/2006/relationships" xmlns:a="http://schemas.openxmlformats.org/drawingml/2006/main" r:embed="R60473ae0c77b4e75"/>
           <a:stretch xmlns:a="http://schemas.openxmlformats.org/drawingml/2006/main"/>
         </p:blipFill>
         <p:spPr>
@@ -6292,7 +6587,7 @@
     </p:spTree>
     <p:extLst>
       <p:ext uri="{BB962C8B-B14F-4D97-AF65-F5344CB8AC3E}">
-        <p14:creationId xmlns:p14="http://schemas.microsoft.com/office/powerpoint/2010/main" val="2102044416"/>
+        <p14:creationId xmlns:p14="http://schemas.microsoft.com/office/powerpoint/2010/main" val="1604197532"/>
       </p:ext>
     </p:extLst>
   </p:cSld>
@@ -6320,7 +6615,7 @@
           <p:nvPr/>
         </p:nvPicPr>
         <p:blipFill>
-          <a:blip xmlns:r="http://schemas.openxmlformats.org/officeDocument/2006/relationships" xmlns:a="http://schemas.openxmlformats.org/drawingml/2006/main" r:embed="Rc512a8a420234aa3"/>
+          <a:blip xmlns:r="http://schemas.openxmlformats.org/officeDocument/2006/relationships" xmlns:a="http://schemas.openxmlformats.org/drawingml/2006/main" r:embed="Rbfc4c15f155a4811"/>
           <a:stretch xmlns:a="http://schemas.openxmlformats.org/drawingml/2006/main"/>
         </p:blipFill>
         <p:spPr>
@@ -6336,7 +6631,7 @@
     </p:spTree>
     <p:extLst>
       <p:ext uri="{BB962C8B-B14F-4D97-AF65-F5344CB8AC3E}">
-        <p14:creationId xmlns:p14="http://schemas.microsoft.com/office/powerpoint/2010/main" val="1347712130"/>
+        <p14:creationId xmlns:p14="http://schemas.microsoft.com/office/powerpoint/2010/main" val="915757569"/>
       </p:ext>
     </p:extLst>
   </p:cSld>
@@ -6364,7 +6659,7 @@
           <p:nvPr/>
         </p:nvPicPr>
         <p:blipFill>
-          <a:blip xmlns:r="http://schemas.openxmlformats.org/officeDocument/2006/relationships" xmlns:a="http://schemas.openxmlformats.org/drawingml/2006/main" r:embed="Ra50f1a16803c409a"/>
+          <a:blip xmlns:r="http://schemas.openxmlformats.org/officeDocument/2006/relationships" xmlns:a="http://schemas.openxmlformats.org/drawingml/2006/main" r:embed="R255b5c38856541af"/>
           <a:stretch xmlns:a="http://schemas.openxmlformats.org/drawingml/2006/main"/>
         </p:blipFill>
         <p:spPr>
@@ -6380,7 +6675,7 @@
     </p:spTree>
     <p:extLst>
       <p:ext uri="{BB962C8B-B14F-4D97-AF65-F5344CB8AC3E}">
-        <p14:creationId xmlns:p14="http://schemas.microsoft.com/office/powerpoint/2010/main" val="1474681589"/>
+        <p14:creationId xmlns:p14="http://schemas.microsoft.com/office/powerpoint/2010/main" val="985402534"/>
       </p:ext>
     </p:extLst>
   </p:cSld>
@@ -6408,7 +6703,7 @@
           <p:nvPr/>
         </p:nvPicPr>
         <p:blipFill>
-          <a:blip xmlns:r="http://schemas.openxmlformats.org/officeDocument/2006/relationships" xmlns:a="http://schemas.openxmlformats.org/drawingml/2006/main" r:embed="R83035f887c604508"/>
+          <a:blip xmlns:r="http://schemas.openxmlformats.org/officeDocument/2006/relationships" xmlns:a="http://schemas.openxmlformats.org/drawingml/2006/main" r:embed="R1ce33d0bd4d74ee4"/>
           <a:stretch xmlns:a="http://schemas.openxmlformats.org/drawingml/2006/main"/>
         </p:blipFill>
         <p:spPr>
@@ -6424,7 +6719,7 @@
     </p:spTree>
     <p:extLst>
       <p:ext uri="{BB962C8B-B14F-4D97-AF65-F5344CB8AC3E}">
-        <p14:creationId xmlns:p14="http://schemas.microsoft.com/office/powerpoint/2010/main" val="1267163543"/>
+        <p14:creationId xmlns:p14="http://schemas.microsoft.com/office/powerpoint/2010/main" val="892117105"/>
       </p:ext>
     </p:extLst>
   </p:cSld>
@@ -6452,7 +6747,7 @@
           <p:nvPr/>
         </p:nvPicPr>
         <p:blipFill>
-          <a:blip xmlns:r="http://schemas.openxmlformats.org/officeDocument/2006/relationships" xmlns:a="http://schemas.openxmlformats.org/drawingml/2006/main" r:embed="R20a6425c194f4549"/>
+          <a:blip xmlns:r="http://schemas.openxmlformats.org/officeDocument/2006/relationships" xmlns:a="http://schemas.openxmlformats.org/drawingml/2006/main" r:embed="R48ebf36a05b740fe"/>
           <a:stretch xmlns:a="http://schemas.openxmlformats.org/drawingml/2006/main"/>
         </p:blipFill>
         <p:spPr>
@@ -6468,7 +6763,7 @@
     </p:spTree>
     <p:extLst>
       <p:ext uri="{BB962C8B-B14F-4D97-AF65-F5344CB8AC3E}">
-        <p14:creationId xmlns:p14="http://schemas.microsoft.com/office/powerpoint/2010/main" val="21272890"/>
+        <p14:creationId xmlns:p14="http://schemas.microsoft.com/office/powerpoint/2010/main" val="827864445"/>
       </p:ext>
     </p:extLst>
   </p:cSld>
@@ -6496,7 +6791,7 @@
           <p:nvPr/>
         </p:nvPicPr>
         <p:blipFill>
-          <a:blip xmlns:r="http://schemas.openxmlformats.org/officeDocument/2006/relationships" xmlns:a="http://schemas.openxmlformats.org/drawingml/2006/main" r:embed="R147778397e974468"/>
+          <a:blip xmlns:r="http://schemas.openxmlformats.org/officeDocument/2006/relationships" xmlns:a="http://schemas.openxmlformats.org/drawingml/2006/main" r:embed="Rd18fc5fec89c4713"/>
           <a:stretch xmlns:a="http://schemas.openxmlformats.org/drawingml/2006/main"/>
         </p:blipFill>
         <p:spPr>
@@ -6512,7 +6807,7 @@
     </p:spTree>
     <p:extLst>
       <p:ext uri="{BB962C8B-B14F-4D97-AF65-F5344CB8AC3E}">
-        <p14:creationId xmlns:p14="http://schemas.microsoft.com/office/powerpoint/2010/main" val="1069933534"/>
+        <p14:creationId xmlns:p14="http://schemas.microsoft.com/office/powerpoint/2010/main" val="1191263455"/>
       </p:ext>
     </p:extLst>
   </p:cSld>
@@ -6540,7 +6835,7 @@
           <p:nvPr/>
         </p:nvPicPr>
         <p:blipFill>
-          <a:blip xmlns:r="http://schemas.openxmlformats.org/officeDocument/2006/relationships" xmlns:a="http://schemas.openxmlformats.org/drawingml/2006/main" r:embed="Ra139193843d645c4"/>
+          <a:blip xmlns:r="http://schemas.openxmlformats.org/officeDocument/2006/relationships" xmlns:a="http://schemas.openxmlformats.org/drawingml/2006/main" r:embed="Rd396c22a107c44d8"/>
           <a:stretch xmlns:a="http://schemas.openxmlformats.org/drawingml/2006/main"/>
         </p:blipFill>
         <p:spPr>
@@ -6556,7 +6851,7 @@
     </p:spTree>
     <p:extLst>
       <p:ext uri="{BB962C8B-B14F-4D97-AF65-F5344CB8AC3E}">
-        <p14:creationId xmlns:p14="http://schemas.microsoft.com/office/powerpoint/2010/main" val="465832018"/>
+        <p14:creationId xmlns:p14="http://schemas.microsoft.com/office/powerpoint/2010/main" val="1920739242"/>
       </p:ext>
     </p:extLst>
   </p:cSld>
@@ -6584,7 +6879,7 @@
           <p:nvPr/>
         </p:nvPicPr>
         <p:blipFill>
-          <a:blip xmlns:r="http://schemas.openxmlformats.org/officeDocument/2006/relationships" xmlns:a="http://schemas.openxmlformats.org/drawingml/2006/main" r:embed="R023024f4173148b7"/>
+          <a:blip xmlns:r="http://schemas.openxmlformats.org/officeDocument/2006/relationships" xmlns:a="http://schemas.openxmlformats.org/drawingml/2006/main" r:embed="R1096370acd604ff9"/>
           <a:stretch xmlns:a="http://schemas.openxmlformats.org/drawingml/2006/main"/>
         </p:blipFill>
         <p:spPr>
@@ -6600,7 +6895,7 @@
     </p:spTree>
     <p:extLst>
       <p:ext uri="{BB962C8B-B14F-4D97-AF65-F5344CB8AC3E}">
-        <p14:creationId xmlns:p14="http://schemas.microsoft.com/office/powerpoint/2010/main" val="1670575758"/>
+        <p14:creationId xmlns:p14="http://schemas.microsoft.com/office/powerpoint/2010/main" val="379393863"/>
       </p:ext>
     </p:extLst>
   </p:cSld>
@@ -6628,7 +6923,7 @@
           <p:nvPr/>
         </p:nvPicPr>
         <p:blipFill>
-          <a:blip xmlns:r="http://schemas.openxmlformats.org/officeDocument/2006/relationships" xmlns:a="http://schemas.openxmlformats.org/drawingml/2006/main" r:embed="R1f8e943f2d7e47ef"/>
+          <a:blip xmlns:r="http://schemas.openxmlformats.org/officeDocument/2006/relationships" xmlns:a="http://schemas.openxmlformats.org/drawingml/2006/main" r:embed="Rfed7550661ca4329"/>
           <a:stretch xmlns:a="http://schemas.openxmlformats.org/drawingml/2006/main"/>
         </p:blipFill>
         <p:spPr>
@@ -6644,7 +6939,7 @@
     </p:spTree>
     <p:extLst>
       <p:ext uri="{BB962C8B-B14F-4D97-AF65-F5344CB8AC3E}">
-        <p14:creationId xmlns:p14="http://schemas.microsoft.com/office/powerpoint/2010/main" val="161423331"/>
+        <p14:creationId xmlns:p14="http://schemas.microsoft.com/office/powerpoint/2010/main" val="1653779724"/>
       </p:ext>
     </p:extLst>
   </p:cSld>
@@ -6672,7 +6967,7 @@
           <p:nvPr/>
         </p:nvPicPr>
         <p:blipFill>
-          <a:blip xmlns:r="http://schemas.openxmlformats.org/officeDocument/2006/relationships" xmlns:a="http://schemas.openxmlformats.org/drawingml/2006/main" r:embed="Re8e87db94439408c"/>
+          <a:blip xmlns:r="http://schemas.openxmlformats.org/officeDocument/2006/relationships" xmlns:a="http://schemas.openxmlformats.org/drawingml/2006/main" r:embed="R85da0c106ef44603"/>
           <a:stretch xmlns:a="http://schemas.openxmlformats.org/drawingml/2006/main"/>
         </p:blipFill>
         <p:spPr>
@@ -6688,7 +6983,7 @@
     </p:spTree>
     <p:extLst>
       <p:ext uri="{BB962C8B-B14F-4D97-AF65-F5344CB8AC3E}">
-        <p14:creationId xmlns:p14="http://schemas.microsoft.com/office/powerpoint/2010/main" val="2082775280"/>
+        <p14:creationId xmlns:p14="http://schemas.microsoft.com/office/powerpoint/2010/main" val="1949270001"/>
       </p:ext>
     </p:extLst>
   </p:cSld>
@@ -6716,7 +7011,7 @@
           <p:nvPr/>
         </p:nvPicPr>
         <p:blipFill>
-          <a:blip xmlns:r="http://schemas.openxmlformats.org/officeDocument/2006/relationships" xmlns:a="http://schemas.openxmlformats.org/drawingml/2006/main" r:embed="R6ff66f04cdfa41a9"/>
+          <a:blip xmlns:r="http://schemas.openxmlformats.org/officeDocument/2006/relationships" xmlns:a="http://schemas.openxmlformats.org/drawingml/2006/main" r:embed="Re895245885cd48da"/>
           <a:stretch xmlns:a="http://schemas.openxmlformats.org/drawingml/2006/main"/>
         </p:blipFill>
         <p:spPr>
@@ -6732,7 +7027,7 @@
     </p:spTree>
     <p:extLst>
       <p:ext uri="{BB962C8B-B14F-4D97-AF65-F5344CB8AC3E}">
-        <p14:creationId xmlns:p14="http://schemas.microsoft.com/office/powerpoint/2010/main" val="602167187"/>
+        <p14:creationId xmlns:p14="http://schemas.microsoft.com/office/powerpoint/2010/main" val="459094494"/>
       </p:ext>
     </p:extLst>
   </p:cSld>
@@ -6760,7 +7055,7 @@
           <p:nvPr/>
         </p:nvPicPr>
         <p:blipFill>
-          <a:blip xmlns:r="http://schemas.openxmlformats.org/officeDocument/2006/relationships" xmlns:a="http://schemas.openxmlformats.org/drawingml/2006/main" r:embed="R7b379c17d8364d6a"/>
+          <a:blip xmlns:r="http://schemas.openxmlformats.org/officeDocument/2006/relationships" xmlns:a="http://schemas.openxmlformats.org/drawingml/2006/main" r:embed="Raa8533a4564c483e"/>
           <a:stretch xmlns:a="http://schemas.openxmlformats.org/drawingml/2006/main"/>
         </p:blipFill>
         <p:spPr>
@@ -6776,7 +7071,7 @@
     </p:spTree>
     <p:extLst>
       <p:ext uri="{BB962C8B-B14F-4D97-AF65-F5344CB8AC3E}">
-        <p14:creationId xmlns:p14="http://schemas.microsoft.com/office/powerpoint/2010/main" val="678727683"/>
+        <p14:creationId xmlns:p14="http://schemas.microsoft.com/office/powerpoint/2010/main" val="440546758"/>
       </p:ext>
     </p:extLst>
   </p:cSld>
@@ -6804,7 +7099,7 @@
           <p:nvPr/>
         </p:nvPicPr>
         <p:blipFill>
-          <a:blip xmlns:r="http://schemas.openxmlformats.org/officeDocument/2006/relationships" xmlns:a="http://schemas.openxmlformats.org/drawingml/2006/main" r:embed="Recb6344e4adc4b58"/>
+          <a:blip xmlns:r="http://schemas.openxmlformats.org/officeDocument/2006/relationships" xmlns:a="http://schemas.openxmlformats.org/drawingml/2006/main" r:embed="Rd337f6b1e950444f"/>
           <a:stretch xmlns:a="http://schemas.openxmlformats.org/drawingml/2006/main"/>
         </p:blipFill>
         <p:spPr>
@@ -6820,7 +7115,7 @@
     </p:spTree>
     <p:extLst>
       <p:ext uri="{BB962C8B-B14F-4D97-AF65-F5344CB8AC3E}">
-        <p14:creationId xmlns:p14="http://schemas.microsoft.com/office/powerpoint/2010/main" val="1248519043"/>
+        <p14:creationId xmlns:p14="http://schemas.microsoft.com/office/powerpoint/2010/main" val="1064643196"/>
       </p:ext>
     </p:extLst>
   </p:cSld>
@@ -6848,7 +7143,7 @@
           <p:nvPr/>
         </p:nvPicPr>
         <p:blipFill>
-          <a:blip xmlns:r="http://schemas.openxmlformats.org/officeDocument/2006/relationships" xmlns:a="http://schemas.openxmlformats.org/drawingml/2006/main" r:embed="R6e7ebb5ecec84462"/>
+          <a:blip xmlns:r="http://schemas.openxmlformats.org/officeDocument/2006/relationships" xmlns:a="http://schemas.openxmlformats.org/drawingml/2006/main" r:embed="R54bbc929ce544dda"/>
           <a:stretch xmlns:a="http://schemas.openxmlformats.org/drawingml/2006/main"/>
         </p:blipFill>
         <p:spPr>
@@ -6864,7 +7159,7 @@
     </p:spTree>
     <p:extLst>
       <p:ext uri="{BB962C8B-B14F-4D97-AF65-F5344CB8AC3E}">
-        <p14:creationId xmlns:p14="http://schemas.microsoft.com/office/powerpoint/2010/main" val="380286185"/>
+        <p14:creationId xmlns:p14="http://schemas.microsoft.com/office/powerpoint/2010/main" val="1807104156"/>
       </p:ext>
     </p:extLst>
   </p:cSld>
@@ -6892,7 +7187,7 @@
           <p:nvPr/>
         </p:nvPicPr>
         <p:blipFill>
-          <a:blip xmlns:r="http://schemas.openxmlformats.org/officeDocument/2006/relationships" xmlns:a="http://schemas.openxmlformats.org/drawingml/2006/main" r:embed="R678847ec28624464"/>
+          <a:blip xmlns:r="http://schemas.openxmlformats.org/officeDocument/2006/relationships" xmlns:a="http://schemas.openxmlformats.org/drawingml/2006/main" r:embed="Rbb0b81689b624ef7"/>
           <a:stretch xmlns:a="http://schemas.openxmlformats.org/drawingml/2006/main"/>
         </p:blipFill>
         <p:spPr>
@@ -6908,7 +7203,7 @@
     </p:spTree>
     <p:extLst>
       <p:ext uri="{BB962C8B-B14F-4D97-AF65-F5344CB8AC3E}">
-        <p14:creationId xmlns:p14="http://schemas.microsoft.com/office/powerpoint/2010/main" val="639441909"/>
+        <p14:creationId xmlns:p14="http://schemas.microsoft.com/office/powerpoint/2010/main" val="1808353917"/>
       </p:ext>
     </p:extLst>
   </p:cSld>
@@ -6936,7 +7231,7 @@
           <p:nvPr/>
         </p:nvPicPr>
         <p:blipFill>
-          <a:blip xmlns:r="http://schemas.openxmlformats.org/officeDocument/2006/relationships" xmlns:a="http://schemas.openxmlformats.org/drawingml/2006/main" r:embed="R653773e800764e23"/>
+          <a:blip xmlns:r="http://schemas.openxmlformats.org/officeDocument/2006/relationships" xmlns:a="http://schemas.openxmlformats.org/drawingml/2006/main" r:embed="R9c32ad22582c4296"/>
           <a:stretch xmlns:a="http://schemas.openxmlformats.org/drawingml/2006/main"/>
         </p:blipFill>
         <p:spPr>
@@ -6952,7 +7247,7 @@
     </p:spTree>
     <p:extLst>
       <p:ext uri="{BB962C8B-B14F-4D97-AF65-F5344CB8AC3E}">
-        <p14:creationId xmlns:p14="http://schemas.microsoft.com/office/powerpoint/2010/main" val="1033286425"/>
+        <p14:creationId xmlns:p14="http://schemas.microsoft.com/office/powerpoint/2010/main" val="605416776"/>
       </p:ext>
     </p:extLst>
   </p:cSld>
@@ -6980,7 +7275,7 @@
           <p:nvPr/>
         </p:nvPicPr>
         <p:blipFill>
-          <a:blip xmlns:r="http://schemas.openxmlformats.org/officeDocument/2006/relationships" xmlns:a="http://schemas.openxmlformats.org/drawingml/2006/main" r:embed="R998dfca568734ce7"/>
+          <a:blip xmlns:r="http://schemas.openxmlformats.org/officeDocument/2006/relationships" xmlns:a="http://schemas.openxmlformats.org/drawingml/2006/main" r:embed="R913d291d67f74880"/>
           <a:stretch xmlns:a="http://schemas.openxmlformats.org/drawingml/2006/main"/>
         </p:blipFill>
         <p:spPr>
@@ -6996,7 +7291,7 @@
     </p:spTree>
     <p:extLst>
       <p:ext uri="{BB962C8B-B14F-4D97-AF65-F5344CB8AC3E}">
-        <p14:creationId xmlns:p14="http://schemas.microsoft.com/office/powerpoint/2010/main" val="1179147450"/>
+        <p14:creationId xmlns:p14="http://schemas.microsoft.com/office/powerpoint/2010/main" val="1981236338"/>
       </p:ext>
     </p:extLst>
   </p:cSld>
@@ -7024,7 +7319,7 @@
           <p:nvPr/>
         </p:nvPicPr>
         <p:blipFill>
-          <a:blip xmlns:r="http://schemas.openxmlformats.org/officeDocument/2006/relationships" xmlns:a="http://schemas.openxmlformats.org/drawingml/2006/main" r:embed="R65370a4457294209"/>
+          <a:blip xmlns:r="http://schemas.openxmlformats.org/officeDocument/2006/relationships" xmlns:a="http://schemas.openxmlformats.org/drawingml/2006/main" r:embed="R200aae3b90474119"/>
           <a:stretch xmlns:a="http://schemas.openxmlformats.org/drawingml/2006/main"/>
         </p:blipFill>
         <p:spPr>
@@ -7040,7 +7335,7 @@
     </p:spTree>
     <p:extLst>
       <p:ext uri="{BB962C8B-B14F-4D97-AF65-F5344CB8AC3E}">
-        <p14:creationId xmlns:p14="http://schemas.microsoft.com/office/powerpoint/2010/main" val="1609982089"/>
+        <p14:creationId xmlns:p14="http://schemas.microsoft.com/office/powerpoint/2010/main" val="624338774"/>
       </p:ext>
     </p:extLst>
   </p:cSld>
@@ -7068,7 +7363,7 @@
           <p:nvPr/>
         </p:nvPicPr>
         <p:blipFill>
-          <a:blip xmlns:r="http://schemas.openxmlformats.org/officeDocument/2006/relationships" xmlns:a="http://schemas.openxmlformats.org/drawingml/2006/main" r:embed="R3c918a188e364ca6"/>
+          <a:blip xmlns:r="http://schemas.openxmlformats.org/officeDocument/2006/relationships" xmlns:a="http://schemas.openxmlformats.org/drawingml/2006/main" r:embed="R8e35575e34f349ce"/>
           <a:stretch xmlns:a="http://schemas.openxmlformats.org/drawingml/2006/main"/>
         </p:blipFill>
         <p:spPr>
@@ -7084,7 +7379,7 @@
     </p:spTree>
     <p:extLst>
       <p:ext uri="{BB962C8B-B14F-4D97-AF65-F5344CB8AC3E}">
-        <p14:creationId xmlns:p14="http://schemas.microsoft.com/office/powerpoint/2010/main" val="493324925"/>
+        <p14:creationId xmlns:p14="http://schemas.microsoft.com/office/powerpoint/2010/main" val="1735911788"/>
       </p:ext>
     </p:extLst>
   </p:cSld>
@@ -7112,7 +7407,7 @@
           <p:nvPr/>
         </p:nvPicPr>
         <p:blipFill>
-          <a:blip xmlns:r="http://schemas.openxmlformats.org/officeDocument/2006/relationships" xmlns:a="http://schemas.openxmlformats.org/drawingml/2006/main" r:embed="Rdd229a337298422b"/>
+          <a:blip xmlns:r="http://schemas.openxmlformats.org/officeDocument/2006/relationships" xmlns:a="http://schemas.openxmlformats.org/drawingml/2006/main" r:embed="R2d9f055fb42a4a29"/>
           <a:stretch xmlns:a="http://schemas.openxmlformats.org/drawingml/2006/main"/>
         </p:blipFill>
         <p:spPr>
@@ -7128,7 +7423,7 @@
     </p:spTree>
     <p:extLst>
       <p:ext uri="{BB962C8B-B14F-4D97-AF65-F5344CB8AC3E}">
-        <p14:creationId xmlns:p14="http://schemas.microsoft.com/office/powerpoint/2010/main" val="1426920238"/>
+        <p14:creationId xmlns:p14="http://schemas.microsoft.com/office/powerpoint/2010/main" val="187971730"/>
       </p:ext>
     </p:extLst>
   </p:cSld>
@@ -7156,7 +7451,7 @@
           <p:nvPr/>
         </p:nvPicPr>
         <p:blipFill>
-          <a:blip xmlns:r="http://schemas.openxmlformats.org/officeDocument/2006/relationships" xmlns:a="http://schemas.openxmlformats.org/drawingml/2006/main" r:embed="Ra8f116b3889048d6"/>
+          <a:blip xmlns:r="http://schemas.openxmlformats.org/officeDocument/2006/relationships" xmlns:a="http://schemas.openxmlformats.org/drawingml/2006/main" r:embed="Ra308f8f342bc476d"/>
           <a:stretch xmlns:a="http://schemas.openxmlformats.org/drawingml/2006/main"/>
         </p:blipFill>
         <p:spPr>
@@ -7172,7 +7467,7 @@
     </p:spTree>
     <p:extLst>
       <p:ext uri="{BB962C8B-B14F-4D97-AF65-F5344CB8AC3E}">
-        <p14:creationId xmlns:p14="http://schemas.microsoft.com/office/powerpoint/2010/main" val="1032536299"/>
+        <p14:creationId xmlns:p14="http://schemas.microsoft.com/office/powerpoint/2010/main" val="1157871953"/>
       </p:ext>
     </p:extLst>
   </p:cSld>
@@ -7200,7 +7495,7 @@
           <p:nvPr/>
         </p:nvPicPr>
         <p:blipFill>
-          <a:blip xmlns:r="http://schemas.openxmlformats.org/officeDocument/2006/relationships" xmlns:a="http://schemas.openxmlformats.org/drawingml/2006/main" r:embed="R94359ad751974771"/>
+          <a:blip xmlns:r="http://schemas.openxmlformats.org/officeDocument/2006/relationships" xmlns:a="http://schemas.openxmlformats.org/drawingml/2006/main" r:embed="R69b3fc8c8bd94da9"/>
           <a:stretch xmlns:a="http://schemas.openxmlformats.org/drawingml/2006/main"/>
         </p:blipFill>
         <p:spPr>
@@ -7216,7 +7511,7 @@
     </p:spTree>
     <p:extLst>
       <p:ext uri="{BB962C8B-B14F-4D97-AF65-F5344CB8AC3E}">
-        <p14:creationId xmlns:p14="http://schemas.microsoft.com/office/powerpoint/2010/main" val="811616433"/>
+        <p14:creationId xmlns:p14="http://schemas.microsoft.com/office/powerpoint/2010/main" val="1853835839"/>
       </p:ext>
     </p:extLst>
   </p:cSld>
@@ -7244,7 +7539,7 @@
           <p:nvPr/>
         </p:nvPicPr>
         <p:blipFill>
-          <a:blip xmlns:r="http://schemas.openxmlformats.org/officeDocument/2006/relationships" xmlns:a="http://schemas.openxmlformats.org/drawingml/2006/main" r:embed="R2181468915fa47c0"/>
+          <a:blip xmlns:r="http://schemas.openxmlformats.org/officeDocument/2006/relationships" xmlns:a="http://schemas.openxmlformats.org/drawingml/2006/main" r:embed="Redc182f264314ce5"/>
           <a:stretch xmlns:a="http://schemas.openxmlformats.org/drawingml/2006/main"/>
         </p:blipFill>
         <p:spPr>
@@ -7260,7 +7555,7 @@
     </p:spTree>
     <p:extLst>
       <p:ext uri="{BB962C8B-B14F-4D97-AF65-F5344CB8AC3E}">
-        <p14:creationId xmlns:p14="http://schemas.microsoft.com/office/powerpoint/2010/main" val="1968602608"/>
+        <p14:creationId xmlns:p14="http://schemas.microsoft.com/office/powerpoint/2010/main" val="700903429"/>
       </p:ext>
     </p:extLst>
   </p:cSld>
@@ -7288,7 +7583,7 @@
           <p:nvPr/>
         </p:nvPicPr>
         <p:blipFill>
-          <a:blip xmlns:r="http://schemas.openxmlformats.org/officeDocument/2006/relationships" xmlns:a="http://schemas.openxmlformats.org/drawingml/2006/main" r:embed="R19aebbaf4d914af6"/>
+          <a:blip xmlns:r="http://schemas.openxmlformats.org/officeDocument/2006/relationships" xmlns:a="http://schemas.openxmlformats.org/drawingml/2006/main" r:embed="R1fe37e31399345c8"/>
           <a:stretch xmlns:a="http://schemas.openxmlformats.org/drawingml/2006/main"/>
         </p:blipFill>
         <p:spPr>
@@ -7304,7 +7599,7 @@
     </p:spTree>
     <p:extLst>
       <p:ext uri="{BB962C8B-B14F-4D97-AF65-F5344CB8AC3E}">
-        <p14:creationId xmlns:p14="http://schemas.microsoft.com/office/powerpoint/2010/main" val="294376873"/>
+        <p14:creationId xmlns:p14="http://schemas.microsoft.com/office/powerpoint/2010/main" val="2032302460"/>
       </p:ext>
     </p:extLst>
   </p:cSld>

</xml_diff>

<commit_message>
Refresh customs-union membership and current status
</commit_message>
<xml_diff>
--- a/teaching/macro-applications/downloads/lecture_2.pptx
+++ b/teaching/macro-applications/downloads/lecture_2.pptx
@@ -2,38 +2,38 @@
 <file path=ppt/presentation.xml><?xml version="1.0" encoding="utf-8"?>
 <p:presentation xmlns:p="http://schemas.openxmlformats.org/presentationml/2006/main">
   <p:sldMasterIdLst>
-    <p:sldMasterId xmlns:r="http://schemas.openxmlformats.org/officeDocument/2006/relationships" id="2147483648" r:id="Re48a85af298d4d2a"/>
+    <p:sldMasterId xmlns:r="http://schemas.openxmlformats.org/officeDocument/2006/relationships" id="2147483648" r:id="R8e95411e8c8946be"/>
   </p:sldMasterIdLst>
   <p:notesMasterIdLst>
-    <p:notesMasterId xmlns:r="http://schemas.openxmlformats.org/officeDocument/2006/relationships" r:id="Rc0c15c0c06c84900"/>
+    <p:notesMasterId xmlns:r="http://schemas.openxmlformats.org/officeDocument/2006/relationships" r:id="R83259020f2314950"/>
   </p:notesMasterIdLst>
   <p:sldIdLst>
-    <p:sldId xmlns:r="http://schemas.openxmlformats.org/officeDocument/2006/relationships" id="256" r:id="R4db49d6fca9346ef"/>
-    <p:sldId xmlns:r="http://schemas.openxmlformats.org/officeDocument/2006/relationships" id="257" r:id="Re67f627f0c9e47ba"/>
-    <p:sldId xmlns:r="http://schemas.openxmlformats.org/officeDocument/2006/relationships" id="258" r:id="R9b75f86c2f3e45ea"/>
-    <p:sldId xmlns:r="http://schemas.openxmlformats.org/officeDocument/2006/relationships" id="259" r:id="R412fc51bdaf941d8"/>
-    <p:sldId xmlns:r="http://schemas.openxmlformats.org/officeDocument/2006/relationships" id="260" r:id="R6a608acd17af4c58"/>
-    <p:sldId xmlns:r="http://schemas.openxmlformats.org/officeDocument/2006/relationships" id="261" r:id="Rafa03f3c18ad4e05"/>
-    <p:sldId xmlns:r="http://schemas.openxmlformats.org/officeDocument/2006/relationships" id="262" r:id="R57e72d556e734f79"/>
-    <p:sldId xmlns:r="http://schemas.openxmlformats.org/officeDocument/2006/relationships" id="263" r:id="R3453f64f3f254491"/>
-    <p:sldId xmlns:r="http://schemas.openxmlformats.org/officeDocument/2006/relationships" id="264" r:id="R4d0f6cc0538d45fa"/>
-    <p:sldId xmlns:r="http://schemas.openxmlformats.org/officeDocument/2006/relationships" id="265" r:id="R5df99b1a126c492d"/>
-    <p:sldId xmlns:r="http://schemas.openxmlformats.org/officeDocument/2006/relationships" id="266" r:id="R1f9dfadadff04f3f"/>
-    <p:sldId xmlns:r="http://schemas.openxmlformats.org/officeDocument/2006/relationships" id="267" r:id="R4bf47a9baa884cd5"/>
-    <p:sldId xmlns:r="http://schemas.openxmlformats.org/officeDocument/2006/relationships" id="268" r:id="R56b382d6c9a6466c"/>
-    <p:sldId xmlns:r="http://schemas.openxmlformats.org/officeDocument/2006/relationships" id="269" r:id="R9d9f04b366b44ce1"/>
-    <p:sldId xmlns:r="http://schemas.openxmlformats.org/officeDocument/2006/relationships" id="270" r:id="Rf832e2377eff4c82"/>
-    <p:sldId xmlns:r="http://schemas.openxmlformats.org/officeDocument/2006/relationships" id="271" r:id="Rcd3bc5877a0045a4"/>
-    <p:sldId xmlns:r="http://schemas.openxmlformats.org/officeDocument/2006/relationships" id="272" r:id="R1d243698a0a34e1b"/>
-    <p:sldId xmlns:r="http://schemas.openxmlformats.org/officeDocument/2006/relationships" id="273" r:id="Rfc57c986a1f74c28"/>
-    <p:sldId xmlns:r="http://schemas.openxmlformats.org/officeDocument/2006/relationships" id="274" r:id="R25528e12af1e45b7"/>
-    <p:sldId xmlns:r="http://schemas.openxmlformats.org/officeDocument/2006/relationships" id="275" r:id="R93de46bfc94e4d64"/>
-    <p:sldId xmlns:r="http://schemas.openxmlformats.org/officeDocument/2006/relationships" id="276" r:id="Rb3e9936b7a0843ba"/>
-    <p:sldId xmlns:r="http://schemas.openxmlformats.org/officeDocument/2006/relationships" id="277" r:id="R8f2358e7fafc4493"/>
-    <p:sldId xmlns:r="http://schemas.openxmlformats.org/officeDocument/2006/relationships" id="278" r:id="R28889b9a48254c5c"/>
-    <p:sldId xmlns:r="http://schemas.openxmlformats.org/officeDocument/2006/relationships" id="279" r:id="R7d19cb1fec594002"/>
-    <p:sldId xmlns:r="http://schemas.openxmlformats.org/officeDocument/2006/relationships" id="280" r:id="Re7122338afeb4627"/>
-    <p:sldId xmlns:r="http://schemas.openxmlformats.org/officeDocument/2006/relationships" id="281" r:id="R41d14dcd69474537"/>
+    <p:sldId xmlns:r="http://schemas.openxmlformats.org/officeDocument/2006/relationships" id="256" r:id="R6a6a4b0d9e384c56"/>
+    <p:sldId xmlns:r="http://schemas.openxmlformats.org/officeDocument/2006/relationships" id="257" r:id="R13576ef886dc4ffc"/>
+    <p:sldId xmlns:r="http://schemas.openxmlformats.org/officeDocument/2006/relationships" id="258" r:id="R973a93a991dc4cb4"/>
+    <p:sldId xmlns:r="http://schemas.openxmlformats.org/officeDocument/2006/relationships" id="259" r:id="R978800d8979245ff"/>
+    <p:sldId xmlns:r="http://schemas.openxmlformats.org/officeDocument/2006/relationships" id="260" r:id="Rf39b7c181a254e68"/>
+    <p:sldId xmlns:r="http://schemas.openxmlformats.org/officeDocument/2006/relationships" id="261" r:id="Rc89a31ca18ca427b"/>
+    <p:sldId xmlns:r="http://schemas.openxmlformats.org/officeDocument/2006/relationships" id="262" r:id="Raabadbfefa8243dc"/>
+    <p:sldId xmlns:r="http://schemas.openxmlformats.org/officeDocument/2006/relationships" id="263" r:id="R4f6888ddf81842a4"/>
+    <p:sldId xmlns:r="http://schemas.openxmlformats.org/officeDocument/2006/relationships" id="264" r:id="R5b2bf34dd81d43c7"/>
+    <p:sldId xmlns:r="http://schemas.openxmlformats.org/officeDocument/2006/relationships" id="265" r:id="R01d61b30340841ec"/>
+    <p:sldId xmlns:r="http://schemas.openxmlformats.org/officeDocument/2006/relationships" id="266" r:id="Rf7af2b244a864936"/>
+    <p:sldId xmlns:r="http://schemas.openxmlformats.org/officeDocument/2006/relationships" id="267" r:id="R5f204b6078fb478b"/>
+    <p:sldId xmlns:r="http://schemas.openxmlformats.org/officeDocument/2006/relationships" id="268" r:id="Re25c0ac2fa1b4e04"/>
+    <p:sldId xmlns:r="http://schemas.openxmlformats.org/officeDocument/2006/relationships" id="269" r:id="R0645fa70f07845e6"/>
+    <p:sldId xmlns:r="http://schemas.openxmlformats.org/officeDocument/2006/relationships" id="270" r:id="R962f614f1b6b4ba2"/>
+    <p:sldId xmlns:r="http://schemas.openxmlformats.org/officeDocument/2006/relationships" id="271" r:id="R722defbb311e4021"/>
+    <p:sldId xmlns:r="http://schemas.openxmlformats.org/officeDocument/2006/relationships" id="272" r:id="R1362a3cb7cce4996"/>
+    <p:sldId xmlns:r="http://schemas.openxmlformats.org/officeDocument/2006/relationships" id="273" r:id="R0c9def19cbcc412d"/>
+    <p:sldId xmlns:r="http://schemas.openxmlformats.org/officeDocument/2006/relationships" id="274" r:id="R40361c60d8d846ba"/>
+    <p:sldId xmlns:r="http://schemas.openxmlformats.org/officeDocument/2006/relationships" id="275" r:id="Ra0cc7b1eb6ce4263"/>
+    <p:sldId xmlns:r="http://schemas.openxmlformats.org/officeDocument/2006/relationships" id="276" r:id="R93d4a68325a14875"/>
+    <p:sldId xmlns:r="http://schemas.openxmlformats.org/officeDocument/2006/relationships" id="277" r:id="R8eed4e5ed2bd4974"/>
+    <p:sldId xmlns:r="http://schemas.openxmlformats.org/officeDocument/2006/relationships" id="278" r:id="R903a7b0c1fe54652"/>
+    <p:sldId xmlns:r="http://schemas.openxmlformats.org/officeDocument/2006/relationships" id="279" r:id="R5b1ae799408b4457"/>
+    <p:sldId xmlns:r="http://schemas.openxmlformats.org/officeDocument/2006/relationships" id="280" r:id="Reb2ac1070c4045b0"/>
+    <p:sldId xmlns:r="http://schemas.openxmlformats.org/officeDocument/2006/relationships" id="281" r:id="Re875279b001e4772"/>
   </p:sldIdLst>
   <p:sldSz cx="12192000" cy="6858000"/>
   <p:notesSz cx="6858000" cy="9144000"/>
@@ -4902,7 +4902,7 @@
           </a:p>
           <a:p xmlns:a="http://schemas.openxmlformats.org/drawingml/2006/main">
             <a:r>
-              <a:t>EACU</a:t>
+              <a:t>EAEU</a:t>
             </a:r>
           </a:p>
           <a:p xmlns:a="http://schemas.openxmlformats.org/drawingml/2006/main">
@@ -4962,12 +4962,22 @@
           </a:p>
           <a:p xmlns:a="http://schemas.openxmlformats.org/drawingml/2006/main">
             <a:r>
+              <a:t>Current membership: October 2026.</a:t>
+            </a:r>
+          </a:p>
+          <a:p xmlns:a="http://schemas.openxmlformats.org/drawingml/2006/main">
+            <a:r>
+              <a:t/>
+            </a:r>
+          </a:p>
+          <a:p xmlns:a="http://schemas.openxmlformats.org/drawingml/2006/main">
+            <a:r>
               <a:t>EUCU</a:t>
             </a:r>
           </a:p>
           <a:p xmlns:a="http://schemas.openxmlformats.org/drawingml/2006/main">
             <a:r>
-              <a:t>EACU</a:t>
+              <a:t>EAEU</a:t>
             </a:r>
           </a:p>
           <a:p xmlns:a="http://schemas.openxmlformats.org/drawingml/2006/main">
@@ -5027,42 +5037,372 @@
           </a:p>
           <a:p xmlns:a="http://schemas.openxmlformats.org/drawingml/2006/main">
             <a:r>
-              <a:t>Historical illustration · membership and implementation vary. Map source (2021 revision, adapted); customs unions in practice.</a:t>
-            </a:r>
-          </a:p>
-          <a:p xmlns:a="http://schemas.openxmlformats.org/drawingml/2006/main">
-            <a:r>
-              <a:t/>
-            </a:r>
-          </a:p>
-          <a:p xmlns:a="http://schemas.openxmlformats.org/drawingml/2006/main">
-            <a:r>
-              <a:t>Historical world map of customs unions and trade blocs. Named controls provide descriptions in the online slide.</a:t>
-            </a:r>
-          </a:p>
-          <a:p xmlns:a="http://schemas.openxmlformats.org/drawingml/2006/main">
-            <a:r>
-              <a:t/>
-            </a:r>
-          </a:p>
-          <a:p xmlns:a="http://schemas.openxmlformats.org/drawingml/2006/main">
-            <a:r>
-              <a:t/>
-            </a:r>
-          </a:p>
-          <a:p xmlns:a="http://schemas.openxmlformats.org/drawingml/2006/main">
-            <a:r>
-              <a:t/>
+              <a:t>Checked 6 October 2026 · Selected arrangements; implementation varies. Stripes: special status or overlapping membership.</a:t>
+            </a:r>
+          </a:p>
+          <a:p xmlns:a="http://schemas.openxmlformats.org/drawingml/2006/main">
+            <a:r>
+              <a:t>Hover for details and official sources. Map base (adapted; territories simplified).</a:t>
+            </a:r>
+          </a:p>
+          <a:p xmlns:a="http://schemas.openxmlformats.org/drawingml/2006/main">
+            <a:r>
+              <a:t/>
+            </a:r>
+          </a:p>
+          <a:p xmlns:a="http://schemas.openxmlformats.org/drawingml/2006/main">
+            <a:r>
+              <a:t>Current membership and status (6 October 2026):</a:t>
+            </a:r>
+          </a:p>
+          <a:p xmlns:a="http://schemas.openxmlformats.org/drawingml/2006/main">
+            <a:r>
+              <a:t>EUCU: EU customs union and linked unions</a:t>
+            </a:r>
+          </a:p>
+          <a:p xmlns:a="http://schemas.openxmlformats.org/drawingml/2006/main">
+            <a:r>
+              <a:t>EU 27 and neighbouring arrangements</a:t>
+            </a:r>
+          </a:p>
+          <a:p xmlns:a="http://schemas.openxmlformats.org/drawingml/2006/main">
+            <a:r>
+              <a:t>EU 27 and Monaco share the EU customs territory. Türkiye, Andorra and San Marino have separate customs-union agreements (striped), with differing product coverage. The UK is outside.</a:t>
+            </a:r>
+          </a:p>
+          <a:p xmlns:a="http://schemas.openxmlformats.org/drawingml/2006/main">
+            <a:r>
+              <a:t/>
+            </a:r>
+          </a:p>
+          <a:p xmlns:a="http://schemas.openxmlformats.org/drawingml/2006/main">
+            <a:r>
+              <a:t>EAEU: Eurasian Economic Union</a:t>
+            </a:r>
+          </a:p>
+          <a:p xmlns:a="http://schemas.openxmlformats.org/drawingml/2006/main">
+            <a:r>
+              <a:t>5 members · Eurasia</a:t>
+            </a:r>
+          </a:p>
+          <a:p xmlns:a="http://schemas.openxmlformats.org/drawingml/2006/main">
+            <a:r>
+              <a:t>Armenia, Belarus, Kazakhstan, Kyrgyzstan and Russia share a customs union and common external tariff. Observer states and free-trade partners are not members and are not shaded.</a:t>
+            </a:r>
+          </a:p>
+          <a:p xmlns:a="http://schemas.openxmlformats.org/drawingml/2006/main">
+            <a:r>
+              <a:t/>
+            </a:r>
+          </a:p>
+          <a:p xmlns:a="http://schemas.openxmlformats.org/drawingml/2006/main">
+            <a:r>
+              <a:t>MERCOSUR: Southern Common Market</a:t>
+            </a:r>
+          </a:p>
+          <a:p xmlns:a="http://schemas.openxmlformats.org/drawingml/2006/main">
+            <a:r>
+              <a:t>5 active members · South America</a:t>
+            </a:r>
+          </a:p>
+          <a:p xmlns:a="http://schemas.openxmlformats.org/drawingml/2006/main">
+            <a:r>
+              <a:t>Argentina, Bolivia, Brazil, Paraguay and Uruguay. Bolivia joined in 2024, with up to four years to adopt bloc rules. Two-colour stripes show its Andean membership too. Venezuela remains suspended.</a:t>
+            </a:r>
+          </a:p>
+          <a:p xmlns:a="http://schemas.openxmlformats.org/drawingml/2006/main">
+            <a:r>
+              <a:t/>
+            </a:r>
+          </a:p>
+          <a:p xmlns:a="http://schemas.openxmlformats.org/drawingml/2006/main">
+            <a:r>
+              <a:t>CAN: Andean Community</a:t>
+            </a:r>
+          </a:p>
+          <a:p xmlns:a="http://schemas.openxmlformats.org/drawingml/2006/main">
+            <a:r>
+              <a:t>4 members · Andean South America</a:t>
+            </a:r>
+          </a:p>
+          <a:p xmlns:a="http://schemas.openxmlformats.org/drawingml/2006/main">
+            <a:r>
+              <a:t>Bolivia, Colombia, Ecuador and Peru. This is a free-trade integration bloc, without a fully operating common external tariff. Stripes flag that distinction; Bolivia also belongs to MERCOSUR.</a:t>
+            </a:r>
+          </a:p>
+          <a:p xmlns:a="http://schemas.openxmlformats.org/drawingml/2006/main">
+            <a:r>
+              <a:t/>
+            </a:r>
+          </a:p>
+          <a:p xmlns:a="http://schemas.openxmlformats.org/drawingml/2006/main">
+            <a:r>
+              <a:t>CACM: Central American economic integration</a:t>
+            </a:r>
+          </a:p>
+          <a:p xmlns:a="http://schemas.openxmlformats.org/drawingml/2006/main">
+            <a:r>
+              <a:t>6 participants · Central America</a:t>
+            </a:r>
+          </a:p>
+          <a:p xmlns:a="http://schemas.openxmlformats.org/drawingml/2006/main">
+            <a:r>
+              <a:t>Costa Rica, El Salvador, Guatemala, Honduras, Nicaragua and Panama. Panama joined in 2013; stripes mark its distinct incorporation arrangements. Customs and tariff integration remain incomplete.</a:t>
+            </a:r>
+          </a:p>
+          <a:p xmlns:a="http://schemas.openxmlformats.org/drawingml/2006/main">
+            <a:r>
+              <a:t/>
+            </a:r>
+          </a:p>
+          <a:p xmlns:a="http://schemas.openxmlformats.org/drawingml/2006/main">
+            <a:r>
+              <a:t>CARICOM: Caribbean Community</a:t>
+            </a:r>
+          </a:p>
+          <a:p xmlns:a="http://schemas.openxmlformats.org/drawingml/2006/main">
+            <a:r>
+              <a:t>15 members · 8 associate members</a:t>
+            </a:r>
+          </a:p>
+          <a:p xmlns:a="http://schemas.openxmlformats.org/drawingml/2006/main">
+            <a:r>
+              <a:t>Twelve Single Market participants. Haiti and Montserrat have special arrangements (striped). The Bahamas and associates are outside this tariff shading. Martinique and French Guiana became associates in 2026.</a:t>
+            </a:r>
+          </a:p>
+          <a:p xmlns:a="http://schemas.openxmlformats.org/drawingml/2006/main">
+            <a:r>
+              <a:t/>
+            </a:r>
+          </a:p>
+          <a:p xmlns:a="http://schemas.openxmlformats.org/drawingml/2006/main">
+            <a:r>
+              <a:t>WAEMU: West African Economic and Monetary Union</a:t>
+            </a:r>
+          </a:p>
+          <a:p xmlns:a="http://schemas.openxmlformats.org/drawingml/2006/main">
+            <a:r>
+              <a:t>8 members · also called UEMOA</a:t>
+            </a:r>
+          </a:p>
+          <a:p xmlns:a="http://schemas.openxmlformats.org/drawingml/2006/main">
+            <a:r>
+              <a:t>Eight members, including Mali, Burkina Faso and Niger. UEMOA remains their customs and monetary union. It is a separate organisation from ECOWAS.</a:t>
+            </a:r>
+          </a:p>
+          <a:p xmlns:a="http://schemas.openxmlformats.org/drawingml/2006/main">
+            <a:r>
+              <a:t/>
+            </a:r>
+          </a:p>
+          <a:p xmlns:a="http://schemas.openxmlformats.org/drawingml/2006/main">
+            <a:r>
+              <a:t>CEMAC: Central African Economic and Monetary Community</a:t>
+            </a:r>
+          </a:p>
+          <a:p xmlns:a="http://schemas.openxmlformats.org/drawingml/2006/main">
+            <a:r>
+              <a:t>6 members · Central Africa</a:t>
+            </a:r>
+          </a:p>
+          <a:p xmlns:a="http://schemas.openxmlformats.org/drawingml/2006/main">
+            <a:r>
+              <a:t>Cameroon, Central African Republic, Chad, Republic of the Congo, Equatorial Guinea and Gabon share a customs-union framework and common currency.</a:t>
+            </a:r>
+          </a:p>
+          <a:p xmlns:a="http://schemas.openxmlformats.org/drawingml/2006/main">
+            <a:r>
+              <a:t/>
+            </a:r>
+          </a:p>
+          <a:p xmlns:a="http://schemas.openxmlformats.org/drawingml/2006/main">
+            <a:r>
+              <a:t>EAC: East African Community</a:t>
+            </a:r>
+          </a:p>
+          <a:p xmlns:a="http://schemas.openxmlformats.org/drawingml/2006/main">
+            <a:r>
+              <a:t>8 partner states · East Africa</a:t>
+            </a:r>
+          </a:p>
+          <a:p xmlns:a="http://schemas.openxmlformats.org/drawingml/2006/main">
+            <a:r>
+              <a:t>Now eight members. South Sudan joined in 2016, DR Congo in 2022 and Somalia in 2024. These three are striped because integration into EAC rules is still underway.</a:t>
+            </a:r>
+          </a:p>
+          <a:p xmlns:a="http://schemas.openxmlformats.org/drawingml/2006/main">
+            <a:r>
+              <a:t/>
+            </a:r>
+          </a:p>
+          <a:p xmlns:a="http://schemas.openxmlformats.org/drawingml/2006/main">
+            <a:r>
+              <a:t>SACU: Southern African Customs Union</a:t>
+            </a:r>
+          </a:p>
+          <a:p xmlns:a="http://schemas.openxmlformats.org/drawingml/2006/main">
+            <a:r>
+              <a:t>5 members · Southern Africa</a:t>
+            </a:r>
+          </a:p>
+          <a:p xmlns:a="http://schemas.openxmlformats.org/drawingml/2006/main">
+            <a:r>
+              <a:t>Botswana, Eswatini, Lesotho, Namibia and South Africa share a customs area, a common external tariff and a revenue-sharing arrangement.</a:t>
+            </a:r>
+          </a:p>
+          <a:p xmlns:a="http://schemas.openxmlformats.org/drawingml/2006/main">
+            <a:r>
+              <a:t/>
+            </a:r>
+          </a:p>
+          <a:p xmlns:a="http://schemas.openxmlformats.org/drawingml/2006/main">
+            <a:r>
+              <a:t>GCC: Gulf Cooperation Council</a:t>
+            </a:r>
+          </a:p>
+          <a:p xmlns:a="http://schemas.openxmlformats.org/drawingml/2006/main">
+            <a:r>
+              <a:t>6 members · Arabian Gulf</a:t>
+            </a:r>
+          </a:p>
+          <a:p xmlns:a="http://schemas.openxmlformats.org/drawingml/2006/main">
+            <a:r>
+              <a:t>Bahrain, Kuwait, Oman, Qatar, Saudi Arabia and the United Arab Emirates. Their customs union dates from 2003; completing its remaining requirements is still an official priority.</a:t>
+            </a:r>
+          </a:p>
+          <a:p xmlns:a="http://schemas.openxmlformats.org/drawingml/2006/main">
+            <a:r>
+              <a:t/>
+            </a:r>
+          </a:p>
+          <a:p xmlns:a="http://schemas.openxmlformats.org/drawingml/2006/main">
+            <a:r>
+              <a:t>CH-FL: Switzerland–Liechtenstein customs union</a:t>
+            </a:r>
+          </a:p>
+          <a:p xmlns:a="http://schemas.openxmlformats.org/drawingml/2006/main">
+            <a:r>
+              <a:t>2 countries · Central Europe</a:t>
+            </a:r>
+          </a:p>
+          <a:p xmlns:a="http://schemas.openxmlformats.org/drawingml/2006/main">
+            <a:r>
+              <a:t>Liechtenstein forms a common customs area with Switzerland under their bilateral treaty. Both countries are outside the EU customs union.</a:t>
+            </a:r>
+          </a:p>
+          <a:p xmlns:a="http://schemas.openxmlformats.org/drawingml/2006/main">
+            <a:r>
+              <a:t/>
+            </a:r>
+          </a:p>
+          <a:p xmlns:a="http://schemas.openxmlformats.org/drawingml/2006/main">
+            <a:r>
+              <a:t>Membership checked 6 October 2026. The East African Community includes eight countries, including South Sudan, DR Congo and Somalia. Bolivia belongs to MERCOSUR and the Andean Community. Stripes identify special or transitional arrangements. Choose a bloc for current membership and qualifications; geography is simplified.</a:t>
+            </a:r>
+          </a:p>
+          <a:p xmlns:a="http://schemas.openxmlformats.org/drawingml/2006/main">
+            <a:r>
+              <a:t/>
+            </a:r>
+          </a:p>
+          <a:p xmlns:a="http://schemas.openxmlformats.org/drawingml/2006/main">
+            <a:r>
+              <a:t/>
+            </a:r>
+          </a:p>
+          <a:p xmlns:a="http://schemas.openxmlformats.org/drawingml/2006/main">
+            <a:r>
+              <a:t/>
+            </a:r>
+          </a:p>
+          <a:p xmlns:a="http://schemas.openxmlformats.org/drawingml/2006/main">
+            <a:r>
+              <a:t>https://taxation-customs.ec.europa.eu/list-non-eu-countries_en</a:t>
+            </a:r>
+          </a:p>
+          <a:p xmlns:a="http://schemas.openxmlformats.org/drawingml/2006/main">
+            <a:r>
+              <a:t>https://taxation-customs.ec.europa.eu/customs/eu-customs-reform_en</a:t>
+            </a:r>
+          </a:p>
+          <a:p xmlns:a="http://schemas.openxmlformats.org/drawingml/2006/main">
+            <a:r>
+              <a:t>https://www.eaeunion.org/?lang=en</a:t>
+            </a:r>
+          </a:p>
+          <a:p xmlns:a="http://schemas.openxmlformats.org/drawingml/2006/main">
+            <a:r>
+              <a:t>https://www.mercosur.int/en/about-mercosur/countries</a:t>
+            </a:r>
+          </a:p>
+          <a:p xmlns:a="http://schemas.openxmlformats.org/drawingml/2006/main">
+            <a:r>
+              <a:t>https://www.comunidadandina.org/quienes-somos/paises-miembros/</a:t>
+            </a:r>
+          </a:p>
+          <a:p xmlns:a="http://schemas.openxmlformats.org/drawingml/2006/main">
+            <a:r>
+              <a:t>https://www.comunidadandina.org/DocOficialesFiles/DInformativos/SGdi1053.pdf</a:t>
+            </a:r>
+          </a:p>
+          <a:p xmlns:a="http://schemas.openxmlformats.org/drawingml/2006/main">
+            <a:r>
+              <a:t>https://www.sieca.int/faq/</a:t>
+            </a:r>
+          </a:p>
+          <a:p xmlns:a="http://schemas.openxmlformats.org/drawingml/2006/main">
+            <a:r>
+              <a:t>https://www.sieca.int/integracion-economica-centroamericana/panama-en-el-subsistema-economico/</a:t>
+            </a:r>
+          </a:p>
+          <a:p xmlns:a="http://schemas.openxmlformats.org/drawingml/2006/main">
+            <a:r>
+              <a:t>https://caricom.org/caricom-secretariat-wraps-up-trade-readiness-talks-with-400-stakeholders-across-12-countries/</a:t>
+            </a:r>
+          </a:p>
+          <a:p xmlns:a="http://schemas.openxmlformats.org/drawingml/2006/main">
+            <a:r>
+              <a:t>https://caricom.org/communique-fifty-first-regular-meeting-of-the-conference-of-heads-of-government-of-the-caribbean-community-caricom-saint-lucia/</a:t>
+            </a:r>
+          </a:p>
+          <a:p xmlns:a="http://schemas.openxmlformats.org/drawingml/2006/main">
+            <a:r>
+              <a:t>https://www.uemoa.int/index.php/en/presentation-of-uemoa</a:t>
+            </a:r>
+          </a:p>
+          <a:p xmlns:a="http://schemas.openxmlformats.org/drawingml/2006/main">
+            <a:r>
+              <a:t>https://cemac.int/</a:t>
+            </a:r>
+          </a:p>
+          <a:p xmlns:a="http://schemas.openxmlformats.org/drawingml/2006/main">
+            <a:r>
+              <a:t>https://www.eac.int/overview-of-eac</a:t>
+            </a:r>
+          </a:p>
+          <a:p xmlns:a="http://schemas.openxmlformats.org/drawingml/2006/main">
+            <a:r>
+              <a:t>https://www.sacu.int/about-sacu</a:t>
+            </a:r>
+          </a:p>
+          <a:p xmlns:a="http://schemas.openxmlformats.org/drawingml/2006/main">
+            <a:r>
+              <a:t>https://www.gcc-sg.org/en/AboutUs/Pages/FoundingDay.aspx</a:t>
+            </a:r>
+          </a:p>
+          <a:p xmlns:a="http://schemas.openxmlformats.org/drawingml/2006/main">
+            <a:r>
+              <a:t>https://www.gcc-sg.org/en/MediaCenter/News/Pages/news2025-12-3-3.aspx</a:t>
+            </a:r>
+          </a:p>
+          <a:p xmlns:a="http://schemas.openxmlformats.org/drawingml/2006/main">
+            <a:r>
+              <a:t>https://www.llv.li/en/national-administration/diplomatic-representations/berne-ch/bilateral-relations-liechtenstein---switzerland</a:t>
             </a:r>
           </a:p>
           <a:p xmlns:a="http://schemas.openxmlformats.org/drawingml/2006/main">
             <a:r>
               <a:t>https://commons.wikimedia.org/wiki/File:Customs_Unions_World.svg</a:t>
-            </a:r>
-          </a:p>
-          <a:p xmlns:a="http://schemas.openxmlformats.org/drawingml/2006/main">
-            <a:r>
-              <a:t>https://www.uktpo.org/2018/03/29/what-can-the-uk-learn-from-existing-customs-unions/</a:t>
             </a:r>
           </a:p>
         </p:txBody>
@@ -5935,7 +6275,7 @@
   </p:cSld>
   <p:clrMap bg1="lt1" tx1="dk1" bg2="lt2" tx2="dk2" accent1="accent1" accent2="accent2" accent3="accent3" accent4="accent4" accent5="accent5" accent6="accent6" hlink="hlink" folHlink="folHlink"/>
   <p:sldLayoutIdLst>
-    <p:sldLayoutId xmlns:r="http://schemas.openxmlformats.org/officeDocument/2006/relationships" id="2147483649" r:id="R08167d3d2bd844b9"/>
+    <p:sldLayoutId xmlns:r="http://schemas.openxmlformats.org/officeDocument/2006/relationships" id="2147483649" r:id="R343d1a3e7ea345e7"/>
   </p:sldLayoutIdLst>
   <p:txStyles>
     <p:titleStyle>
@@ -6483,7 +6823,7 @@
           <p:nvPr/>
         </p:nvPicPr>
         <p:blipFill>
-          <a:blip xmlns:r="http://schemas.openxmlformats.org/officeDocument/2006/relationships" xmlns:a="http://schemas.openxmlformats.org/drawingml/2006/main" r:embed="R0cb6c42f6ae449b9"/>
+          <a:blip xmlns:r="http://schemas.openxmlformats.org/officeDocument/2006/relationships" xmlns:a="http://schemas.openxmlformats.org/drawingml/2006/main" r:embed="Rc98e3382a83b402d"/>
           <a:stretch xmlns:a="http://schemas.openxmlformats.org/drawingml/2006/main"/>
         </p:blipFill>
         <p:spPr>
@@ -6499,7 +6839,7 @@
     </p:spTree>
     <p:extLst>
       <p:ext uri="{BB962C8B-B14F-4D97-AF65-F5344CB8AC3E}">
-        <p14:creationId xmlns:p14="http://schemas.microsoft.com/office/powerpoint/2010/main" val="2052902077"/>
+        <p14:creationId xmlns:p14="http://schemas.microsoft.com/office/powerpoint/2010/main" val="1634345264"/>
       </p:ext>
     </p:extLst>
   </p:cSld>
@@ -6527,7 +6867,7 @@
           <p:nvPr/>
         </p:nvPicPr>
         <p:blipFill>
-          <a:blip xmlns:r="http://schemas.openxmlformats.org/officeDocument/2006/relationships" xmlns:a="http://schemas.openxmlformats.org/drawingml/2006/main" r:embed="Rda78d6e6df26420c"/>
+          <a:blip xmlns:r="http://schemas.openxmlformats.org/officeDocument/2006/relationships" xmlns:a="http://schemas.openxmlformats.org/drawingml/2006/main" r:embed="Rc2ced3d278e9458f"/>
           <a:stretch xmlns:a="http://schemas.openxmlformats.org/drawingml/2006/main"/>
         </p:blipFill>
         <p:spPr>
@@ -6543,7 +6883,7 @@
     </p:spTree>
     <p:extLst>
       <p:ext uri="{BB962C8B-B14F-4D97-AF65-F5344CB8AC3E}">
-        <p14:creationId xmlns:p14="http://schemas.microsoft.com/office/powerpoint/2010/main" val="1746304369"/>
+        <p14:creationId xmlns:p14="http://schemas.microsoft.com/office/powerpoint/2010/main" val="1830212492"/>
       </p:ext>
     </p:extLst>
   </p:cSld>
@@ -6571,7 +6911,7 @@
           <p:nvPr/>
         </p:nvPicPr>
         <p:blipFill>
-          <a:blip xmlns:r="http://schemas.openxmlformats.org/officeDocument/2006/relationships" xmlns:a="http://schemas.openxmlformats.org/drawingml/2006/main" r:embed="R60473ae0c77b4e75"/>
+          <a:blip xmlns:r="http://schemas.openxmlformats.org/officeDocument/2006/relationships" xmlns:a="http://schemas.openxmlformats.org/drawingml/2006/main" r:embed="R38a115bf15ac4c83"/>
           <a:stretch xmlns:a="http://schemas.openxmlformats.org/drawingml/2006/main"/>
         </p:blipFill>
         <p:spPr>
@@ -6587,7 +6927,7 @@
     </p:spTree>
     <p:extLst>
       <p:ext uri="{BB962C8B-B14F-4D97-AF65-F5344CB8AC3E}">
-        <p14:creationId xmlns:p14="http://schemas.microsoft.com/office/powerpoint/2010/main" val="1604197532"/>
+        <p14:creationId xmlns:p14="http://schemas.microsoft.com/office/powerpoint/2010/main" val="2010169562"/>
       </p:ext>
     </p:extLst>
   </p:cSld>
@@ -6615,7 +6955,7 @@
           <p:nvPr/>
         </p:nvPicPr>
         <p:blipFill>
-          <a:blip xmlns:r="http://schemas.openxmlformats.org/officeDocument/2006/relationships" xmlns:a="http://schemas.openxmlformats.org/drawingml/2006/main" r:embed="Rbfc4c15f155a4811"/>
+          <a:blip xmlns:r="http://schemas.openxmlformats.org/officeDocument/2006/relationships" xmlns:a="http://schemas.openxmlformats.org/drawingml/2006/main" r:embed="Ree6785dd71d049e5"/>
           <a:stretch xmlns:a="http://schemas.openxmlformats.org/drawingml/2006/main"/>
         </p:blipFill>
         <p:spPr>
@@ -6631,7 +6971,7 @@
     </p:spTree>
     <p:extLst>
       <p:ext uri="{BB962C8B-B14F-4D97-AF65-F5344CB8AC3E}">
-        <p14:creationId xmlns:p14="http://schemas.microsoft.com/office/powerpoint/2010/main" val="915757569"/>
+        <p14:creationId xmlns:p14="http://schemas.microsoft.com/office/powerpoint/2010/main" val="958069319"/>
       </p:ext>
     </p:extLst>
   </p:cSld>
@@ -6659,7 +6999,7 @@
           <p:nvPr/>
         </p:nvPicPr>
         <p:blipFill>
-          <a:blip xmlns:r="http://schemas.openxmlformats.org/officeDocument/2006/relationships" xmlns:a="http://schemas.openxmlformats.org/drawingml/2006/main" r:embed="R255b5c38856541af"/>
+          <a:blip xmlns:r="http://schemas.openxmlformats.org/officeDocument/2006/relationships" xmlns:a="http://schemas.openxmlformats.org/drawingml/2006/main" r:embed="R899dd9153bbb4ae9"/>
           <a:stretch xmlns:a="http://schemas.openxmlformats.org/drawingml/2006/main"/>
         </p:blipFill>
         <p:spPr>
@@ -6675,7 +7015,7 @@
     </p:spTree>
     <p:extLst>
       <p:ext uri="{BB962C8B-B14F-4D97-AF65-F5344CB8AC3E}">
-        <p14:creationId xmlns:p14="http://schemas.microsoft.com/office/powerpoint/2010/main" val="985402534"/>
+        <p14:creationId xmlns:p14="http://schemas.microsoft.com/office/powerpoint/2010/main" val="1858577471"/>
       </p:ext>
     </p:extLst>
   </p:cSld>
@@ -6703,7 +7043,7 @@
           <p:nvPr/>
         </p:nvPicPr>
         <p:blipFill>
-          <a:blip xmlns:r="http://schemas.openxmlformats.org/officeDocument/2006/relationships" xmlns:a="http://schemas.openxmlformats.org/drawingml/2006/main" r:embed="R1ce33d0bd4d74ee4"/>
+          <a:blip xmlns:r="http://schemas.openxmlformats.org/officeDocument/2006/relationships" xmlns:a="http://schemas.openxmlformats.org/drawingml/2006/main" r:embed="Rf7263de55b5b4e25"/>
           <a:stretch xmlns:a="http://schemas.openxmlformats.org/drawingml/2006/main"/>
         </p:blipFill>
         <p:spPr>
@@ -6719,7 +7059,7 @@
     </p:spTree>
     <p:extLst>
       <p:ext uri="{BB962C8B-B14F-4D97-AF65-F5344CB8AC3E}">
-        <p14:creationId xmlns:p14="http://schemas.microsoft.com/office/powerpoint/2010/main" val="892117105"/>
+        <p14:creationId xmlns:p14="http://schemas.microsoft.com/office/powerpoint/2010/main" val="1403781128"/>
       </p:ext>
     </p:extLst>
   </p:cSld>
@@ -6747,7 +7087,7 @@
           <p:nvPr/>
         </p:nvPicPr>
         <p:blipFill>
-          <a:blip xmlns:r="http://schemas.openxmlformats.org/officeDocument/2006/relationships" xmlns:a="http://schemas.openxmlformats.org/drawingml/2006/main" r:embed="R48ebf36a05b740fe"/>
+          <a:blip xmlns:r="http://schemas.openxmlformats.org/officeDocument/2006/relationships" xmlns:a="http://schemas.openxmlformats.org/drawingml/2006/main" r:embed="R73257d43e4bf42de"/>
           <a:stretch xmlns:a="http://schemas.openxmlformats.org/drawingml/2006/main"/>
         </p:blipFill>
         <p:spPr>
@@ -6763,7 +7103,7 @@
     </p:spTree>
     <p:extLst>
       <p:ext uri="{BB962C8B-B14F-4D97-AF65-F5344CB8AC3E}">
-        <p14:creationId xmlns:p14="http://schemas.microsoft.com/office/powerpoint/2010/main" val="827864445"/>
+        <p14:creationId xmlns:p14="http://schemas.microsoft.com/office/powerpoint/2010/main" val="1449176277"/>
       </p:ext>
     </p:extLst>
   </p:cSld>
@@ -6791,7 +7131,7 @@
           <p:nvPr/>
         </p:nvPicPr>
         <p:blipFill>
-          <a:blip xmlns:r="http://schemas.openxmlformats.org/officeDocument/2006/relationships" xmlns:a="http://schemas.openxmlformats.org/drawingml/2006/main" r:embed="Rd18fc5fec89c4713"/>
+          <a:blip xmlns:r="http://schemas.openxmlformats.org/officeDocument/2006/relationships" xmlns:a="http://schemas.openxmlformats.org/drawingml/2006/main" r:embed="Re49d5bdf395744a2"/>
           <a:stretch xmlns:a="http://schemas.openxmlformats.org/drawingml/2006/main"/>
         </p:blipFill>
         <p:spPr>
@@ -6807,7 +7147,7 @@
     </p:spTree>
     <p:extLst>
       <p:ext uri="{BB962C8B-B14F-4D97-AF65-F5344CB8AC3E}">
-        <p14:creationId xmlns:p14="http://schemas.microsoft.com/office/powerpoint/2010/main" val="1191263455"/>
+        <p14:creationId xmlns:p14="http://schemas.microsoft.com/office/powerpoint/2010/main" val="135114811"/>
       </p:ext>
     </p:extLst>
   </p:cSld>
@@ -6835,7 +7175,7 @@
           <p:nvPr/>
         </p:nvPicPr>
         <p:blipFill>
-          <a:blip xmlns:r="http://schemas.openxmlformats.org/officeDocument/2006/relationships" xmlns:a="http://schemas.openxmlformats.org/drawingml/2006/main" r:embed="Rd396c22a107c44d8"/>
+          <a:blip xmlns:r="http://schemas.openxmlformats.org/officeDocument/2006/relationships" xmlns:a="http://schemas.openxmlformats.org/drawingml/2006/main" r:embed="R5ac2dee5168e43b7"/>
           <a:stretch xmlns:a="http://schemas.openxmlformats.org/drawingml/2006/main"/>
         </p:blipFill>
         <p:spPr>
@@ -6851,7 +7191,7 @@
     </p:spTree>
     <p:extLst>
       <p:ext uri="{BB962C8B-B14F-4D97-AF65-F5344CB8AC3E}">
-        <p14:creationId xmlns:p14="http://schemas.microsoft.com/office/powerpoint/2010/main" val="1920739242"/>
+        <p14:creationId xmlns:p14="http://schemas.microsoft.com/office/powerpoint/2010/main" val="392639251"/>
       </p:ext>
     </p:extLst>
   </p:cSld>
@@ -6879,7 +7219,7 @@
           <p:nvPr/>
         </p:nvPicPr>
         <p:blipFill>
-          <a:blip xmlns:r="http://schemas.openxmlformats.org/officeDocument/2006/relationships" xmlns:a="http://schemas.openxmlformats.org/drawingml/2006/main" r:embed="R1096370acd604ff9"/>
+          <a:blip xmlns:r="http://schemas.openxmlformats.org/officeDocument/2006/relationships" xmlns:a="http://schemas.openxmlformats.org/drawingml/2006/main" r:embed="R451cdc1263804609"/>
           <a:stretch xmlns:a="http://schemas.openxmlformats.org/drawingml/2006/main"/>
         </p:blipFill>
         <p:spPr>
@@ -6895,7 +7235,7 @@
     </p:spTree>
     <p:extLst>
       <p:ext uri="{BB962C8B-B14F-4D97-AF65-F5344CB8AC3E}">
-        <p14:creationId xmlns:p14="http://schemas.microsoft.com/office/powerpoint/2010/main" val="379393863"/>
+        <p14:creationId xmlns:p14="http://schemas.microsoft.com/office/powerpoint/2010/main" val="248294691"/>
       </p:ext>
     </p:extLst>
   </p:cSld>
@@ -6923,7 +7263,7 @@
           <p:nvPr/>
         </p:nvPicPr>
         <p:blipFill>
-          <a:blip xmlns:r="http://schemas.openxmlformats.org/officeDocument/2006/relationships" xmlns:a="http://schemas.openxmlformats.org/drawingml/2006/main" r:embed="Rfed7550661ca4329"/>
+          <a:blip xmlns:r="http://schemas.openxmlformats.org/officeDocument/2006/relationships" xmlns:a="http://schemas.openxmlformats.org/drawingml/2006/main" r:embed="Rb127233016574cbf"/>
           <a:stretch xmlns:a="http://schemas.openxmlformats.org/drawingml/2006/main"/>
         </p:blipFill>
         <p:spPr>
@@ -6939,7 +7279,7 @@
     </p:spTree>
     <p:extLst>
       <p:ext uri="{BB962C8B-B14F-4D97-AF65-F5344CB8AC3E}">
-        <p14:creationId xmlns:p14="http://schemas.microsoft.com/office/powerpoint/2010/main" val="1653779724"/>
+        <p14:creationId xmlns:p14="http://schemas.microsoft.com/office/powerpoint/2010/main" val="1527583364"/>
       </p:ext>
     </p:extLst>
   </p:cSld>
@@ -6967,7 +7307,7 @@
           <p:nvPr/>
         </p:nvPicPr>
         <p:blipFill>
-          <a:blip xmlns:r="http://schemas.openxmlformats.org/officeDocument/2006/relationships" xmlns:a="http://schemas.openxmlformats.org/drawingml/2006/main" r:embed="R85da0c106ef44603"/>
+          <a:blip xmlns:r="http://schemas.openxmlformats.org/officeDocument/2006/relationships" xmlns:a="http://schemas.openxmlformats.org/drawingml/2006/main" r:embed="R233012deee424d07"/>
           <a:stretch xmlns:a="http://schemas.openxmlformats.org/drawingml/2006/main"/>
         </p:blipFill>
         <p:spPr>
@@ -6983,7 +7323,7 @@
     </p:spTree>
     <p:extLst>
       <p:ext uri="{BB962C8B-B14F-4D97-AF65-F5344CB8AC3E}">
-        <p14:creationId xmlns:p14="http://schemas.microsoft.com/office/powerpoint/2010/main" val="1949270001"/>
+        <p14:creationId xmlns:p14="http://schemas.microsoft.com/office/powerpoint/2010/main" val="1112977644"/>
       </p:ext>
     </p:extLst>
   </p:cSld>
@@ -7011,7 +7351,7 @@
           <p:nvPr/>
         </p:nvPicPr>
         <p:blipFill>
-          <a:blip xmlns:r="http://schemas.openxmlformats.org/officeDocument/2006/relationships" xmlns:a="http://schemas.openxmlformats.org/drawingml/2006/main" r:embed="Re895245885cd48da"/>
+          <a:blip xmlns:r="http://schemas.openxmlformats.org/officeDocument/2006/relationships" xmlns:a="http://schemas.openxmlformats.org/drawingml/2006/main" r:embed="R9db28850d943462a"/>
           <a:stretch xmlns:a="http://schemas.openxmlformats.org/drawingml/2006/main"/>
         </p:blipFill>
         <p:spPr>
@@ -7027,7 +7367,7 @@
     </p:spTree>
     <p:extLst>
       <p:ext uri="{BB962C8B-B14F-4D97-AF65-F5344CB8AC3E}">
-        <p14:creationId xmlns:p14="http://schemas.microsoft.com/office/powerpoint/2010/main" val="459094494"/>
+        <p14:creationId xmlns:p14="http://schemas.microsoft.com/office/powerpoint/2010/main" val="952509145"/>
       </p:ext>
     </p:extLst>
   </p:cSld>
@@ -7055,7 +7395,7 @@
           <p:nvPr/>
         </p:nvPicPr>
         <p:blipFill>
-          <a:blip xmlns:r="http://schemas.openxmlformats.org/officeDocument/2006/relationships" xmlns:a="http://schemas.openxmlformats.org/drawingml/2006/main" r:embed="Raa8533a4564c483e"/>
+          <a:blip xmlns:r="http://schemas.openxmlformats.org/officeDocument/2006/relationships" xmlns:a="http://schemas.openxmlformats.org/drawingml/2006/main" r:embed="R2a50b0d956dd422a"/>
           <a:stretch xmlns:a="http://schemas.openxmlformats.org/drawingml/2006/main"/>
         </p:blipFill>
         <p:spPr>
@@ -7071,7 +7411,7 @@
     </p:spTree>
     <p:extLst>
       <p:ext uri="{BB962C8B-B14F-4D97-AF65-F5344CB8AC3E}">
-        <p14:creationId xmlns:p14="http://schemas.microsoft.com/office/powerpoint/2010/main" val="440546758"/>
+        <p14:creationId xmlns:p14="http://schemas.microsoft.com/office/powerpoint/2010/main" val="2129428281"/>
       </p:ext>
     </p:extLst>
   </p:cSld>
@@ -7099,7 +7439,7 @@
           <p:nvPr/>
         </p:nvPicPr>
         <p:blipFill>
-          <a:blip xmlns:r="http://schemas.openxmlformats.org/officeDocument/2006/relationships" xmlns:a="http://schemas.openxmlformats.org/drawingml/2006/main" r:embed="Rd337f6b1e950444f"/>
+          <a:blip xmlns:r="http://schemas.openxmlformats.org/officeDocument/2006/relationships" xmlns:a="http://schemas.openxmlformats.org/drawingml/2006/main" r:embed="Ra299d60155e84210"/>
           <a:stretch xmlns:a="http://schemas.openxmlformats.org/drawingml/2006/main"/>
         </p:blipFill>
         <p:spPr>
@@ -7115,7 +7455,7 @@
     </p:spTree>
     <p:extLst>
       <p:ext uri="{BB962C8B-B14F-4D97-AF65-F5344CB8AC3E}">
-        <p14:creationId xmlns:p14="http://schemas.microsoft.com/office/powerpoint/2010/main" val="1064643196"/>
+        <p14:creationId xmlns:p14="http://schemas.microsoft.com/office/powerpoint/2010/main" val="437150392"/>
       </p:ext>
     </p:extLst>
   </p:cSld>
@@ -7143,7 +7483,7 @@
           <p:nvPr/>
         </p:nvPicPr>
         <p:blipFill>
-          <a:blip xmlns:r="http://schemas.openxmlformats.org/officeDocument/2006/relationships" xmlns:a="http://schemas.openxmlformats.org/drawingml/2006/main" r:embed="R54bbc929ce544dda"/>
+          <a:blip xmlns:r="http://schemas.openxmlformats.org/officeDocument/2006/relationships" xmlns:a="http://schemas.openxmlformats.org/drawingml/2006/main" r:embed="R4c70a9dff86744d2"/>
           <a:stretch xmlns:a="http://schemas.openxmlformats.org/drawingml/2006/main"/>
         </p:blipFill>
         <p:spPr>
@@ -7159,7 +7499,7 @@
     </p:spTree>
     <p:extLst>
       <p:ext uri="{BB962C8B-B14F-4D97-AF65-F5344CB8AC3E}">
-        <p14:creationId xmlns:p14="http://schemas.microsoft.com/office/powerpoint/2010/main" val="1807104156"/>
+        <p14:creationId xmlns:p14="http://schemas.microsoft.com/office/powerpoint/2010/main" val="1776491545"/>
       </p:ext>
     </p:extLst>
   </p:cSld>
@@ -7187,7 +7527,7 @@
           <p:nvPr/>
         </p:nvPicPr>
         <p:blipFill>
-          <a:blip xmlns:r="http://schemas.openxmlformats.org/officeDocument/2006/relationships" xmlns:a="http://schemas.openxmlformats.org/drawingml/2006/main" r:embed="Rbb0b81689b624ef7"/>
+          <a:blip xmlns:r="http://schemas.openxmlformats.org/officeDocument/2006/relationships" xmlns:a="http://schemas.openxmlformats.org/drawingml/2006/main" r:embed="Rc2691a5ab1a14fc5"/>
           <a:stretch xmlns:a="http://schemas.openxmlformats.org/drawingml/2006/main"/>
         </p:blipFill>
         <p:spPr>
@@ -7203,7 +7543,7 @@
     </p:spTree>
     <p:extLst>
       <p:ext uri="{BB962C8B-B14F-4D97-AF65-F5344CB8AC3E}">
-        <p14:creationId xmlns:p14="http://schemas.microsoft.com/office/powerpoint/2010/main" val="1808353917"/>
+        <p14:creationId xmlns:p14="http://schemas.microsoft.com/office/powerpoint/2010/main" val="430741716"/>
       </p:ext>
     </p:extLst>
   </p:cSld>
@@ -7231,7 +7571,7 @@
           <p:nvPr/>
         </p:nvPicPr>
         <p:blipFill>
-          <a:blip xmlns:r="http://schemas.openxmlformats.org/officeDocument/2006/relationships" xmlns:a="http://schemas.openxmlformats.org/drawingml/2006/main" r:embed="R9c32ad22582c4296"/>
+          <a:blip xmlns:r="http://schemas.openxmlformats.org/officeDocument/2006/relationships" xmlns:a="http://schemas.openxmlformats.org/drawingml/2006/main" r:embed="Re06fd06354ec4b01"/>
           <a:stretch xmlns:a="http://schemas.openxmlformats.org/drawingml/2006/main"/>
         </p:blipFill>
         <p:spPr>
@@ -7247,7 +7587,7 @@
     </p:spTree>
     <p:extLst>
       <p:ext uri="{BB962C8B-B14F-4D97-AF65-F5344CB8AC3E}">
-        <p14:creationId xmlns:p14="http://schemas.microsoft.com/office/powerpoint/2010/main" val="605416776"/>
+        <p14:creationId xmlns:p14="http://schemas.microsoft.com/office/powerpoint/2010/main" val="1456330828"/>
       </p:ext>
     </p:extLst>
   </p:cSld>
@@ -7275,7 +7615,7 @@
           <p:nvPr/>
         </p:nvPicPr>
         <p:blipFill>
-          <a:blip xmlns:r="http://schemas.openxmlformats.org/officeDocument/2006/relationships" xmlns:a="http://schemas.openxmlformats.org/drawingml/2006/main" r:embed="R913d291d67f74880"/>
+          <a:blip xmlns:r="http://schemas.openxmlformats.org/officeDocument/2006/relationships" xmlns:a="http://schemas.openxmlformats.org/drawingml/2006/main" r:embed="R859fa542a0f14924"/>
           <a:stretch xmlns:a="http://schemas.openxmlformats.org/drawingml/2006/main"/>
         </p:blipFill>
         <p:spPr>
@@ -7291,7 +7631,7 @@
     </p:spTree>
     <p:extLst>
       <p:ext uri="{BB962C8B-B14F-4D97-AF65-F5344CB8AC3E}">
-        <p14:creationId xmlns:p14="http://schemas.microsoft.com/office/powerpoint/2010/main" val="1981236338"/>
+        <p14:creationId xmlns:p14="http://schemas.microsoft.com/office/powerpoint/2010/main" val="1494239276"/>
       </p:ext>
     </p:extLst>
   </p:cSld>
@@ -7319,7 +7659,7 @@
           <p:nvPr/>
         </p:nvPicPr>
         <p:blipFill>
-          <a:blip xmlns:r="http://schemas.openxmlformats.org/officeDocument/2006/relationships" xmlns:a="http://schemas.openxmlformats.org/drawingml/2006/main" r:embed="R200aae3b90474119"/>
+          <a:blip xmlns:r="http://schemas.openxmlformats.org/officeDocument/2006/relationships" xmlns:a="http://schemas.openxmlformats.org/drawingml/2006/main" r:embed="R991cc913cb434639"/>
           <a:stretch xmlns:a="http://schemas.openxmlformats.org/drawingml/2006/main"/>
         </p:blipFill>
         <p:spPr>
@@ -7335,7 +7675,7 @@
     </p:spTree>
     <p:extLst>
       <p:ext uri="{BB962C8B-B14F-4D97-AF65-F5344CB8AC3E}">
-        <p14:creationId xmlns:p14="http://schemas.microsoft.com/office/powerpoint/2010/main" val="624338774"/>
+        <p14:creationId xmlns:p14="http://schemas.microsoft.com/office/powerpoint/2010/main" val="1277347037"/>
       </p:ext>
     </p:extLst>
   </p:cSld>
@@ -7363,7 +7703,7 @@
           <p:nvPr/>
         </p:nvPicPr>
         <p:blipFill>
-          <a:blip xmlns:r="http://schemas.openxmlformats.org/officeDocument/2006/relationships" xmlns:a="http://schemas.openxmlformats.org/drawingml/2006/main" r:embed="R8e35575e34f349ce"/>
+          <a:blip xmlns:r="http://schemas.openxmlformats.org/officeDocument/2006/relationships" xmlns:a="http://schemas.openxmlformats.org/drawingml/2006/main" r:embed="Ref7fd98110634d52"/>
           <a:stretch xmlns:a="http://schemas.openxmlformats.org/drawingml/2006/main"/>
         </p:blipFill>
         <p:spPr>
@@ -7379,7 +7719,7 @@
     </p:spTree>
     <p:extLst>
       <p:ext uri="{BB962C8B-B14F-4D97-AF65-F5344CB8AC3E}">
-        <p14:creationId xmlns:p14="http://schemas.microsoft.com/office/powerpoint/2010/main" val="1735911788"/>
+        <p14:creationId xmlns:p14="http://schemas.microsoft.com/office/powerpoint/2010/main" val="67777300"/>
       </p:ext>
     </p:extLst>
   </p:cSld>
@@ -7407,7 +7747,7 @@
           <p:nvPr/>
         </p:nvPicPr>
         <p:blipFill>
-          <a:blip xmlns:r="http://schemas.openxmlformats.org/officeDocument/2006/relationships" xmlns:a="http://schemas.openxmlformats.org/drawingml/2006/main" r:embed="R2d9f055fb42a4a29"/>
+          <a:blip xmlns:r="http://schemas.openxmlformats.org/officeDocument/2006/relationships" xmlns:a="http://schemas.openxmlformats.org/drawingml/2006/main" r:embed="R8a6d49d8c90947f4"/>
           <a:stretch xmlns:a="http://schemas.openxmlformats.org/drawingml/2006/main"/>
         </p:blipFill>
         <p:spPr>
@@ -7423,7 +7763,7 @@
     </p:spTree>
     <p:extLst>
       <p:ext uri="{BB962C8B-B14F-4D97-AF65-F5344CB8AC3E}">
-        <p14:creationId xmlns:p14="http://schemas.microsoft.com/office/powerpoint/2010/main" val="187971730"/>
+        <p14:creationId xmlns:p14="http://schemas.microsoft.com/office/powerpoint/2010/main" val="585393877"/>
       </p:ext>
     </p:extLst>
   </p:cSld>
@@ -7451,7 +7791,7 @@
           <p:nvPr/>
         </p:nvPicPr>
         <p:blipFill>
-          <a:blip xmlns:r="http://schemas.openxmlformats.org/officeDocument/2006/relationships" xmlns:a="http://schemas.openxmlformats.org/drawingml/2006/main" r:embed="Ra308f8f342bc476d"/>
+          <a:blip xmlns:r="http://schemas.openxmlformats.org/officeDocument/2006/relationships" xmlns:a="http://schemas.openxmlformats.org/drawingml/2006/main" r:embed="Rd34085bea2de4690"/>
           <a:stretch xmlns:a="http://schemas.openxmlformats.org/drawingml/2006/main"/>
         </p:blipFill>
         <p:spPr>
@@ -7467,7 +7807,7 @@
     </p:spTree>
     <p:extLst>
       <p:ext uri="{BB962C8B-B14F-4D97-AF65-F5344CB8AC3E}">
-        <p14:creationId xmlns:p14="http://schemas.microsoft.com/office/powerpoint/2010/main" val="1157871953"/>
+        <p14:creationId xmlns:p14="http://schemas.microsoft.com/office/powerpoint/2010/main" val="1236570334"/>
       </p:ext>
     </p:extLst>
   </p:cSld>
@@ -7495,7 +7835,7 @@
           <p:nvPr/>
         </p:nvPicPr>
         <p:blipFill>
-          <a:blip xmlns:r="http://schemas.openxmlformats.org/officeDocument/2006/relationships" xmlns:a="http://schemas.openxmlformats.org/drawingml/2006/main" r:embed="R69b3fc8c8bd94da9"/>
+          <a:blip xmlns:r="http://schemas.openxmlformats.org/officeDocument/2006/relationships" xmlns:a="http://schemas.openxmlformats.org/drawingml/2006/main" r:embed="R0c810852380548fc"/>
           <a:stretch xmlns:a="http://schemas.openxmlformats.org/drawingml/2006/main"/>
         </p:blipFill>
         <p:spPr>
@@ -7511,7 +7851,7 @@
     </p:spTree>
     <p:extLst>
       <p:ext uri="{BB962C8B-B14F-4D97-AF65-F5344CB8AC3E}">
-        <p14:creationId xmlns:p14="http://schemas.microsoft.com/office/powerpoint/2010/main" val="1853835839"/>
+        <p14:creationId xmlns:p14="http://schemas.microsoft.com/office/powerpoint/2010/main" val="789634696"/>
       </p:ext>
     </p:extLst>
   </p:cSld>
@@ -7539,7 +7879,7 @@
           <p:nvPr/>
         </p:nvPicPr>
         <p:blipFill>
-          <a:blip xmlns:r="http://schemas.openxmlformats.org/officeDocument/2006/relationships" xmlns:a="http://schemas.openxmlformats.org/drawingml/2006/main" r:embed="Redc182f264314ce5"/>
+          <a:blip xmlns:r="http://schemas.openxmlformats.org/officeDocument/2006/relationships" xmlns:a="http://schemas.openxmlformats.org/drawingml/2006/main" r:embed="Rc357f19621274d91"/>
           <a:stretch xmlns:a="http://schemas.openxmlformats.org/drawingml/2006/main"/>
         </p:blipFill>
         <p:spPr>
@@ -7555,7 +7895,7 @@
     </p:spTree>
     <p:extLst>
       <p:ext uri="{BB962C8B-B14F-4D97-AF65-F5344CB8AC3E}">
-        <p14:creationId xmlns:p14="http://schemas.microsoft.com/office/powerpoint/2010/main" val="700903429"/>
+        <p14:creationId xmlns:p14="http://schemas.microsoft.com/office/powerpoint/2010/main" val="1557802612"/>
       </p:ext>
     </p:extLst>
   </p:cSld>
@@ -7583,7 +7923,7 @@
           <p:nvPr/>
         </p:nvPicPr>
         <p:blipFill>
-          <a:blip xmlns:r="http://schemas.openxmlformats.org/officeDocument/2006/relationships" xmlns:a="http://schemas.openxmlformats.org/drawingml/2006/main" r:embed="R1fe37e31399345c8"/>
+          <a:blip xmlns:r="http://schemas.openxmlformats.org/officeDocument/2006/relationships" xmlns:a="http://schemas.openxmlformats.org/drawingml/2006/main" r:embed="R1d22b1eb200149df"/>
           <a:stretch xmlns:a="http://schemas.openxmlformats.org/drawingml/2006/main"/>
         </p:blipFill>
         <p:spPr>
@@ -7599,7 +7939,7 @@
     </p:spTree>
     <p:extLst>
       <p:ext uri="{BB962C8B-B14F-4D97-AF65-F5344CB8AC3E}">
-        <p14:creationId xmlns:p14="http://schemas.microsoft.com/office/powerpoint/2010/main" val="2032302460"/>
+        <p14:creationId xmlns:p14="http://schemas.microsoft.com/office/powerpoint/2010/main" val="1997111560"/>
       </p:ext>
     </p:extLst>
   </p:cSld>

</xml_diff>

<commit_message>
Direct further reading to Talis across all five lectures
</commit_message>
<xml_diff>
--- a/teaching/macro-applications/downloads/lecture_2.pptx
+++ b/teaching/macro-applications/downloads/lecture_2.pptx
@@ -2,38 +2,38 @@
 <file path=ppt/presentation.xml><?xml version="1.0" encoding="utf-8"?>
 <p:presentation xmlns:p="http://schemas.openxmlformats.org/presentationml/2006/main">
   <p:sldMasterIdLst>
-    <p:sldMasterId xmlns:r="http://schemas.openxmlformats.org/officeDocument/2006/relationships" id="2147483648" r:id="R8e95411e8c8946be"/>
+    <p:sldMasterId xmlns:r="http://schemas.openxmlformats.org/officeDocument/2006/relationships" id="2147483648" r:id="R453e26a52f334d2b"/>
   </p:sldMasterIdLst>
   <p:notesMasterIdLst>
-    <p:notesMasterId xmlns:r="http://schemas.openxmlformats.org/officeDocument/2006/relationships" r:id="R83259020f2314950"/>
+    <p:notesMasterId xmlns:r="http://schemas.openxmlformats.org/officeDocument/2006/relationships" r:id="Rd0c6cea852f44f64"/>
   </p:notesMasterIdLst>
   <p:sldIdLst>
-    <p:sldId xmlns:r="http://schemas.openxmlformats.org/officeDocument/2006/relationships" id="256" r:id="R6a6a4b0d9e384c56"/>
-    <p:sldId xmlns:r="http://schemas.openxmlformats.org/officeDocument/2006/relationships" id="257" r:id="R13576ef886dc4ffc"/>
-    <p:sldId xmlns:r="http://schemas.openxmlformats.org/officeDocument/2006/relationships" id="258" r:id="R973a93a991dc4cb4"/>
-    <p:sldId xmlns:r="http://schemas.openxmlformats.org/officeDocument/2006/relationships" id="259" r:id="R978800d8979245ff"/>
-    <p:sldId xmlns:r="http://schemas.openxmlformats.org/officeDocument/2006/relationships" id="260" r:id="Rf39b7c181a254e68"/>
-    <p:sldId xmlns:r="http://schemas.openxmlformats.org/officeDocument/2006/relationships" id="261" r:id="Rc89a31ca18ca427b"/>
-    <p:sldId xmlns:r="http://schemas.openxmlformats.org/officeDocument/2006/relationships" id="262" r:id="Raabadbfefa8243dc"/>
-    <p:sldId xmlns:r="http://schemas.openxmlformats.org/officeDocument/2006/relationships" id="263" r:id="R4f6888ddf81842a4"/>
-    <p:sldId xmlns:r="http://schemas.openxmlformats.org/officeDocument/2006/relationships" id="264" r:id="R5b2bf34dd81d43c7"/>
-    <p:sldId xmlns:r="http://schemas.openxmlformats.org/officeDocument/2006/relationships" id="265" r:id="R01d61b30340841ec"/>
-    <p:sldId xmlns:r="http://schemas.openxmlformats.org/officeDocument/2006/relationships" id="266" r:id="Rf7af2b244a864936"/>
-    <p:sldId xmlns:r="http://schemas.openxmlformats.org/officeDocument/2006/relationships" id="267" r:id="R5f204b6078fb478b"/>
-    <p:sldId xmlns:r="http://schemas.openxmlformats.org/officeDocument/2006/relationships" id="268" r:id="Re25c0ac2fa1b4e04"/>
-    <p:sldId xmlns:r="http://schemas.openxmlformats.org/officeDocument/2006/relationships" id="269" r:id="R0645fa70f07845e6"/>
-    <p:sldId xmlns:r="http://schemas.openxmlformats.org/officeDocument/2006/relationships" id="270" r:id="R962f614f1b6b4ba2"/>
-    <p:sldId xmlns:r="http://schemas.openxmlformats.org/officeDocument/2006/relationships" id="271" r:id="R722defbb311e4021"/>
-    <p:sldId xmlns:r="http://schemas.openxmlformats.org/officeDocument/2006/relationships" id="272" r:id="R1362a3cb7cce4996"/>
-    <p:sldId xmlns:r="http://schemas.openxmlformats.org/officeDocument/2006/relationships" id="273" r:id="R0c9def19cbcc412d"/>
-    <p:sldId xmlns:r="http://schemas.openxmlformats.org/officeDocument/2006/relationships" id="274" r:id="R40361c60d8d846ba"/>
-    <p:sldId xmlns:r="http://schemas.openxmlformats.org/officeDocument/2006/relationships" id="275" r:id="Ra0cc7b1eb6ce4263"/>
-    <p:sldId xmlns:r="http://schemas.openxmlformats.org/officeDocument/2006/relationships" id="276" r:id="R93d4a68325a14875"/>
-    <p:sldId xmlns:r="http://schemas.openxmlformats.org/officeDocument/2006/relationships" id="277" r:id="R8eed4e5ed2bd4974"/>
-    <p:sldId xmlns:r="http://schemas.openxmlformats.org/officeDocument/2006/relationships" id="278" r:id="R903a7b0c1fe54652"/>
-    <p:sldId xmlns:r="http://schemas.openxmlformats.org/officeDocument/2006/relationships" id="279" r:id="R5b1ae799408b4457"/>
-    <p:sldId xmlns:r="http://schemas.openxmlformats.org/officeDocument/2006/relationships" id="280" r:id="Reb2ac1070c4045b0"/>
-    <p:sldId xmlns:r="http://schemas.openxmlformats.org/officeDocument/2006/relationships" id="281" r:id="Re875279b001e4772"/>
+    <p:sldId xmlns:r="http://schemas.openxmlformats.org/officeDocument/2006/relationships" id="256" r:id="R519553fee49c4be0"/>
+    <p:sldId xmlns:r="http://schemas.openxmlformats.org/officeDocument/2006/relationships" id="257" r:id="Rd657c15d40154a0e"/>
+    <p:sldId xmlns:r="http://schemas.openxmlformats.org/officeDocument/2006/relationships" id="258" r:id="R0eca076c0e454686"/>
+    <p:sldId xmlns:r="http://schemas.openxmlformats.org/officeDocument/2006/relationships" id="259" r:id="R3144ab5418a6432c"/>
+    <p:sldId xmlns:r="http://schemas.openxmlformats.org/officeDocument/2006/relationships" id="260" r:id="R0adea9a930244c8c"/>
+    <p:sldId xmlns:r="http://schemas.openxmlformats.org/officeDocument/2006/relationships" id="261" r:id="Rcb2f6ce514da4a22"/>
+    <p:sldId xmlns:r="http://schemas.openxmlformats.org/officeDocument/2006/relationships" id="262" r:id="R584a342259304eb9"/>
+    <p:sldId xmlns:r="http://schemas.openxmlformats.org/officeDocument/2006/relationships" id="263" r:id="R47d99fe174774532"/>
+    <p:sldId xmlns:r="http://schemas.openxmlformats.org/officeDocument/2006/relationships" id="264" r:id="Rb71a1a2fbac347c1"/>
+    <p:sldId xmlns:r="http://schemas.openxmlformats.org/officeDocument/2006/relationships" id="265" r:id="R0ba0c57902564850"/>
+    <p:sldId xmlns:r="http://schemas.openxmlformats.org/officeDocument/2006/relationships" id="266" r:id="Rdea12cc099614653"/>
+    <p:sldId xmlns:r="http://schemas.openxmlformats.org/officeDocument/2006/relationships" id="267" r:id="Rb4adb5f57b2a4ea2"/>
+    <p:sldId xmlns:r="http://schemas.openxmlformats.org/officeDocument/2006/relationships" id="268" r:id="R3c3792cc88564ad3"/>
+    <p:sldId xmlns:r="http://schemas.openxmlformats.org/officeDocument/2006/relationships" id="269" r:id="Re20c1f83c9554ab7"/>
+    <p:sldId xmlns:r="http://schemas.openxmlformats.org/officeDocument/2006/relationships" id="270" r:id="R4b3c0e7180c04817"/>
+    <p:sldId xmlns:r="http://schemas.openxmlformats.org/officeDocument/2006/relationships" id="271" r:id="Rbcc462873a754eac"/>
+    <p:sldId xmlns:r="http://schemas.openxmlformats.org/officeDocument/2006/relationships" id="272" r:id="Refc9f3219de644d4"/>
+    <p:sldId xmlns:r="http://schemas.openxmlformats.org/officeDocument/2006/relationships" id="273" r:id="R40fcf9a8bb694f48"/>
+    <p:sldId xmlns:r="http://schemas.openxmlformats.org/officeDocument/2006/relationships" id="274" r:id="R61644737c5f345ae"/>
+    <p:sldId xmlns:r="http://schemas.openxmlformats.org/officeDocument/2006/relationships" id="275" r:id="R7d287ba32d7144b5"/>
+    <p:sldId xmlns:r="http://schemas.openxmlformats.org/officeDocument/2006/relationships" id="276" r:id="R7ee63f46806c477f"/>
+    <p:sldId xmlns:r="http://schemas.openxmlformats.org/officeDocument/2006/relationships" id="277" r:id="Rfd9d873ed318438c"/>
+    <p:sldId xmlns:r="http://schemas.openxmlformats.org/officeDocument/2006/relationships" id="278" r:id="Re0b09798dd6d4577"/>
+    <p:sldId xmlns:r="http://schemas.openxmlformats.org/officeDocument/2006/relationships" id="279" r:id="R98b48bebf576461d"/>
+    <p:sldId xmlns:r="http://schemas.openxmlformats.org/officeDocument/2006/relationships" id="280" r:id="Rdec87e76c8cb4335"/>
+    <p:sldId xmlns:r="http://schemas.openxmlformats.org/officeDocument/2006/relationships" id="281" r:id="Rf52caec7054f4e49"/>
   </p:sldIdLst>
   <p:sldSz cx="12192000" cy="6858000"/>
   <p:notesSz cx="6858000" cy="9144000"/>
@@ -4582,52 +4582,42 @@
           </a:p>
           <a:p xmlns:a="http://schemas.openxmlformats.org/drawingml/2006/main">
             <a:r>
-              <a:t>Baldwin R., Venables A. (1995), Regional Economic Integration, Handbook of International Economics, Chapter 31.</a:t>
-            </a:r>
-          </a:p>
-          <a:p xmlns:a="http://schemas.openxmlformats.org/drawingml/2006/main">
-            <a:r>
-              <a:t>Lee J.-W., Swagel P. (1997), Trade Barriers and Trade Flows Across Countries and Industries, Review of Economics and Statistics, 79 (3), pp. 372-382.</a:t>
-            </a:r>
-          </a:p>
-          <a:p xmlns:a="http://schemas.openxmlformats.org/drawingml/2006/main">
-            <a:r>
-              <a:t>Miller M., Spencer J.E. (1977), The Static Economic Effects of the UK Joining the EEC: A General Equilibrium Approach, Review of Economic Studies, 44 (1), 71-93.</a:t>
-            </a:r>
-          </a:p>
-          <a:p xmlns:a="http://schemas.openxmlformats.org/drawingml/2006/main">
-            <a:r>
-              <a:t>Winters L.A. (1987), Britain in Europe: a Survey of Quantitative Trade Studies, Journal of Common Market Studies, XXV (4), 315-335.</a:t>
-            </a:r>
-          </a:p>
-          <a:p xmlns:a="http://schemas.openxmlformats.org/drawingml/2006/main">
-            <a:r>
-              <a:t/>
-            </a:r>
-          </a:p>
-          <a:p xmlns:a="http://schemas.openxmlformats.org/drawingml/2006/main">
-            <a:r>
-              <a:t/>
-            </a:r>
-          </a:p>
-          <a:p xmlns:a="http://schemas.openxmlformats.org/drawingml/2006/main">
-            <a:r>
-              <a:t/>
-            </a:r>
-          </a:p>
-          <a:p xmlns:a="http://schemas.openxmlformats.org/drawingml/2006/main">
-            <a:r>
-              <a:t>EEC: European Economic Community</a:t>
-            </a:r>
-          </a:p>
-          <a:p xmlns:a="http://schemas.openxmlformats.org/drawingml/2006/main">
-            <a:r>
-              <a:t/>
-            </a:r>
-          </a:p>
-          <a:p xmlns:a="http://schemas.openxmlformats.org/drawingml/2006/main">
-            <a:r>
-              <a:t/>
+              <a:t/>
+            </a:r>
+          </a:p>
+          <a:p xmlns:a="http://schemas.openxmlformats.org/drawingml/2006/main">
+            <a:r>
+              <a:t>See the ECON2271 Talis reading list, also available through Blackboard.</a:t>
+            </a:r>
+          </a:p>
+          <a:p xmlns:a="http://schemas.openxmlformats.org/drawingml/2006/main">
+            <a:r>
+              <a:t/>
+            </a:r>
+          </a:p>
+          <a:p xmlns:a="http://schemas.openxmlformats.org/drawingml/2006/main">
+            <a:r>
+              <a:t/>
+            </a:r>
+          </a:p>
+          <a:p xmlns:a="http://schemas.openxmlformats.org/drawingml/2006/main">
+            <a:r>
+              <a:t/>
+            </a:r>
+          </a:p>
+          <a:p xmlns:a="http://schemas.openxmlformats.org/drawingml/2006/main">
+            <a:r>
+              <a:t/>
+            </a:r>
+          </a:p>
+          <a:p xmlns:a="http://schemas.openxmlformats.org/drawingml/2006/main">
+            <a:r>
+              <a:t/>
+            </a:r>
+          </a:p>
+          <a:p xmlns:a="http://schemas.openxmlformats.org/drawingml/2006/main">
+            <a:r>
+              <a:t>https://durham.rl.talis.com/lists/d85d1ad3-e9ac-4daf-aa66-e3ddfcf902d7.html</a:t>
             </a:r>
           </a:p>
         </p:txBody>
@@ -6275,7 +6265,7 @@
   </p:cSld>
   <p:clrMap bg1="lt1" tx1="dk1" bg2="lt2" tx2="dk2" accent1="accent1" accent2="accent2" accent3="accent3" accent4="accent4" accent5="accent5" accent6="accent6" hlink="hlink" folHlink="folHlink"/>
   <p:sldLayoutIdLst>
-    <p:sldLayoutId xmlns:r="http://schemas.openxmlformats.org/officeDocument/2006/relationships" id="2147483649" r:id="R343d1a3e7ea345e7"/>
+    <p:sldLayoutId xmlns:r="http://schemas.openxmlformats.org/officeDocument/2006/relationships" id="2147483649" r:id="R7b7a8260116a4954"/>
   </p:sldLayoutIdLst>
   <p:txStyles>
     <p:titleStyle>
@@ -6823,7 +6813,7 @@
           <p:nvPr/>
         </p:nvPicPr>
         <p:blipFill>
-          <a:blip xmlns:r="http://schemas.openxmlformats.org/officeDocument/2006/relationships" xmlns:a="http://schemas.openxmlformats.org/drawingml/2006/main" r:embed="Rc98e3382a83b402d"/>
+          <a:blip xmlns:r="http://schemas.openxmlformats.org/officeDocument/2006/relationships" xmlns:a="http://schemas.openxmlformats.org/drawingml/2006/main" r:embed="R797a325c41c74f87"/>
           <a:stretch xmlns:a="http://schemas.openxmlformats.org/drawingml/2006/main"/>
         </p:blipFill>
         <p:spPr>
@@ -6839,7 +6829,7 @@
     </p:spTree>
     <p:extLst>
       <p:ext uri="{BB962C8B-B14F-4D97-AF65-F5344CB8AC3E}">
-        <p14:creationId xmlns:p14="http://schemas.microsoft.com/office/powerpoint/2010/main" val="1634345264"/>
+        <p14:creationId xmlns:p14="http://schemas.microsoft.com/office/powerpoint/2010/main" val="340658360"/>
       </p:ext>
     </p:extLst>
   </p:cSld>
@@ -6867,7 +6857,7 @@
           <p:nvPr/>
         </p:nvPicPr>
         <p:blipFill>
-          <a:blip xmlns:r="http://schemas.openxmlformats.org/officeDocument/2006/relationships" xmlns:a="http://schemas.openxmlformats.org/drawingml/2006/main" r:embed="Rc2ced3d278e9458f"/>
+          <a:blip xmlns:r="http://schemas.openxmlformats.org/officeDocument/2006/relationships" xmlns:a="http://schemas.openxmlformats.org/drawingml/2006/main" r:embed="Rbdd1376972ba4116"/>
           <a:stretch xmlns:a="http://schemas.openxmlformats.org/drawingml/2006/main"/>
         </p:blipFill>
         <p:spPr>
@@ -6883,7 +6873,7 @@
     </p:spTree>
     <p:extLst>
       <p:ext uri="{BB962C8B-B14F-4D97-AF65-F5344CB8AC3E}">
-        <p14:creationId xmlns:p14="http://schemas.microsoft.com/office/powerpoint/2010/main" val="1830212492"/>
+        <p14:creationId xmlns:p14="http://schemas.microsoft.com/office/powerpoint/2010/main" val="1336080504"/>
       </p:ext>
     </p:extLst>
   </p:cSld>
@@ -6911,7 +6901,7 @@
           <p:nvPr/>
         </p:nvPicPr>
         <p:blipFill>
-          <a:blip xmlns:r="http://schemas.openxmlformats.org/officeDocument/2006/relationships" xmlns:a="http://schemas.openxmlformats.org/drawingml/2006/main" r:embed="R38a115bf15ac4c83"/>
+          <a:blip xmlns:r="http://schemas.openxmlformats.org/officeDocument/2006/relationships" xmlns:a="http://schemas.openxmlformats.org/drawingml/2006/main" r:embed="R179aa1f450914fc4"/>
           <a:stretch xmlns:a="http://schemas.openxmlformats.org/drawingml/2006/main"/>
         </p:blipFill>
         <p:spPr>
@@ -6927,7 +6917,7 @@
     </p:spTree>
     <p:extLst>
       <p:ext uri="{BB962C8B-B14F-4D97-AF65-F5344CB8AC3E}">
-        <p14:creationId xmlns:p14="http://schemas.microsoft.com/office/powerpoint/2010/main" val="2010169562"/>
+        <p14:creationId xmlns:p14="http://schemas.microsoft.com/office/powerpoint/2010/main" val="357468810"/>
       </p:ext>
     </p:extLst>
   </p:cSld>
@@ -6955,7 +6945,7 @@
           <p:nvPr/>
         </p:nvPicPr>
         <p:blipFill>
-          <a:blip xmlns:r="http://schemas.openxmlformats.org/officeDocument/2006/relationships" xmlns:a="http://schemas.openxmlformats.org/drawingml/2006/main" r:embed="Ree6785dd71d049e5"/>
+          <a:blip xmlns:r="http://schemas.openxmlformats.org/officeDocument/2006/relationships" xmlns:a="http://schemas.openxmlformats.org/drawingml/2006/main" r:embed="Ra2f1a3d85c3d4ca4"/>
           <a:stretch xmlns:a="http://schemas.openxmlformats.org/drawingml/2006/main"/>
         </p:blipFill>
         <p:spPr>
@@ -6971,7 +6961,7 @@
     </p:spTree>
     <p:extLst>
       <p:ext uri="{BB962C8B-B14F-4D97-AF65-F5344CB8AC3E}">
-        <p14:creationId xmlns:p14="http://schemas.microsoft.com/office/powerpoint/2010/main" val="958069319"/>
+        <p14:creationId xmlns:p14="http://schemas.microsoft.com/office/powerpoint/2010/main" val="606747645"/>
       </p:ext>
     </p:extLst>
   </p:cSld>
@@ -6999,7 +6989,7 @@
           <p:nvPr/>
         </p:nvPicPr>
         <p:blipFill>
-          <a:blip xmlns:r="http://schemas.openxmlformats.org/officeDocument/2006/relationships" xmlns:a="http://schemas.openxmlformats.org/drawingml/2006/main" r:embed="R899dd9153bbb4ae9"/>
+          <a:blip xmlns:r="http://schemas.openxmlformats.org/officeDocument/2006/relationships" xmlns:a="http://schemas.openxmlformats.org/drawingml/2006/main" r:embed="Ra3ba702402e84ea4"/>
           <a:stretch xmlns:a="http://schemas.openxmlformats.org/drawingml/2006/main"/>
         </p:blipFill>
         <p:spPr>
@@ -7015,7 +7005,7 @@
     </p:spTree>
     <p:extLst>
       <p:ext uri="{BB962C8B-B14F-4D97-AF65-F5344CB8AC3E}">
-        <p14:creationId xmlns:p14="http://schemas.microsoft.com/office/powerpoint/2010/main" val="1858577471"/>
+        <p14:creationId xmlns:p14="http://schemas.microsoft.com/office/powerpoint/2010/main" val="2029585042"/>
       </p:ext>
     </p:extLst>
   </p:cSld>
@@ -7043,7 +7033,7 @@
           <p:nvPr/>
         </p:nvPicPr>
         <p:blipFill>
-          <a:blip xmlns:r="http://schemas.openxmlformats.org/officeDocument/2006/relationships" xmlns:a="http://schemas.openxmlformats.org/drawingml/2006/main" r:embed="Rf7263de55b5b4e25"/>
+          <a:blip xmlns:r="http://schemas.openxmlformats.org/officeDocument/2006/relationships" xmlns:a="http://schemas.openxmlformats.org/drawingml/2006/main" r:embed="R2d9d5eeaba4344de"/>
           <a:stretch xmlns:a="http://schemas.openxmlformats.org/drawingml/2006/main"/>
         </p:blipFill>
         <p:spPr>
@@ -7059,7 +7049,7 @@
     </p:spTree>
     <p:extLst>
       <p:ext uri="{BB962C8B-B14F-4D97-AF65-F5344CB8AC3E}">
-        <p14:creationId xmlns:p14="http://schemas.microsoft.com/office/powerpoint/2010/main" val="1403781128"/>
+        <p14:creationId xmlns:p14="http://schemas.microsoft.com/office/powerpoint/2010/main" val="1209744937"/>
       </p:ext>
     </p:extLst>
   </p:cSld>
@@ -7087,7 +7077,7 @@
           <p:nvPr/>
         </p:nvPicPr>
         <p:blipFill>
-          <a:blip xmlns:r="http://schemas.openxmlformats.org/officeDocument/2006/relationships" xmlns:a="http://schemas.openxmlformats.org/drawingml/2006/main" r:embed="R73257d43e4bf42de"/>
+          <a:blip xmlns:r="http://schemas.openxmlformats.org/officeDocument/2006/relationships" xmlns:a="http://schemas.openxmlformats.org/drawingml/2006/main" r:embed="R940b94ec2d694e34"/>
           <a:stretch xmlns:a="http://schemas.openxmlformats.org/drawingml/2006/main"/>
         </p:blipFill>
         <p:spPr>
@@ -7103,7 +7093,7 @@
     </p:spTree>
     <p:extLst>
       <p:ext uri="{BB962C8B-B14F-4D97-AF65-F5344CB8AC3E}">
-        <p14:creationId xmlns:p14="http://schemas.microsoft.com/office/powerpoint/2010/main" val="1449176277"/>
+        <p14:creationId xmlns:p14="http://schemas.microsoft.com/office/powerpoint/2010/main" val="1051940636"/>
       </p:ext>
     </p:extLst>
   </p:cSld>
@@ -7131,7 +7121,7 @@
           <p:nvPr/>
         </p:nvPicPr>
         <p:blipFill>
-          <a:blip xmlns:r="http://schemas.openxmlformats.org/officeDocument/2006/relationships" xmlns:a="http://schemas.openxmlformats.org/drawingml/2006/main" r:embed="Re49d5bdf395744a2"/>
+          <a:blip xmlns:r="http://schemas.openxmlformats.org/officeDocument/2006/relationships" xmlns:a="http://schemas.openxmlformats.org/drawingml/2006/main" r:embed="R098b8758886a49b0"/>
           <a:stretch xmlns:a="http://schemas.openxmlformats.org/drawingml/2006/main"/>
         </p:blipFill>
         <p:spPr>
@@ -7147,7 +7137,7 @@
     </p:spTree>
     <p:extLst>
       <p:ext uri="{BB962C8B-B14F-4D97-AF65-F5344CB8AC3E}">
-        <p14:creationId xmlns:p14="http://schemas.microsoft.com/office/powerpoint/2010/main" val="135114811"/>
+        <p14:creationId xmlns:p14="http://schemas.microsoft.com/office/powerpoint/2010/main" val="471112149"/>
       </p:ext>
     </p:extLst>
   </p:cSld>
@@ -7175,7 +7165,7 @@
           <p:nvPr/>
         </p:nvPicPr>
         <p:blipFill>
-          <a:blip xmlns:r="http://schemas.openxmlformats.org/officeDocument/2006/relationships" xmlns:a="http://schemas.openxmlformats.org/drawingml/2006/main" r:embed="R5ac2dee5168e43b7"/>
+          <a:blip xmlns:r="http://schemas.openxmlformats.org/officeDocument/2006/relationships" xmlns:a="http://schemas.openxmlformats.org/drawingml/2006/main" r:embed="Rf6a7aca8ebab4c5f"/>
           <a:stretch xmlns:a="http://schemas.openxmlformats.org/drawingml/2006/main"/>
         </p:blipFill>
         <p:spPr>
@@ -7191,7 +7181,7 @@
     </p:spTree>
     <p:extLst>
       <p:ext uri="{BB962C8B-B14F-4D97-AF65-F5344CB8AC3E}">
-        <p14:creationId xmlns:p14="http://schemas.microsoft.com/office/powerpoint/2010/main" val="392639251"/>
+        <p14:creationId xmlns:p14="http://schemas.microsoft.com/office/powerpoint/2010/main" val="1748128660"/>
       </p:ext>
     </p:extLst>
   </p:cSld>
@@ -7219,7 +7209,7 @@
           <p:nvPr/>
         </p:nvPicPr>
         <p:blipFill>
-          <a:blip xmlns:r="http://schemas.openxmlformats.org/officeDocument/2006/relationships" xmlns:a="http://schemas.openxmlformats.org/drawingml/2006/main" r:embed="R451cdc1263804609"/>
+          <a:blip xmlns:r="http://schemas.openxmlformats.org/officeDocument/2006/relationships" xmlns:a="http://schemas.openxmlformats.org/drawingml/2006/main" r:embed="Rd46b46024fcc4c0a"/>
           <a:stretch xmlns:a="http://schemas.openxmlformats.org/drawingml/2006/main"/>
         </p:blipFill>
         <p:spPr>
@@ -7235,7 +7225,7 @@
     </p:spTree>
     <p:extLst>
       <p:ext uri="{BB962C8B-B14F-4D97-AF65-F5344CB8AC3E}">
-        <p14:creationId xmlns:p14="http://schemas.microsoft.com/office/powerpoint/2010/main" val="248294691"/>
+        <p14:creationId xmlns:p14="http://schemas.microsoft.com/office/powerpoint/2010/main" val="348819393"/>
       </p:ext>
     </p:extLst>
   </p:cSld>
@@ -7263,7 +7253,7 @@
           <p:nvPr/>
         </p:nvPicPr>
         <p:blipFill>
-          <a:blip xmlns:r="http://schemas.openxmlformats.org/officeDocument/2006/relationships" xmlns:a="http://schemas.openxmlformats.org/drawingml/2006/main" r:embed="Rb127233016574cbf"/>
+          <a:blip xmlns:r="http://schemas.openxmlformats.org/officeDocument/2006/relationships" xmlns:a="http://schemas.openxmlformats.org/drawingml/2006/main" r:embed="R789d51eb6b054626"/>
           <a:stretch xmlns:a="http://schemas.openxmlformats.org/drawingml/2006/main"/>
         </p:blipFill>
         <p:spPr>
@@ -7279,7 +7269,7 @@
     </p:spTree>
     <p:extLst>
       <p:ext uri="{BB962C8B-B14F-4D97-AF65-F5344CB8AC3E}">
-        <p14:creationId xmlns:p14="http://schemas.microsoft.com/office/powerpoint/2010/main" val="1527583364"/>
+        <p14:creationId xmlns:p14="http://schemas.microsoft.com/office/powerpoint/2010/main" val="1615145784"/>
       </p:ext>
     </p:extLst>
   </p:cSld>
@@ -7307,7 +7297,7 @@
           <p:nvPr/>
         </p:nvPicPr>
         <p:blipFill>
-          <a:blip xmlns:r="http://schemas.openxmlformats.org/officeDocument/2006/relationships" xmlns:a="http://schemas.openxmlformats.org/drawingml/2006/main" r:embed="R233012deee424d07"/>
+          <a:blip xmlns:r="http://schemas.openxmlformats.org/officeDocument/2006/relationships" xmlns:a="http://schemas.openxmlformats.org/drawingml/2006/main" r:embed="R450105fc078b420c"/>
           <a:stretch xmlns:a="http://schemas.openxmlformats.org/drawingml/2006/main"/>
         </p:blipFill>
         <p:spPr>
@@ -7323,7 +7313,7 @@
     </p:spTree>
     <p:extLst>
       <p:ext uri="{BB962C8B-B14F-4D97-AF65-F5344CB8AC3E}">
-        <p14:creationId xmlns:p14="http://schemas.microsoft.com/office/powerpoint/2010/main" val="1112977644"/>
+        <p14:creationId xmlns:p14="http://schemas.microsoft.com/office/powerpoint/2010/main" val="820269702"/>
       </p:ext>
     </p:extLst>
   </p:cSld>
@@ -7351,7 +7341,7 @@
           <p:nvPr/>
         </p:nvPicPr>
         <p:blipFill>
-          <a:blip xmlns:r="http://schemas.openxmlformats.org/officeDocument/2006/relationships" xmlns:a="http://schemas.openxmlformats.org/drawingml/2006/main" r:embed="R9db28850d943462a"/>
+          <a:blip xmlns:r="http://schemas.openxmlformats.org/officeDocument/2006/relationships" xmlns:a="http://schemas.openxmlformats.org/drawingml/2006/main" r:embed="R5632bfc8c36a4c10"/>
           <a:stretch xmlns:a="http://schemas.openxmlformats.org/drawingml/2006/main"/>
         </p:blipFill>
         <p:spPr>
@@ -7367,7 +7357,7 @@
     </p:spTree>
     <p:extLst>
       <p:ext uri="{BB962C8B-B14F-4D97-AF65-F5344CB8AC3E}">
-        <p14:creationId xmlns:p14="http://schemas.microsoft.com/office/powerpoint/2010/main" val="952509145"/>
+        <p14:creationId xmlns:p14="http://schemas.microsoft.com/office/powerpoint/2010/main" val="890406018"/>
       </p:ext>
     </p:extLst>
   </p:cSld>
@@ -7395,7 +7385,7 @@
           <p:nvPr/>
         </p:nvPicPr>
         <p:blipFill>
-          <a:blip xmlns:r="http://schemas.openxmlformats.org/officeDocument/2006/relationships" xmlns:a="http://schemas.openxmlformats.org/drawingml/2006/main" r:embed="R2a50b0d956dd422a"/>
+          <a:blip xmlns:r="http://schemas.openxmlformats.org/officeDocument/2006/relationships" xmlns:a="http://schemas.openxmlformats.org/drawingml/2006/main" r:embed="R9448dc81c31040ad"/>
           <a:stretch xmlns:a="http://schemas.openxmlformats.org/drawingml/2006/main"/>
         </p:blipFill>
         <p:spPr>
@@ -7411,7 +7401,7 @@
     </p:spTree>
     <p:extLst>
       <p:ext uri="{BB962C8B-B14F-4D97-AF65-F5344CB8AC3E}">
-        <p14:creationId xmlns:p14="http://schemas.microsoft.com/office/powerpoint/2010/main" val="2129428281"/>
+        <p14:creationId xmlns:p14="http://schemas.microsoft.com/office/powerpoint/2010/main" val="330334605"/>
       </p:ext>
     </p:extLst>
   </p:cSld>
@@ -7439,7 +7429,7 @@
           <p:nvPr/>
         </p:nvPicPr>
         <p:blipFill>
-          <a:blip xmlns:r="http://schemas.openxmlformats.org/officeDocument/2006/relationships" xmlns:a="http://schemas.openxmlformats.org/drawingml/2006/main" r:embed="Ra299d60155e84210"/>
+          <a:blip xmlns:r="http://schemas.openxmlformats.org/officeDocument/2006/relationships" xmlns:a="http://schemas.openxmlformats.org/drawingml/2006/main" r:embed="Rb29067c306724c88"/>
           <a:stretch xmlns:a="http://schemas.openxmlformats.org/drawingml/2006/main"/>
         </p:blipFill>
         <p:spPr>
@@ -7455,7 +7445,7 @@
     </p:spTree>
     <p:extLst>
       <p:ext uri="{BB962C8B-B14F-4D97-AF65-F5344CB8AC3E}">
-        <p14:creationId xmlns:p14="http://schemas.microsoft.com/office/powerpoint/2010/main" val="437150392"/>
+        <p14:creationId xmlns:p14="http://schemas.microsoft.com/office/powerpoint/2010/main" val="724962842"/>
       </p:ext>
     </p:extLst>
   </p:cSld>
@@ -7483,7 +7473,7 @@
           <p:nvPr/>
         </p:nvPicPr>
         <p:blipFill>
-          <a:blip xmlns:r="http://schemas.openxmlformats.org/officeDocument/2006/relationships" xmlns:a="http://schemas.openxmlformats.org/drawingml/2006/main" r:embed="R4c70a9dff86744d2"/>
+          <a:blip xmlns:r="http://schemas.openxmlformats.org/officeDocument/2006/relationships" xmlns:a="http://schemas.openxmlformats.org/drawingml/2006/main" r:embed="R4177da53258c4b30"/>
           <a:stretch xmlns:a="http://schemas.openxmlformats.org/drawingml/2006/main"/>
         </p:blipFill>
         <p:spPr>
@@ -7499,7 +7489,7 @@
     </p:spTree>
     <p:extLst>
       <p:ext uri="{BB962C8B-B14F-4D97-AF65-F5344CB8AC3E}">
-        <p14:creationId xmlns:p14="http://schemas.microsoft.com/office/powerpoint/2010/main" val="1776491545"/>
+        <p14:creationId xmlns:p14="http://schemas.microsoft.com/office/powerpoint/2010/main" val="844552469"/>
       </p:ext>
     </p:extLst>
   </p:cSld>
@@ -7527,7 +7517,7 @@
           <p:nvPr/>
         </p:nvPicPr>
         <p:blipFill>
-          <a:blip xmlns:r="http://schemas.openxmlformats.org/officeDocument/2006/relationships" xmlns:a="http://schemas.openxmlformats.org/drawingml/2006/main" r:embed="Rc2691a5ab1a14fc5"/>
+          <a:blip xmlns:r="http://schemas.openxmlformats.org/officeDocument/2006/relationships" xmlns:a="http://schemas.openxmlformats.org/drawingml/2006/main" r:embed="R6b6d180942b2433b"/>
           <a:stretch xmlns:a="http://schemas.openxmlformats.org/drawingml/2006/main"/>
         </p:blipFill>
         <p:spPr>
@@ -7543,7 +7533,7 @@
     </p:spTree>
     <p:extLst>
       <p:ext uri="{BB962C8B-B14F-4D97-AF65-F5344CB8AC3E}">
-        <p14:creationId xmlns:p14="http://schemas.microsoft.com/office/powerpoint/2010/main" val="430741716"/>
+        <p14:creationId xmlns:p14="http://schemas.microsoft.com/office/powerpoint/2010/main" val="1516707461"/>
       </p:ext>
     </p:extLst>
   </p:cSld>
@@ -7571,7 +7561,7 @@
           <p:nvPr/>
         </p:nvPicPr>
         <p:blipFill>
-          <a:blip xmlns:r="http://schemas.openxmlformats.org/officeDocument/2006/relationships" xmlns:a="http://schemas.openxmlformats.org/drawingml/2006/main" r:embed="Re06fd06354ec4b01"/>
+          <a:blip xmlns:r="http://schemas.openxmlformats.org/officeDocument/2006/relationships" xmlns:a="http://schemas.openxmlformats.org/drawingml/2006/main" r:embed="Rf03985cdbf5b4448"/>
           <a:stretch xmlns:a="http://schemas.openxmlformats.org/drawingml/2006/main"/>
         </p:blipFill>
         <p:spPr>
@@ -7587,7 +7577,7 @@
     </p:spTree>
     <p:extLst>
       <p:ext uri="{BB962C8B-B14F-4D97-AF65-F5344CB8AC3E}">
-        <p14:creationId xmlns:p14="http://schemas.microsoft.com/office/powerpoint/2010/main" val="1456330828"/>
+        <p14:creationId xmlns:p14="http://schemas.microsoft.com/office/powerpoint/2010/main" val="134912192"/>
       </p:ext>
     </p:extLst>
   </p:cSld>
@@ -7615,7 +7605,7 @@
           <p:nvPr/>
         </p:nvPicPr>
         <p:blipFill>
-          <a:blip xmlns:r="http://schemas.openxmlformats.org/officeDocument/2006/relationships" xmlns:a="http://schemas.openxmlformats.org/drawingml/2006/main" r:embed="R859fa542a0f14924"/>
+          <a:blip xmlns:r="http://schemas.openxmlformats.org/officeDocument/2006/relationships" xmlns:a="http://schemas.openxmlformats.org/drawingml/2006/main" r:embed="R4d36abdbfc794a5d"/>
           <a:stretch xmlns:a="http://schemas.openxmlformats.org/drawingml/2006/main"/>
         </p:blipFill>
         <p:spPr>
@@ -7631,7 +7621,7 @@
     </p:spTree>
     <p:extLst>
       <p:ext uri="{BB962C8B-B14F-4D97-AF65-F5344CB8AC3E}">
-        <p14:creationId xmlns:p14="http://schemas.microsoft.com/office/powerpoint/2010/main" val="1494239276"/>
+        <p14:creationId xmlns:p14="http://schemas.microsoft.com/office/powerpoint/2010/main" val="106417832"/>
       </p:ext>
     </p:extLst>
   </p:cSld>
@@ -7659,7 +7649,7 @@
           <p:nvPr/>
         </p:nvPicPr>
         <p:blipFill>
-          <a:blip xmlns:r="http://schemas.openxmlformats.org/officeDocument/2006/relationships" xmlns:a="http://schemas.openxmlformats.org/drawingml/2006/main" r:embed="R991cc913cb434639"/>
+          <a:blip xmlns:r="http://schemas.openxmlformats.org/officeDocument/2006/relationships" xmlns:a="http://schemas.openxmlformats.org/drawingml/2006/main" r:embed="R883640cda8c34a34"/>
           <a:stretch xmlns:a="http://schemas.openxmlformats.org/drawingml/2006/main"/>
         </p:blipFill>
         <p:spPr>
@@ -7675,7 +7665,7 @@
     </p:spTree>
     <p:extLst>
       <p:ext uri="{BB962C8B-B14F-4D97-AF65-F5344CB8AC3E}">
-        <p14:creationId xmlns:p14="http://schemas.microsoft.com/office/powerpoint/2010/main" val="1277347037"/>
+        <p14:creationId xmlns:p14="http://schemas.microsoft.com/office/powerpoint/2010/main" val="1631685771"/>
       </p:ext>
     </p:extLst>
   </p:cSld>
@@ -7703,7 +7693,7 @@
           <p:nvPr/>
         </p:nvPicPr>
         <p:blipFill>
-          <a:blip xmlns:r="http://schemas.openxmlformats.org/officeDocument/2006/relationships" xmlns:a="http://schemas.openxmlformats.org/drawingml/2006/main" r:embed="Ref7fd98110634d52"/>
+          <a:blip xmlns:r="http://schemas.openxmlformats.org/officeDocument/2006/relationships" xmlns:a="http://schemas.openxmlformats.org/drawingml/2006/main" r:embed="R1246ee24525744e9"/>
           <a:stretch xmlns:a="http://schemas.openxmlformats.org/drawingml/2006/main"/>
         </p:blipFill>
         <p:spPr>
@@ -7719,7 +7709,7 @@
     </p:spTree>
     <p:extLst>
       <p:ext uri="{BB962C8B-B14F-4D97-AF65-F5344CB8AC3E}">
-        <p14:creationId xmlns:p14="http://schemas.microsoft.com/office/powerpoint/2010/main" val="67777300"/>
+        <p14:creationId xmlns:p14="http://schemas.microsoft.com/office/powerpoint/2010/main" val="2147146843"/>
       </p:ext>
     </p:extLst>
   </p:cSld>
@@ -7747,7 +7737,7 @@
           <p:nvPr/>
         </p:nvPicPr>
         <p:blipFill>
-          <a:blip xmlns:r="http://schemas.openxmlformats.org/officeDocument/2006/relationships" xmlns:a="http://schemas.openxmlformats.org/drawingml/2006/main" r:embed="R8a6d49d8c90947f4"/>
+          <a:blip xmlns:r="http://schemas.openxmlformats.org/officeDocument/2006/relationships" xmlns:a="http://schemas.openxmlformats.org/drawingml/2006/main" r:embed="Rfae431bbdda34437"/>
           <a:stretch xmlns:a="http://schemas.openxmlformats.org/drawingml/2006/main"/>
         </p:blipFill>
         <p:spPr>
@@ -7763,7 +7753,7 @@
     </p:spTree>
     <p:extLst>
       <p:ext uri="{BB962C8B-B14F-4D97-AF65-F5344CB8AC3E}">
-        <p14:creationId xmlns:p14="http://schemas.microsoft.com/office/powerpoint/2010/main" val="585393877"/>
+        <p14:creationId xmlns:p14="http://schemas.microsoft.com/office/powerpoint/2010/main" val="218550055"/>
       </p:ext>
     </p:extLst>
   </p:cSld>
@@ -7791,7 +7781,7 @@
           <p:nvPr/>
         </p:nvPicPr>
         <p:blipFill>
-          <a:blip xmlns:r="http://schemas.openxmlformats.org/officeDocument/2006/relationships" xmlns:a="http://schemas.openxmlformats.org/drawingml/2006/main" r:embed="Rd34085bea2de4690"/>
+          <a:blip xmlns:r="http://schemas.openxmlformats.org/officeDocument/2006/relationships" xmlns:a="http://schemas.openxmlformats.org/drawingml/2006/main" r:embed="Rd2642ec0023f4e84"/>
           <a:stretch xmlns:a="http://schemas.openxmlformats.org/drawingml/2006/main"/>
         </p:blipFill>
         <p:spPr>
@@ -7807,7 +7797,7 @@
     </p:spTree>
     <p:extLst>
       <p:ext uri="{BB962C8B-B14F-4D97-AF65-F5344CB8AC3E}">
-        <p14:creationId xmlns:p14="http://schemas.microsoft.com/office/powerpoint/2010/main" val="1236570334"/>
+        <p14:creationId xmlns:p14="http://schemas.microsoft.com/office/powerpoint/2010/main" val="1162340462"/>
       </p:ext>
     </p:extLst>
   </p:cSld>
@@ -7835,7 +7825,7 @@
           <p:nvPr/>
         </p:nvPicPr>
         <p:blipFill>
-          <a:blip xmlns:r="http://schemas.openxmlformats.org/officeDocument/2006/relationships" xmlns:a="http://schemas.openxmlformats.org/drawingml/2006/main" r:embed="R0c810852380548fc"/>
+          <a:blip xmlns:r="http://schemas.openxmlformats.org/officeDocument/2006/relationships" xmlns:a="http://schemas.openxmlformats.org/drawingml/2006/main" r:embed="R7515dce8f4b64b5c"/>
           <a:stretch xmlns:a="http://schemas.openxmlformats.org/drawingml/2006/main"/>
         </p:blipFill>
         <p:spPr>
@@ -7851,7 +7841,7 @@
     </p:spTree>
     <p:extLst>
       <p:ext uri="{BB962C8B-B14F-4D97-AF65-F5344CB8AC3E}">
-        <p14:creationId xmlns:p14="http://schemas.microsoft.com/office/powerpoint/2010/main" val="789634696"/>
+        <p14:creationId xmlns:p14="http://schemas.microsoft.com/office/powerpoint/2010/main" val="605459160"/>
       </p:ext>
     </p:extLst>
   </p:cSld>
@@ -7879,7 +7869,7 @@
           <p:nvPr/>
         </p:nvPicPr>
         <p:blipFill>
-          <a:blip xmlns:r="http://schemas.openxmlformats.org/officeDocument/2006/relationships" xmlns:a="http://schemas.openxmlformats.org/drawingml/2006/main" r:embed="Rc357f19621274d91"/>
+          <a:blip xmlns:r="http://schemas.openxmlformats.org/officeDocument/2006/relationships" xmlns:a="http://schemas.openxmlformats.org/drawingml/2006/main" r:embed="R213f0e17c1ca40cc"/>
           <a:stretch xmlns:a="http://schemas.openxmlformats.org/drawingml/2006/main"/>
         </p:blipFill>
         <p:spPr>
@@ -7895,7 +7885,7 @@
     </p:spTree>
     <p:extLst>
       <p:ext uri="{BB962C8B-B14F-4D97-AF65-F5344CB8AC3E}">
-        <p14:creationId xmlns:p14="http://schemas.microsoft.com/office/powerpoint/2010/main" val="1557802612"/>
+        <p14:creationId xmlns:p14="http://schemas.microsoft.com/office/powerpoint/2010/main" val="1823239707"/>
       </p:ext>
     </p:extLst>
   </p:cSld>
@@ -7923,7 +7913,7 @@
           <p:nvPr/>
         </p:nvPicPr>
         <p:blipFill>
-          <a:blip xmlns:r="http://schemas.openxmlformats.org/officeDocument/2006/relationships" xmlns:a="http://schemas.openxmlformats.org/drawingml/2006/main" r:embed="R1d22b1eb200149df"/>
+          <a:blip xmlns:r="http://schemas.openxmlformats.org/officeDocument/2006/relationships" xmlns:a="http://schemas.openxmlformats.org/drawingml/2006/main" r:embed="R736ae0335551454c"/>
           <a:stretch xmlns:a="http://schemas.openxmlformats.org/drawingml/2006/main"/>
         </p:blipFill>
         <p:spPr>
@@ -7939,7 +7929,7 @@
     </p:spTree>
     <p:extLst>
       <p:ext uri="{BB962C8B-B14F-4D97-AF65-F5344CB8AC3E}">
-        <p14:creationId xmlns:p14="http://schemas.microsoft.com/office/powerpoint/2010/main" val="1997111560"/>
+        <p14:creationId xmlns:p14="http://schemas.microsoft.com/office/powerpoint/2010/main" val="531816877"/>
       </p:ext>
     </p:extLst>
   </p:cSld>

</xml_diff>

<commit_message>
Allow any edition of Baldwin and Wyplosz across lectures
</commit_message>
<xml_diff>
--- a/teaching/macro-applications/downloads/lecture_2.pptx
+++ b/teaching/macro-applications/downloads/lecture_2.pptx
@@ -2,38 +2,38 @@
 <file path=ppt/presentation.xml><?xml version="1.0" encoding="utf-8"?>
 <p:presentation xmlns:p="http://schemas.openxmlformats.org/presentationml/2006/main">
   <p:sldMasterIdLst>
-    <p:sldMasterId xmlns:r="http://schemas.openxmlformats.org/officeDocument/2006/relationships" id="2147483648" r:id="R453e26a52f334d2b"/>
+    <p:sldMasterId xmlns:r="http://schemas.openxmlformats.org/officeDocument/2006/relationships" id="2147483648" r:id="Ra4351ec6a08e4efd"/>
   </p:sldMasterIdLst>
   <p:notesMasterIdLst>
-    <p:notesMasterId xmlns:r="http://schemas.openxmlformats.org/officeDocument/2006/relationships" r:id="Rd0c6cea852f44f64"/>
+    <p:notesMasterId xmlns:r="http://schemas.openxmlformats.org/officeDocument/2006/relationships" r:id="Ra8f9f98daaf64450"/>
   </p:notesMasterIdLst>
   <p:sldIdLst>
-    <p:sldId xmlns:r="http://schemas.openxmlformats.org/officeDocument/2006/relationships" id="256" r:id="R519553fee49c4be0"/>
-    <p:sldId xmlns:r="http://schemas.openxmlformats.org/officeDocument/2006/relationships" id="257" r:id="Rd657c15d40154a0e"/>
-    <p:sldId xmlns:r="http://schemas.openxmlformats.org/officeDocument/2006/relationships" id="258" r:id="R0eca076c0e454686"/>
-    <p:sldId xmlns:r="http://schemas.openxmlformats.org/officeDocument/2006/relationships" id="259" r:id="R3144ab5418a6432c"/>
-    <p:sldId xmlns:r="http://schemas.openxmlformats.org/officeDocument/2006/relationships" id="260" r:id="R0adea9a930244c8c"/>
-    <p:sldId xmlns:r="http://schemas.openxmlformats.org/officeDocument/2006/relationships" id="261" r:id="Rcb2f6ce514da4a22"/>
-    <p:sldId xmlns:r="http://schemas.openxmlformats.org/officeDocument/2006/relationships" id="262" r:id="R584a342259304eb9"/>
-    <p:sldId xmlns:r="http://schemas.openxmlformats.org/officeDocument/2006/relationships" id="263" r:id="R47d99fe174774532"/>
-    <p:sldId xmlns:r="http://schemas.openxmlformats.org/officeDocument/2006/relationships" id="264" r:id="Rb71a1a2fbac347c1"/>
-    <p:sldId xmlns:r="http://schemas.openxmlformats.org/officeDocument/2006/relationships" id="265" r:id="R0ba0c57902564850"/>
-    <p:sldId xmlns:r="http://schemas.openxmlformats.org/officeDocument/2006/relationships" id="266" r:id="Rdea12cc099614653"/>
-    <p:sldId xmlns:r="http://schemas.openxmlformats.org/officeDocument/2006/relationships" id="267" r:id="Rb4adb5f57b2a4ea2"/>
-    <p:sldId xmlns:r="http://schemas.openxmlformats.org/officeDocument/2006/relationships" id="268" r:id="R3c3792cc88564ad3"/>
-    <p:sldId xmlns:r="http://schemas.openxmlformats.org/officeDocument/2006/relationships" id="269" r:id="Re20c1f83c9554ab7"/>
-    <p:sldId xmlns:r="http://schemas.openxmlformats.org/officeDocument/2006/relationships" id="270" r:id="R4b3c0e7180c04817"/>
-    <p:sldId xmlns:r="http://schemas.openxmlformats.org/officeDocument/2006/relationships" id="271" r:id="Rbcc462873a754eac"/>
-    <p:sldId xmlns:r="http://schemas.openxmlformats.org/officeDocument/2006/relationships" id="272" r:id="Refc9f3219de644d4"/>
-    <p:sldId xmlns:r="http://schemas.openxmlformats.org/officeDocument/2006/relationships" id="273" r:id="R40fcf9a8bb694f48"/>
-    <p:sldId xmlns:r="http://schemas.openxmlformats.org/officeDocument/2006/relationships" id="274" r:id="R61644737c5f345ae"/>
-    <p:sldId xmlns:r="http://schemas.openxmlformats.org/officeDocument/2006/relationships" id="275" r:id="R7d287ba32d7144b5"/>
-    <p:sldId xmlns:r="http://schemas.openxmlformats.org/officeDocument/2006/relationships" id="276" r:id="R7ee63f46806c477f"/>
-    <p:sldId xmlns:r="http://schemas.openxmlformats.org/officeDocument/2006/relationships" id="277" r:id="Rfd9d873ed318438c"/>
-    <p:sldId xmlns:r="http://schemas.openxmlformats.org/officeDocument/2006/relationships" id="278" r:id="Re0b09798dd6d4577"/>
-    <p:sldId xmlns:r="http://schemas.openxmlformats.org/officeDocument/2006/relationships" id="279" r:id="R98b48bebf576461d"/>
-    <p:sldId xmlns:r="http://schemas.openxmlformats.org/officeDocument/2006/relationships" id="280" r:id="Rdec87e76c8cb4335"/>
-    <p:sldId xmlns:r="http://schemas.openxmlformats.org/officeDocument/2006/relationships" id="281" r:id="Rf52caec7054f4e49"/>
+    <p:sldId xmlns:r="http://schemas.openxmlformats.org/officeDocument/2006/relationships" id="256" r:id="R01f46237a53f4daf"/>
+    <p:sldId xmlns:r="http://schemas.openxmlformats.org/officeDocument/2006/relationships" id="257" r:id="Rad04b6e432d84915"/>
+    <p:sldId xmlns:r="http://schemas.openxmlformats.org/officeDocument/2006/relationships" id="258" r:id="R6a8cf57055b94271"/>
+    <p:sldId xmlns:r="http://schemas.openxmlformats.org/officeDocument/2006/relationships" id="259" r:id="Rb9e5581d3a804485"/>
+    <p:sldId xmlns:r="http://schemas.openxmlformats.org/officeDocument/2006/relationships" id="260" r:id="R7bfe6231bdc546b7"/>
+    <p:sldId xmlns:r="http://schemas.openxmlformats.org/officeDocument/2006/relationships" id="261" r:id="R2c3164c32e6348fa"/>
+    <p:sldId xmlns:r="http://schemas.openxmlformats.org/officeDocument/2006/relationships" id="262" r:id="Rc659bda866b341d9"/>
+    <p:sldId xmlns:r="http://schemas.openxmlformats.org/officeDocument/2006/relationships" id="263" r:id="R26fc504a73ee41a9"/>
+    <p:sldId xmlns:r="http://schemas.openxmlformats.org/officeDocument/2006/relationships" id="264" r:id="Re1f0170e1c85421a"/>
+    <p:sldId xmlns:r="http://schemas.openxmlformats.org/officeDocument/2006/relationships" id="265" r:id="Raaccb36f23894e00"/>
+    <p:sldId xmlns:r="http://schemas.openxmlformats.org/officeDocument/2006/relationships" id="266" r:id="R1195ed1e82e54356"/>
+    <p:sldId xmlns:r="http://schemas.openxmlformats.org/officeDocument/2006/relationships" id="267" r:id="R829fbbdb3c094989"/>
+    <p:sldId xmlns:r="http://schemas.openxmlformats.org/officeDocument/2006/relationships" id="268" r:id="Ra6103a8ed8b54572"/>
+    <p:sldId xmlns:r="http://schemas.openxmlformats.org/officeDocument/2006/relationships" id="269" r:id="Ra737208b4bd04552"/>
+    <p:sldId xmlns:r="http://schemas.openxmlformats.org/officeDocument/2006/relationships" id="270" r:id="Rad5ef4689adb4761"/>
+    <p:sldId xmlns:r="http://schemas.openxmlformats.org/officeDocument/2006/relationships" id="271" r:id="R762d365d07764276"/>
+    <p:sldId xmlns:r="http://schemas.openxmlformats.org/officeDocument/2006/relationships" id="272" r:id="Rb0f0e7dc09da43b8"/>
+    <p:sldId xmlns:r="http://schemas.openxmlformats.org/officeDocument/2006/relationships" id="273" r:id="R8e3b463dbd884b3d"/>
+    <p:sldId xmlns:r="http://schemas.openxmlformats.org/officeDocument/2006/relationships" id="274" r:id="R5dc748a8f3f14708"/>
+    <p:sldId xmlns:r="http://schemas.openxmlformats.org/officeDocument/2006/relationships" id="275" r:id="R5ae4273dfb9d48ee"/>
+    <p:sldId xmlns:r="http://schemas.openxmlformats.org/officeDocument/2006/relationships" id="276" r:id="R6a1f2370eb9845b4"/>
+    <p:sldId xmlns:r="http://schemas.openxmlformats.org/officeDocument/2006/relationships" id="277" r:id="R52c56af9d96b41b1"/>
+    <p:sldId xmlns:r="http://schemas.openxmlformats.org/officeDocument/2006/relationships" id="278" r:id="R1010825900404b2e"/>
+    <p:sldId xmlns:r="http://schemas.openxmlformats.org/officeDocument/2006/relationships" id="279" r:id="Re2c89f78d9734870"/>
+    <p:sldId xmlns:r="http://schemas.openxmlformats.org/officeDocument/2006/relationships" id="280" r:id="Rf028feea83494f38"/>
+    <p:sldId xmlns:r="http://schemas.openxmlformats.org/officeDocument/2006/relationships" id="281" r:id="R813eaa4d32d14bd6"/>
   </p:sldIdLst>
   <p:sldSz cx="12192000" cy="6858000"/>
   <p:notesSz cx="6858000" cy="9144000"/>
@@ -4572,7 +4572,7 @@
           </a:p>
           <a:p xmlns:a="http://schemas.openxmlformats.org/drawingml/2006/main">
             <a:r>
-              <a:t>Baldwin R., Wyplosz C. (2022), The Economics of European Integration, Chapters 4 and 5</a:t>
+              <a:t>Baldwin and Wyplosz, The Economics of European Integration, Chapters 4 and 5 (any edition).</a:t>
             </a:r>
           </a:p>
           <a:p xmlns:a="http://schemas.openxmlformats.org/drawingml/2006/main">
@@ -6265,7 +6265,7 @@
   </p:cSld>
   <p:clrMap bg1="lt1" tx1="dk1" bg2="lt2" tx2="dk2" accent1="accent1" accent2="accent2" accent3="accent3" accent4="accent4" accent5="accent5" accent6="accent6" hlink="hlink" folHlink="folHlink"/>
   <p:sldLayoutIdLst>
-    <p:sldLayoutId xmlns:r="http://schemas.openxmlformats.org/officeDocument/2006/relationships" id="2147483649" r:id="R7b7a8260116a4954"/>
+    <p:sldLayoutId xmlns:r="http://schemas.openxmlformats.org/officeDocument/2006/relationships" id="2147483649" r:id="R4087482ac4d142e9"/>
   </p:sldLayoutIdLst>
   <p:txStyles>
     <p:titleStyle>
@@ -6813,7 +6813,7 @@
           <p:nvPr/>
         </p:nvPicPr>
         <p:blipFill>
-          <a:blip xmlns:r="http://schemas.openxmlformats.org/officeDocument/2006/relationships" xmlns:a="http://schemas.openxmlformats.org/drawingml/2006/main" r:embed="R797a325c41c74f87"/>
+          <a:blip xmlns:r="http://schemas.openxmlformats.org/officeDocument/2006/relationships" xmlns:a="http://schemas.openxmlformats.org/drawingml/2006/main" r:embed="R19209e166b2446da"/>
           <a:stretch xmlns:a="http://schemas.openxmlformats.org/drawingml/2006/main"/>
         </p:blipFill>
         <p:spPr>
@@ -6829,7 +6829,7 @@
     </p:spTree>
     <p:extLst>
       <p:ext uri="{BB962C8B-B14F-4D97-AF65-F5344CB8AC3E}">
-        <p14:creationId xmlns:p14="http://schemas.microsoft.com/office/powerpoint/2010/main" val="340658360"/>
+        <p14:creationId xmlns:p14="http://schemas.microsoft.com/office/powerpoint/2010/main" val="1004676899"/>
       </p:ext>
     </p:extLst>
   </p:cSld>
@@ -6857,7 +6857,7 @@
           <p:nvPr/>
         </p:nvPicPr>
         <p:blipFill>
-          <a:blip xmlns:r="http://schemas.openxmlformats.org/officeDocument/2006/relationships" xmlns:a="http://schemas.openxmlformats.org/drawingml/2006/main" r:embed="Rbdd1376972ba4116"/>
+          <a:blip xmlns:r="http://schemas.openxmlformats.org/officeDocument/2006/relationships" xmlns:a="http://schemas.openxmlformats.org/drawingml/2006/main" r:embed="R6f78218eb959474d"/>
           <a:stretch xmlns:a="http://schemas.openxmlformats.org/drawingml/2006/main"/>
         </p:blipFill>
         <p:spPr>
@@ -6873,7 +6873,7 @@
     </p:spTree>
     <p:extLst>
       <p:ext uri="{BB962C8B-B14F-4D97-AF65-F5344CB8AC3E}">
-        <p14:creationId xmlns:p14="http://schemas.microsoft.com/office/powerpoint/2010/main" val="1336080504"/>
+        <p14:creationId xmlns:p14="http://schemas.microsoft.com/office/powerpoint/2010/main" val="173006748"/>
       </p:ext>
     </p:extLst>
   </p:cSld>
@@ -6901,7 +6901,7 @@
           <p:nvPr/>
         </p:nvPicPr>
         <p:blipFill>
-          <a:blip xmlns:r="http://schemas.openxmlformats.org/officeDocument/2006/relationships" xmlns:a="http://schemas.openxmlformats.org/drawingml/2006/main" r:embed="R179aa1f450914fc4"/>
+          <a:blip xmlns:r="http://schemas.openxmlformats.org/officeDocument/2006/relationships" xmlns:a="http://schemas.openxmlformats.org/drawingml/2006/main" r:embed="Rfac238d41d114cab"/>
           <a:stretch xmlns:a="http://schemas.openxmlformats.org/drawingml/2006/main"/>
         </p:blipFill>
         <p:spPr>
@@ -6917,7 +6917,7 @@
     </p:spTree>
     <p:extLst>
       <p:ext uri="{BB962C8B-B14F-4D97-AF65-F5344CB8AC3E}">
-        <p14:creationId xmlns:p14="http://schemas.microsoft.com/office/powerpoint/2010/main" val="357468810"/>
+        <p14:creationId xmlns:p14="http://schemas.microsoft.com/office/powerpoint/2010/main" val="663881826"/>
       </p:ext>
     </p:extLst>
   </p:cSld>
@@ -6945,7 +6945,7 @@
           <p:nvPr/>
         </p:nvPicPr>
         <p:blipFill>
-          <a:blip xmlns:r="http://schemas.openxmlformats.org/officeDocument/2006/relationships" xmlns:a="http://schemas.openxmlformats.org/drawingml/2006/main" r:embed="Ra2f1a3d85c3d4ca4"/>
+          <a:blip xmlns:r="http://schemas.openxmlformats.org/officeDocument/2006/relationships" xmlns:a="http://schemas.openxmlformats.org/drawingml/2006/main" r:embed="R32d8cd28f29a42d8"/>
           <a:stretch xmlns:a="http://schemas.openxmlformats.org/drawingml/2006/main"/>
         </p:blipFill>
         <p:spPr>
@@ -6961,7 +6961,7 @@
     </p:spTree>
     <p:extLst>
       <p:ext uri="{BB962C8B-B14F-4D97-AF65-F5344CB8AC3E}">
-        <p14:creationId xmlns:p14="http://schemas.microsoft.com/office/powerpoint/2010/main" val="606747645"/>
+        <p14:creationId xmlns:p14="http://schemas.microsoft.com/office/powerpoint/2010/main" val="358143088"/>
       </p:ext>
     </p:extLst>
   </p:cSld>
@@ -6989,7 +6989,7 @@
           <p:nvPr/>
         </p:nvPicPr>
         <p:blipFill>
-          <a:blip xmlns:r="http://schemas.openxmlformats.org/officeDocument/2006/relationships" xmlns:a="http://schemas.openxmlformats.org/drawingml/2006/main" r:embed="Ra3ba702402e84ea4"/>
+          <a:blip xmlns:r="http://schemas.openxmlformats.org/officeDocument/2006/relationships" xmlns:a="http://schemas.openxmlformats.org/drawingml/2006/main" r:embed="R6a3cac71aad44e8f"/>
           <a:stretch xmlns:a="http://schemas.openxmlformats.org/drawingml/2006/main"/>
         </p:blipFill>
         <p:spPr>
@@ -7005,7 +7005,7 @@
     </p:spTree>
     <p:extLst>
       <p:ext uri="{BB962C8B-B14F-4D97-AF65-F5344CB8AC3E}">
-        <p14:creationId xmlns:p14="http://schemas.microsoft.com/office/powerpoint/2010/main" val="2029585042"/>
+        <p14:creationId xmlns:p14="http://schemas.microsoft.com/office/powerpoint/2010/main" val="1104241893"/>
       </p:ext>
     </p:extLst>
   </p:cSld>
@@ -7033,7 +7033,7 @@
           <p:nvPr/>
         </p:nvPicPr>
         <p:blipFill>
-          <a:blip xmlns:r="http://schemas.openxmlformats.org/officeDocument/2006/relationships" xmlns:a="http://schemas.openxmlformats.org/drawingml/2006/main" r:embed="R2d9d5eeaba4344de"/>
+          <a:blip xmlns:r="http://schemas.openxmlformats.org/officeDocument/2006/relationships" xmlns:a="http://schemas.openxmlformats.org/drawingml/2006/main" r:embed="R73980ee4d3b44b22"/>
           <a:stretch xmlns:a="http://schemas.openxmlformats.org/drawingml/2006/main"/>
         </p:blipFill>
         <p:spPr>
@@ -7049,7 +7049,7 @@
     </p:spTree>
     <p:extLst>
       <p:ext uri="{BB962C8B-B14F-4D97-AF65-F5344CB8AC3E}">
-        <p14:creationId xmlns:p14="http://schemas.microsoft.com/office/powerpoint/2010/main" val="1209744937"/>
+        <p14:creationId xmlns:p14="http://schemas.microsoft.com/office/powerpoint/2010/main" val="1966682690"/>
       </p:ext>
     </p:extLst>
   </p:cSld>
@@ -7077,7 +7077,7 @@
           <p:nvPr/>
         </p:nvPicPr>
         <p:blipFill>
-          <a:blip xmlns:r="http://schemas.openxmlformats.org/officeDocument/2006/relationships" xmlns:a="http://schemas.openxmlformats.org/drawingml/2006/main" r:embed="R940b94ec2d694e34"/>
+          <a:blip xmlns:r="http://schemas.openxmlformats.org/officeDocument/2006/relationships" xmlns:a="http://schemas.openxmlformats.org/drawingml/2006/main" r:embed="Rc31f3f006e434098"/>
           <a:stretch xmlns:a="http://schemas.openxmlformats.org/drawingml/2006/main"/>
         </p:blipFill>
         <p:spPr>
@@ -7093,7 +7093,7 @@
     </p:spTree>
     <p:extLst>
       <p:ext uri="{BB962C8B-B14F-4D97-AF65-F5344CB8AC3E}">
-        <p14:creationId xmlns:p14="http://schemas.microsoft.com/office/powerpoint/2010/main" val="1051940636"/>
+        <p14:creationId xmlns:p14="http://schemas.microsoft.com/office/powerpoint/2010/main" val="2068918430"/>
       </p:ext>
     </p:extLst>
   </p:cSld>
@@ -7121,7 +7121,7 @@
           <p:nvPr/>
         </p:nvPicPr>
         <p:blipFill>
-          <a:blip xmlns:r="http://schemas.openxmlformats.org/officeDocument/2006/relationships" xmlns:a="http://schemas.openxmlformats.org/drawingml/2006/main" r:embed="R098b8758886a49b0"/>
+          <a:blip xmlns:r="http://schemas.openxmlformats.org/officeDocument/2006/relationships" xmlns:a="http://schemas.openxmlformats.org/drawingml/2006/main" r:embed="R48f35e6596cb425e"/>
           <a:stretch xmlns:a="http://schemas.openxmlformats.org/drawingml/2006/main"/>
         </p:blipFill>
         <p:spPr>
@@ -7137,7 +7137,7 @@
     </p:spTree>
     <p:extLst>
       <p:ext uri="{BB962C8B-B14F-4D97-AF65-F5344CB8AC3E}">
-        <p14:creationId xmlns:p14="http://schemas.microsoft.com/office/powerpoint/2010/main" val="471112149"/>
+        <p14:creationId xmlns:p14="http://schemas.microsoft.com/office/powerpoint/2010/main" val="413373545"/>
       </p:ext>
     </p:extLst>
   </p:cSld>
@@ -7165,7 +7165,7 @@
           <p:nvPr/>
         </p:nvPicPr>
         <p:blipFill>
-          <a:blip xmlns:r="http://schemas.openxmlformats.org/officeDocument/2006/relationships" xmlns:a="http://schemas.openxmlformats.org/drawingml/2006/main" r:embed="Rf6a7aca8ebab4c5f"/>
+          <a:blip xmlns:r="http://schemas.openxmlformats.org/officeDocument/2006/relationships" xmlns:a="http://schemas.openxmlformats.org/drawingml/2006/main" r:embed="R96f61085ed824667"/>
           <a:stretch xmlns:a="http://schemas.openxmlformats.org/drawingml/2006/main"/>
         </p:blipFill>
         <p:spPr>
@@ -7181,7 +7181,7 @@
     </p:spTree>
     <p:extLst>
       <p:ext uri="{BB962C8B-B14F-4D97-AF65-F5344CB8AC3E}">
-        <p14:creationId xmlns:p14="http://schemas.microsoft.com/office/powerpoint/2010/main" val="1748128660"/>
+        <p14:creationId xmlns:p14="http://schemas.microsoft.com/office/powerpoint/2010/main" val="372227651"/>
       </p:ext>
     </p:extLst>
   </p:cSld>
@@ -7209,7 +7209,7 @@
           <p:nvPr/>
         </p:nvPicPr>
         <p:blipFill>
-          <a:blip xmlns:r="http://schemas.openxmlformats.org/officeDocument/2006/relationships" xmlns:a="http://schemas.openxmlformats.org/drawingml/2006/main" r:embed="Rd46b46024fcc4c0a"/>
+          <a:blip xmlns:r="http://schemas.openxmlformats.org/officeDocument/2006/relationships" xmlns:a="http://schemas.openxmlformats.org/drawingml/2006/main" r:embed="R5f528c5a708a4fe2"/>
           <a:stretch xmlns:a="http://schemas.openxmlformats.org/drawingml/2006/main"/>
         </p:blipFill>
         <p:spPr>
@@ -7225,7 +7225,7 @@
     </p:spTree>
     <p:extLst>
       <p:ext uri="{BB962C8B-B14F-4D97-AF65-F5344CB8AC3E}">
-        <p14:creationId xmlns:p14="http://schemas.microsoft.com/office/powerpoint/2010/main" val="348819393"/>
+        <p14:creationId xmlns:p14="http://schemas.microsoft.com/office/powerpoint/2010/main" val="1291754884"/>
       </p:ext>
     </p:extLst>
   </p:cSld>
@@ -7253,7 +7253,7 @@
           <p:nvPr/>
         </p:nvPicPr>
         <p:blipFill>
-          <a:blip xmlns:r="http://schemas.openxmlformats.org/officeDocument/2006/relationships" xmlns:a="http://schemas.openxmlformats.org/drawingml/2006/main" r:embed="R789d51eb6b054626"/>
+          <a:blip xmlns:r="http://schemas.openxmlformats.org/officeDocument/2006/relationships" xmlns:a="http://schemas.openxmlformats.org/drawingml/2006/main" r:embed="Rf5d29d4084f54658"/>
           <a:stretch xmlns:a="http://schemas.openxmlformats.org/drawingml/2006/main"/>
         </p:blipFill>
         <p:spPr>
@@ -7269,7 +7269,7 @@
     </p:spTree>
     <p:extLst>
       <p:ext uri="{BB962C8B-B14F-4D97-AF65-F5344CB8AC3E}">
-        <p14:creationId xmlns:p14="http://schemas.microsoft.com/office/powerpoint/2010/main" val="1615145784"/>
+        <p14:creationId xmlns:p14="http://schemas.microsoft.com/office/powerpoint/2010/main" val="974646465"/>
       </p:ext>
     </p:extLst>
   </p:cSld>
@@ -7297,7 +7297,7 @@
           <p:nvPr/>
         </p:nvPicPr>
         <p:blipFill>
-          <a:blip xmlns:r="http://schemas.openxmlformats.org/officeDocument/2006/relationships" xmlns:a="http://schemas.openxmlformats.org/drawingml/2006/main" r:embed="R450105fc078b420c"/>
+          <a:blip xmlns:r="http://schemas.openxmlformats.org/officeDocument/2006/relationships" xmlns:a="http://schemas.openxmlformats.org/drawingml/2006/main" r:embed="R5b3331a3f2664105"/>
           <a:stretch xmlns:a="http://schemas.openxmlformats.org/drawingml/2006/main"/>
         </p:blipFill>
         <p:spPr>
@@ -7313,7 +7313,7 @@
     </p:spTree>
     <p:extLst>
       <p:ext uri="{BB962C8B-B14F-4D97-AF65-F5344CB8AC3E}">
-        <p14:creationId xmlns:p14="http://schemas.microsoft.com/office/powerpoint/2010/main" val="820269702"/>
+        <p14:creationId xmlns:p14="http://schemas.microsoft.com/office/powerpoint/2010/main" val="83621247"/>
       </p:ext>
     </p:extLst>
   </p:cSld>
@@ -7341,7 +7341,7 @@
           <p:nvPr/>
         </p:nvPicPr>
         <p:blipFill>
-          <a:blip xmlns:r="http://schemas.openxmlformats.org/officeDocument/2006/relationships" xmlns:a="http://schemas.openxmlformats.org/drawingml/2006/main" r:embed="R5632bfc8c36a4c10"/>
+          <a:blip xmlns:r="http://schemas.openxmlformats.org/officeDocument/2006/relationships" xmlns:a="http://schemas.openxmlformats.org/drawingml/2006/main" r:embed="Rb059737d3ad04674"/>
           <a:stretch xmlns:a="http://schemas.openxmlformats.org/drawingml/2006/main"/>
         </p:blipFill>
         <p:spPr>
@@ -7357,7 +7357,7 @@
     </p:spTree>
     <p:extLst>
       <p:ext uri="{BB962C8B-B14F-4D97-AF65-F5344CB8AC3E}">
-        <p14:creationId xmlns:p14="http://schemas.microsoft.com/office/powerpoint/2010/main" val="890406018"/>
+        <p14:creationId xmlns:p14="http://schemas.microsoft.com/office/powerpoint/2010/main" val="71453413"/>
       </p:ext>
     </p:extLst>
   </p:cSld>
@@ -7385,7 +7385,7 @@
           <p:nvPr/>
         </p:nvPicPr>
         <p:blipFill>
-          <a:blip xmlns:r="http://schemas.openxmlformats.org/officeDocument/2006/relationships" xmlns:a="http://schemas.openxmlformats.org/drawingml/2006/main" r:embed="R9448dc81c31040ad"/>
+          <a:blip xmlns:r="http://schemas.openxmlformats.org/officeDocument/2006/relationships" xmlns:a="http://schemas.openxmlformats.org/drawingml/2006/main" r:embed="R131dc00d7a2f4302"/>
           <a:stretch xmlns:a="http://schemas.openxmlformats.org/drawingml/2006/main"/>
         </p:blipFill>
         <p:spPr>
@@ -7401,7 +7401,7 @@
     </p:spTree>
     <p:extLst>
       <p:ext uri="{BB962C8B-B14F-4D97-AF65-F5344CB8AC3E}">
-        <p14:creationId xmlns:p14="http://schemas.microsoft.com/office/powerpoint/2010/main" val="330334605"/>
+        <p14:creationId xmlns:p14="http://schemas.microsoft.com/office/powerpoint/2010/main" val="622768438"/>
       </p:ext>
     </p:extLst>
   </p:cSld>
@@ -7429,7 +7429,7 @@
           <p:nvPr/>
         </p:nvPicPr>
         <p:blipFill>
-          <a:blip xmlns:r="http://schemas.openxmlformats.org/officeDocument/2006/relationships" xmlns:a="http://schemas.openxmlformats.org/drawingml/2006/main" r:embed="Rb29067c306724c88"/>
+          <a:blip xmlns:r="http://schemas.openxmlformats.org/officeDocument/2006/relationships" xmlns:a="http://schemas.openxmlformats.org/drawingml/2006/main" r:embed="R81fb117c711c4d40"/>
           <a:stretch xmlns:a="http://schemas.openxmlformats.org/drawingml/2006/main"/>
         </p:blipFill>
         <p:spPr>
@@ -7445,7 +7445,7 @@
     </p:spTree>
     <p:extLst>
       <p:ext uri="{BB962C8B-B14F-4D97-AF65-F5344CB8AC3E}">
-        <p14:creationId xmlns:p14="http://schemas.microsoft.com/office/powerpoint/2010/main" val="724962842"/>
+        <p14:creationId xmlns:p14="http://schemas.microsoft.com/office/powerpoint/2010/main" val="1740875916"/>
       </p:ext>
     </p:extLst>
   </p:cSld>
@@ -7473,7 +7473,7 @@
           <p:nvPr/>
         </p:nvPicPr>
         <p:blipFill>
-          <a:blip xmlns:r="http://schemas.openxmlformats.org/officeDocument/2006/relationships" xmlns:a="http://schemas.openxmlformats.org/drawingml/2006/main" r:embed="R4177da53258c4b30"/>
+          <a:blip xmlns:r="http://schemas.openxmlformats.org/officeDocument/2006/relationships" xmlns:a="http://schemas.openxmlformats.org/drawingml/2006/main" r:embed="Red2615ef9d514b46"/>
           <a:stretch xmlns:a="http://schemas.openxmlformats.org/drawingml/2006/main"/>
         </p:blipFill>
         <p:spPr>
@@ -7489,7 +7489,7 @@
     </p:spTree>
     <p:extLst>
       <p:ext uri="{BB962C8B-B14F-4D97-AF65-F5344CB8AC3E}">
-        <p14:creationId xmlns:p14="http://schemas.microsoft.com/office/powerpoint/2010/main" val="844552469"/>
+        <p14:creationId xmlns:p14="http://schemas.microsoft.com/office/powerpoint/2010/main" val="1422464299"/>
       </p:ext>
     </p:extLst>
   </p:cSld>
@@ -7517,7 +7517,7 @@
           <p:nvPr/>
         </p:nvPicPr>
         <p:blipFill>
-          <a:blip xmlns:r="http://schemas.openxmlformats.org/officeDocument/2006/relationships" xmlns:a="http://schemas.openxmlformats.org/drawingml/2006/main" r:embed="R6b6d180942b2433b"/>
+          <a:blip xmlns:r="http://schemas.openxmlformats.org/officeDocument/2006/relationships" xmlns:a="http://schemas.openxmlformats.org/drawingml/2006/main" r:embed="R87f30c52078c4b39"/>
           <a:stretch xmlns:a="http://schemas.openxmlformats.org/drawingml/2006/main"/>
         </p:blipFill>
         <p:spPr>
@@ -7533,7 +7533,7 @@
     </p:spTree>
     <p:extLst>
       <p:ext uri="{BB962C8B-B14F-4D97-AF65-F5344CB8AC3E}">
-        <p14:creationId xmlns:p14="http://schemas.microsoft.com/office/powerpoint/2010/main" val="1516707461"/>
+        <p14:creationId xmlns:p14="http://schemas.microsoft.com/office/powerpoint/2010/main" val="1530078415"/>
       </p:ext>
     </p:extLst>
   </p:cSld>
@@ -7561,7 +7561,7 @@
           <p:nvPr/>
         </p:nvPicPr>
         <p:blipFill>
-          <a:blip xmlns:r="http://schemas.openxmlformats.org/officeDocument/2006/relationships" xmlns:a="http://schemas.openxmlformats.org/drawingml/2006/main" r:embed="Rf03985cdbf5b4448"/>
+          <a:blip xmlns:r="http://schemas.openxmlformats.org/officeDocument/2006/relationships" xmlns:a="http://schemas.openxmlformats.org/drawingml/2006/main" r:embed="Rc0bf13665473491f"/>
           <a:stretch xmlns:a="http://schemas.openxmlformats.org/drawingml/2006/main"/>
         </p:blipFill>
         <p:spPr>
@@ -7577,7 +7577,7 @@
     </p:spTree>
     <p:extLst>
       <p:ext uri="{BB962C8B-B14F-4D97-AF65-F5344CB8AC3E}">
-        <p14:creationId xmlns:p14="http://schemas.microsoft.com/office/powerpoint/2010/main" val="134912192"/>
+        <p14:creationId xmlns:p14="http://schemas.microsoft.com/office/powerpoint/2010/main" val="945601134"/>
       </p:ext>
     </p:extLst>
   </p:cSld>
@@ -7605,7 +7605,7 @@
           <p:nvPr/>
         </p:nvPicPr>
         <p:blipFill>
-          <a:blip xmlns:r="http://schemas.openxmlformats.org/officeDocument/2006/relationships" xmlns:a="http://schemas.openxmlformats.org/drawingml/2006/main" r:embed="R4d36abdbfc794a5d"/>
+          <a:blip xmlns:r="http://schemas.openxmlformats.org/officeDocument/2006/relationships" xmlns:a="http://schemas.openxmlformats.org/drawingml/2006/main" r:embed="Rd4e8c0f53e81410d"/>
           <a:stretch xmlns:a="http://schemas.openxmlformats.org/drawingml/2006/main"/>
         </p:blipFill>
         <p:spPr>
@@ -7621,7 +7621,7 @@
     </p:spTree>
     <p:extLst>
       <p:ext uri="{BB962C8B-B14F-4D97-AF65-F5344CB8AC3E}">
-        <p14:creationId xmlns:p14="http://schemas.microsoft.com/office/powerpoint/2010/main" val="106417832"/>
+        <p14:creationId xmlns:p14="http://schemas.microsoft.com/office/powerpoint/2010/main" val="1439741292"/>
       </p:ext>
     </p:extLst>
   </p:cSld>
@@ -7649,7 +7649,7 @@
           <p:nvPr/>
         </p:nvPicPr>
         <p:blipFill>
-          <a:blip xmlns:r="http://schemas.openxmlformats.org/officeDocument/2006/relationships" xmlns:a="http://schemas.openxmlformats.org/drawingml/2006/main" r:embed="R883640cda8c34a34"/>
+          <a:blip xmlns:r="http://schemas.openxmlformats.org/officeDocument/2006/relationships" xmlns:a="http://schemas.openxmlformats.org/drawingml/2006/main" r:embed="Radbf11c479da4e9c"/>
           <a:stretch xmlns:a="http://schemas.openxmlformats.org/drawingml/2006/main"/>
         </p:blipFill>
         <p:spPr>
@@ -7665,7 +7665,7 @@
     </p:spTree>
     <p:extLst>
       <p:ext uri="{BB962C8B-B14F-4D97-AF65-F5344CB8AC3E}">
-        <p14:creationId xmlns:p14="http://schemas.microsoft.com/office/powerpoint/2010/main" val="1631685771"/>
+        <p14:creationId xmlns:p14="http://schemas.microsoft.com/office/powerpoint/2010/main" val="1664908471"/>
       </p:ext>
     </p:extLst>
   </p:cSld>
@@ -7693,7 +7693,7 @@
           <p:nvPr/>
         </p:nvPicPr>
         <p:blipFill>
-          <a:blip xmlns:r="http://schemas.openxmlformats.org/officeDocument/2006/relationships" xmlns:a="http://schemas.openxmlformats.org/drawingml/2006/main" r:embed="R1246ee24525744e9"/>
+          <a:blip xmlns:r="http://schemas.openxmlformats.org/officeDocument/2006/relationships" xmlns:a="http://schemas.openxmlformats.org/drawingml/2006/main" r:embed="R39ea768e5a944c1f"/>
           <a:stretch xmlns:a="http://schemas.openxmlformats.org/drawingml/2006/main"/>
         </p:blipFill>
         <p:spPr>
@@ -7709,7 +7709,7 @@
     </p:spTree>
     <p:extLst>
       <p:ext uri="{BB962C8B-B14F-4D97-AF65-F5344CB8AC3E}">
-        <p14:creationId xmlns:p14="http://schemas.microsoft.com/office/powerpoint/2010/main" val="2147146843"/>
+        <p14:creationId xmlns:p14="http://schemas.microsoft.com/office/powerpoint/2010/main" val="1111308363"/>
       </p:ext>
     </p:extLst>
   </p:cSld>
@@ -7737,7 +7737,7 @@
           <p:nvPr/>
         </p:nvPicPr>
         <p:blipFill>
-          <a:blip xmlns:r="http://schemas.openxmlformats.org/officeDocument/2006/relationships" xmlns:a="http://schemas.openxmlformats.org/drawingml/2006/main" r:embed="Rfae431bbdda34437"/>
+          <a:blip xmlns:r="http://schemas.openxmlformats.org/officeDocument/2006/relationships" xmlns:a="http://schemas.openxmlformats.org/drawingml/2006/main" r:embed="Ra189893051d248b5"/>
           <a:stretch xmlns:a="http://schemas.openxmlformats.org/drawingml/2006/main"/>
         </p:blipFill>
         <p:spPr>
@@ -7753,7 +7753,7 @@
     </p:spTree>
     <p:extLst>
       <p:ext uri="{BB962C8B-B14F-4D97-AF65-F5344CB8AC3E}">
-        <p14:creationId xmlns:p14="http://schemas.microsoft.com/office/powerpoint/2010/main" val="218550055"/>
+        <p14:creationId xmlns:p14="http://schemas.microsoft.com/office/powerpoint/2010/main" val="1751840914"/>
       </p:ext>
     </p:extLst>
   </p:cSld>
@@ -7781,7 +7781,7 @@
           <p:nvPr/>
         </p:nvPicPr>
         <p:blipFill>
-          <a:blip xmlns:r="http://schemas.openxmlformats.org/officeDocument/2006/relationships" xmlns:a="http://schemas.openxmlformats.org/drawingml/2006/main" r:embed="Rd2642ec0023f4e84"/>
+          <a:blip xmlns:r="http://schemas.openxmlformats.org/officeDocument/2006/relationships" xmlns:a="http://schemas.openxmlformats.org/drawingml/2006/main" r:embed="R9d606b5eb47e42e3"/>
           <a:stretch xmlns:a="http://schemas.openxmlformats.org/drawingml/2006/main"/>
         </p:blipFill>
         <p:spPr>
@@ -7797,7 +7797,7 @@
     </p:spTree>
     <p:extLst>
       <p:ext uri="{BB962C8B-B14F-4D97-AF65-F5344CB8AC3E}">
-        <p14:creationId xmlns:p14="http://schemas.microsoft.com/office/powerpoint/2010/main" val="1162340462"/>
+        <p14:creationId xmlns:p14="http://schemas.microsoft.com/office/powerpoint/2010/main" val="239656520"/>
       </p:ext>
     </p:extLst>
   </p:cSld>
@@ -7825,7 +7825,7 @@
           <p:nvPr/>
         </p:nvPicPr>
         <p:blipFill>
-          <a:blip xmlns:r="http://schemas.openxmlformats.org/officeDocument/2006/relationships" xmlns:a="http://schemas.openxmlformats.org/drawingml/2006/main" r:embed="R7515dce8f4b64b5c"/>
+          <a:blip xmlns:r="http://schemas.openxmlformats.org/officeDocument/2006/relationships" xmlns:a="http://schemas.openxmlformats.org/drawingml/2006/main" r:embed="R7f21f2289da64e8e"/>
           <a:stretch xmlns:a="http://schemas.openxmlformats.org/drawingml/2006/main"/>
         </p:blipFill>
         <p:spPr>
@@ -7841,7 +7841,7 @@
     </p:spTree>
     <p:extLst>
       <p:ext uri="{BB962C8B-B14F-4D97-AF65-F5344CB8AC3E}">
-        <p14:creationId xmlns:p14="http://schemas.microsoft.com/office/powerpoint/2010/main" val="605459160"/>
+        <p14:creationId xmlns:p14="http://schemas.microsoft.com/office/powerpoint/2010/main" val="1081785164"/>
       </p:ext>
     </p:extLst>
   </p:cSld>
@@ -7869,7 +7869,7 @@
           <p:nvPr/>
         </p:nvPicPr>
         <p:blipFill>
-          <a:blip xmlns:r="http://schemas.openxmlformats.org/officeDocument/2006/relationships" xmlns:a="http://schemas.openxmlformats.org/drawingml/2006/main" r:embed="R213f0e17c1ca40cc"/>
+          <a:blip xmlns:r="http://schemas.openxmlformats.org/officeDocument/2006/relationships" xmlns:a="http://schemas.openxmlformats.org/drawingml/2006/main" r:embed="R0f00c436891a4f49"/>
           <a:stretch xmlns:a="http://schemas.openxmlformats.org/drawingml/2006/main"/>
         </p:blipFill>
         <p:spPr>
@@ -7885,7 +7885,7 @@
     </p:spTree>
     <p:extLst>
       <p:ext uri="{BB962C8B-B14F-4D97-AF65-F5344CB8AC3E}">
-        <p14:creationId xmlns:p14="http://schemas.microsoft.com/office/powerpoint/2010/main" val="1823239707"/>
+        <p14:creationId xmlns:p14="http://schemas.microsoft.com/office/powerpoint/2010/main" val="1479217963"/>
       </p:ext>
     </p:extLst>
   </p:cSld>
@@ -7913,7 +7913,7 @@
           <p:nvPr/>
         </p:nvPicPr>
         <p:blipFill>
-          <a:blip xmlns:r="http://schemas.openxmlformats.org/officeDocument/2006/relationships" xmlns:a="http://schemas.openxmlformats.org/drawingml/2006/main" r:embed="R736ae0335551454c"/>
+          <a:blip xmlns:r="http://schemas.openxmlformats.org/officeDocument/2006/relationships" xmlns:a="http://schemas.openxmlformats.org/drawingml/2006/main" r:embed="Ra2ce5149afbe4d00"/>
           <a:stretch xmlns:a="http://schemas.openxmlformats.org/drawingml/2006/main"/>
         </p:blipFill>
         <p:spPr>
@@ -7929,7 +7929,7 @@
     </p:spTree>
     <p:extLst>
       <p:ext uri="{BB962C8B-B14F-4D97-AF65-F5344CB8AC3E}">
-        <p14:creationId xmlns:p14="http://schemas.microsoft.com/office/powerpoint/2010/main" val="531816877"/>
+        <p14:creationId xmlns:p14="http://schemas.microsoft.com/office/powerpoint/2010/main" val="477941256"/>
       </p:ext>
     </p:extLst>
   </p:cSld>

</xml_diff>

<commit_message>
Clarify Lecture 2 tariff question and welfare gains
</commit_message>
<xml_diff>
--- a/teaching/macro-applications/downloads/lecture_2.pptx
+++ b/teaching/macro-applications/downloads/lecture_2.pptx
@@ -2,38 +2,38 @@
 <file path=ppt/presentation.xml><?xml version="1.0" encoding="utf-8"?>
 <p:presentation xmlns:p="http://schemas.openxmlformats.org/presentationml/2006/main">
   <p:sldMasterIdLst>
-    <p:sldMasterId xmlns:r="http://schemas.openxmlformats.org/officeDocument/2006/relationships" id="2147483648" r:id="Ra4351ec6a08e4efd"/>
+    <p:sldMasterId xmlns:r="http://schemas.openxmlformats.org/officeDocument/2006/relationships" id="2147483648" r:id="Rd447f47e139243ef"/>
   </p:sldMasterIdLst>
   <p:notesMasterIdLst>
-    <p:notesMasterId xmlns:r="http://schemas.openxmlformats.org/officeDocument/2006/relationships" r:id="Ra8f9f98daaf64450"/>
+    <p:notesMasterId xmlns:r="http://schemas.openxmlformats.org/officeDocument/2006/relationships" r:id="Rf7c9aa6ecada4b1a"/>
   </p:notesMasterIdLst>
   <p:sldIdLst>
-    <p:sldId xmlns:r="http://schemas.openxmlformats.org/officeDocument/2006/relationships" id="256" r:id="R01f46237a53f4daf"/>
-    <p:sldId xmlns:r="http://schemas.openxmlformats.org/officeDocument/2006/relationships" id="257" r:id="Rad04b6e432d84915"/>
-    <p:sldId xmlns:r="http://schemas.openxmlformats.org/officeDocument/2006/relationships" id="258" r:id="R6a8cf57055b94271"/>
-    <p:sldId xmlns:r="http://schemas.openxmlformats.org/officeDocument/2006/relationships" id="259" r:id="Rb9e5581d3a804485"/>
-    <p:sldId xmlns:r="http://schemas.openxmlformats.org/officeDocument/2006/relationships" id="260" r:id="R7bfe6231bdc546b7"/>
-    <p:sldId xmlns:r="http://schemas.openxmlformats.org/officeDocument/2006/relationships" id="261" r:id="R2c3164c32e6348fa"/>
-    <p:sldId xmlns:r="http://schemas.openxmlformats.org/officeDocument/2006/relationships" id="262" r:id="Rc659bda866b341d9"/>
-    <p:sldId xmlns:r="http://schemas.openxmlformats.org/officeDocument/2006/relationships" id="263" r:id="R26fc504a73ee41a9"/>
-    <p:sldId xmlns:r="http://schemas.openxmlformats.org/officeDocument/2006/relationships" id="264" r:id="Re1f0170e1c85421a"/>
-    <p:sldId xmlns:r="http://schemas.openxmlformats.org/officeDocument/2006/relationships" id="265" r:id="Raaccb36f23894e00"/>
-    <p:sldId xmlns:r="http://schemas.openxmlformats.org/officeDocument/2006/relationships" id="266" r:id="R1195ed1e82e54356"/>
-    <p:sldId xmlns:r="http://schemas.openxmlformats.org/officeDocument/2006/relationships" id="267" r:id="R829fbbdb3c094989"/>
-    <p:sldId xmlns:r="http://schemas.openxmlformats.org/officeDocument/2006/relationships" id="268" r:id="Ra6103a8ed8b54572"/>
-    <p:sldId xmlns:r="http://schemas.openxmlformats.org/officeDocument/2006/relationships" id="269" r:id="Ra737208b4bd04552"/>
-    <p:sldId xmlns:r="http://schemas.openxmlformats.org/officeDocument/2006/relationships" id="270" r:id="Rad5ef4689adb4761"/>
-    <p:sldId xmlns:r="http://schemas.openxmlformats.org/officeDocument/2006/relationships" id="271" r:id="R762d365d07764276"/>
-    <p:sldId xmlns:r="http://schemas.openxmlformats.org/officeDocument/2006/relationships" id="272" r:id="Rb0f0e7dc09da43b8"/>
-    <p:sldId xmlns:r="http://schemas.openxmlformats.org/officeDocument/2006/relationships" id="273" r:id="R8e3b463dbd884b3d"/>
-    <p:sldId xmlns:r="http://schemas.openxmlformats.org/officeDocument/2006/relationships" id="274" r:id="R5dc748a8f3f14708"/>
-    <p:sldId xmlns:r="http://schemas.openxmlformats.org/officeDocument/2006/relationships" id="275" r:id="R5ae4273dfb9d48ee"/>
-    <p:sldId xmlns:r="http://schemas.openxmlformats.org/officeDocument/2006/relationships" id="276" r:id="R6a1f2370eb9845b4"/>
-    <p:sldId xmlns:r="http://schemas.openxmlformats.org/officeDocument/2006/relationships" id="277" r:id="R52c56af9d96b41b1"/>
-    <p:sldId xmlns:r="http://schemas.openxmlformats.org/officeDocument/2006/relationships" id="278" r:id="R1010825900404b2e"/>
-    <p:sldId xmlns:r="http://schemas.openxmlformats.org/officeDocument/2006/relationships" id="279" r:id="Re2c89f78d9734870"/>
-    <p:sldId xmlns:r="http://schemas.openxmlformats.org/officeDocument/2006/relationships" id="280" r:id="Rf028feea83494f38"/>
-    <p:sldId xmlns:r="http://schemas.openxmlformats.org/officeDocument/2006/relationships" id="281" r:id="R813eaa4d32d14bd6"/>
+    <p:sldId xmlns:r="http://schemas.openxmlformats.org/officeDocument/2006/relationships" id="256" r:id="R4ab6aade855144bf"/>
+    <p:sldId xmlns:r="http://schemas.openxmlformats.org/officeDocument/2006/relationships" id="257" r:id="Rd83125007cfc4119"/>
+    <p:sldId xmlns:r="http://schemas.openxmlformats.org/officeDocument/2006/relationships" id="258" r:id="Rfc82e965cfe94ad3"/>
+    <p:sldId xmlns:r="http://schemas.openxmlformats.org/officeDocument/2006/relationships" id="259" r:id="Re252efe5d0504c29"/>
+    <p:sldId xmlns:r="http://schemas.openxmlformats.org/officeDocument/2006/relationships" id="260" r:id="R83951f95c6774afd"/>
+    <p:sldId xmlns:r="http://schemas.openxmlformats.org/officeDocument/2006/relationships" id="261" r:id="R0e5a05e5816f47c3"/>
+    <p:sldId xmlns:r="http://schemas.openxmlformats.org/officeDocument/2006/relationships" id="262" r:id="Rb3216f6b58454fe8"/>
+    <p:sldId xmlns:r="http://schemas.openxmlformats.org/officeDocument/2006/relationships" id="263" r:id="R20479967366b49a9"/>
+    <p:sldId xmlns:r="http://schemas.openxmlformats.org/officeDocument/2006/relationships" id="264" r:id="R23c35cc875c64d25"/>
+    <p:sldId xmlns:r="http://schemas.openxmlformats.org/officeDocument/2006/relationships" id="265" r:id="R50aae14e15874f03"/>
+    <p:sldId xmlns:r="http://schemas.openxmlformats.org/officeDocument/2006/relationships" id="266" r:id="Ra4eb00d8c70c419b"/>
+    <p:sldId xmlns:r="http://schemas.openxmlformats.org/officeDocument/2006/relationships" id="267" r:id="Rc39468218a0b47a4"/>
+    <p:sldId xmlns:r="http://schemas.openxmlformats.org/officeDocument/2006/relationships" id="268" r:id="Rdac00ae97e9d465f"/>
+    <p:sldId xmlns:r="http://schemas.openxmlformats.org/officeDocument/2006/relationships" id="269" r:id="Rffea2039f4e34488"/>
+    <p:sldId xmlns:r="http://schemas.openxmlformats.org/officeDocument/2006/relationships" id="270" r:id="Re862448975ce40ce"/>
+    <p:sldId xmlns:r="http://schemas.openxmlformats.org/officeDocument/2006/relationships" id="271" r:id="R57b7dd21f1794efb"/>
+    <p:sldId xmlns:r="http://schemas.openxmlformats.org/officeDocument/2006/relationships" id="272" r:id="R833adca3d4c94a37"/>
+    <p:sldId xmlns:r="http://schemas.openxmlformats.org/officeDocument/2006/relationships" id="273" r:id="Redad785600684ccf"/>
+    <p:sldId xmlns:r="http://schemas.openxmlformats.org/officeDocument/2006/relationships" id="274" r:id="R330cf34639634b74"/>
+    <p:sldId xmlns:r="http://schemas.openxmlformats.org/officeDocument/2006/relationships" id="275" r:id="Rb3a304b6164549d6"/>
+    <p:sldId xmlns:r="http://schemas.openxmlformats.org/officeDocument/2006/relationships" id="276" r:id="Rb34bad00deea4b95"/>
+    <p:sldId xmlns:r="http://schemas.openxmlformats.org/officeDocument/2006/relationships" id="277" r:id="Rcbcd5e02e170466b"/>
+    <p:sldId xmlns:r="http://schemas.openxmlformats.org/officeDocument/2006/relationships" id="278" r:id="R561f9a3f195a4990"/>
+    <p:sldId xmlns:r="http://schemas.openxmlformats.org/officeDocument/2006/relationships" id="279" r:id="R2f4e887d68224fa9"/>
+    <p:sldId xmlns:r="http://schemas.openxmlformats.org/officeDocument/2006/relationships" id="280" r:id="Rde250d8fd56b4d01"/>
+    <p:sldId xmlns:r="http://schemas.openxmlformats.org/officeDocument/2006/relationships" id="281" r:id="R033f52af174a4c52"/>
   </p:sldIdLst>
   <p:sldSz cx="12192000" cy="6858000"/>
   <p:notesSz cx="6858000" cy="9144000"/>
@@ -223,16 +223,16 @@
         <a:srgbClr val="96607D"/>
       </a:folHlink>
     </a:clrScheme>
-    <a:fontScheme name="Office">
+    <a:fontScheme name="">
       <a:majorFont>
-        <a:latin typeface="Calibri Light"/>
-        <a:ea typeface="Calibri Light"/>
-        <a:cs typeface="Calibri Light"/>
+        <a:latin typeface="Aptos"/>
+        <a:ea typeface=""/>
+        <a:cs typeface=""/>
       </a:majorFont>
       <a:minorFont>
-        <a:latin typeface="Calibri"/>
-        <a:ea typeface="Calibri"/>
-        <a:cs typeface="Calibri"/>
+        <a:latin typeface="Aptos"/>
+        <a:ea typeface=""/>
+        <a:cs typeface=""/>
       </a:minorFont>
     </a:fontScheme>
     <a:fmtScheme name="ChatGPT">
@@ -2347,7 +2347,7 @@
           </a:p>
           <a:p xmlns:a="http://schemas.openxmlformats.org/drawingml/2006/main">
             <a:r>
-              <a:t>A = A₂ + A₃; the net welfare effect is A + B − C.</a:t>
+              <a:t>Green: gains A + B. Hatched orange: loss C.</a:t>
             </a:r>
           </a:p>
           <a:p xmlns:a="http://schemas.openxmlformats.org/drawingml/2006/main">
@@ -2727,7 +2727,7 @@
           </a:p>
           <a:p xmlns:a="http://schemas.openxmlformats.org/drawingml/2006/main">
             <a:r>
-              <a:t>The sign is ambiguous. Here, </a:t>
+              <a:t>Home gains if </a:t>
             </a:r>
           </a:p>
           <a:p xmlns:a="http://schemas.openxmlformats.org/drawingml/2006/main">
@@ -2737,7 +2737,32 @@
           </a:p>
           <a:p xmlns:a="http://schemas.openxmlformats.org/drawingml/2006/main">
             <a:r>
-              <a:t>=</a:t>
+              <a:t>+</a:t>
+            </a:r>
+          </a:p>
+          <a:p xmlns:a="http://schemas.openxmlformats.org/drawingml/2006/main">
+            <a:r>
+              <a:t>𝐵</a:t>
+            </a:r>
+          </a:p>
+          <a:p xmlns:a="http://schemas.openxmlformats.org/drawingml/2006/main">
+            <a:r>
+              <a:t>&gt;</a:t>
+            </a:r>
+          </a:p>
+          <a:p xmlns:a="http://schemas.openxmlformats.org/drawingml/2006/main">
+            <a:r>
+              <a:t>𝐶</a:t>
+            </a:r>
+          </a:p>
+          <a:p xmlns:a="http://schemas.openxmlformats.org/drawingml/2006/main">
+            <a:r>
+              <a:t>.</a:t>
+            </a:r>
+          </a:p>
+          <a:p xmlns:a="http://schemas.openxmlformats.org/drawingml/2006/main">
+            <a:r>
+              <a:t>Home loses if </a:t>
             </a:r>
           </a:p>
           <a:p xmlns:a="http://schemas.openxmlformats.org/drawingml/2006/main">
@@ -2747,22 +2772,22 @@
           </a:p>
           <a:p xmlns:a="http://schemas.openxmlformats.org/drawingml/2006/main">
             <a:r>
-              <a:t>2</a:t>
-            </a:r>
-          </a:p>
-          <a:p xmlns:a="http://schemas.openxmlformats.org/drawingml/2006/main">
-            <a:r>
               <a:t>+</a:t>
             </a:r>
           </a:p>
           <a:p xmlns:a="http://schemas.openxmlformats.org/drawingml/2006/main">
             <a:r>
-              <a:t>𝐴</a:t>
-            </a:r>
-          </a:p>
-          <a:p xmlns:a="http://schemas.openxmlformats.org/drawingml/2006/main">
-            <a:r>
-              <a:t>3</a:t>
+              <a:t>𝐵</a:t>
+            </a:r>
+          </a:p>
+          <a:p xmlns:a="http://schemas.openxmlformats.org/drawingml/2006/main">
+            <a:r>
+              <a:t>&lt;</a:t>
+            </a:r>
+          </a:p>
+          <a:p xmlns:a="http://schemas.openxmlformats.org/drawingml/2006/main">
+            <a:r>
+              <a:t>𝐶</a:t>
             </a:r>
           </a:p>
           <a:p xmlns:a="http://schemas.openxmlformats.org/drawingml/2006/main">
@@ -2787,7 +2812,7 @@
           </a:p>
           <a:p xmlns:a="http://schemas.openxmlformats.org/drawingml/2006/main">
             <a:r>
-              <a:t>RoW: Rest of the world</a:t>
+              <a:t>RoW: RoW: Rest of the world</a:t>
             </a:r>
           </a:p>
           <a:p xmlns:a="http://schemas.openxmlformats.org/drawingml/2006/main">
@@ -5477,17 +5502,7 @@
           </a:p>
           <a:p xmlns:a="http://schemas.openxmlformats.org/drawingml/2006/main">
             <a:r>
-              <a:t>Tariff removal: who benefits?</a:t>
-            </a:r>
-          </a:p>
-          <a:p xmlns:a="http://schemas.openxmlformats.org/drawingml/2006/main">
-            <a:r>
-              <a:t/>
-            </a:r>
-          </a:p>
-          <a:p xmlns:a="http://schemas.openxmlformats.org/drawingml/2006/main">
-            <a:r>
-              <a:t>Is the removal of tariff barriers beneficial for all countries involved?</a:t>
+              <a:t>Does removing tariff barriers benefit every country?</a:t>
             </a:r>
           </a:p>
           <a:p xmlns:a="http://schemas.openxmlformats.org/drawingml/2006/main">
@@ -6239,6 +6254,1661 @@
       <p:grpSpPr>
         <a:xfrm xmlns:a="http://schemas.openxmlformats.org/drawingml/2006/main"/>
       </p:grpSpPr>
+      <p:sp>
+        <p:nvSpPr>
+          <p:cNvPr id="3" name="Title">
+            <a:extLst xmlns:a="http://schemas.openxmlformats.org/drawingml/2006/main">
+              <a:ext uri="{FF2B5EF4-FFF2-40B4-BE49-F238E27FC236}">
+                <a16:creationId xmlns:a16="http://schemas.microsoft.com/office/drawing/2014/main" id="{2E92E0B9-A79C-4105-9673-2F3D1756E8C4}"/>
+              </a:ext>
+            </a:extLst>
+          </p:cNvPr>
+          <p:cNvSpPr>
+            <a:spLocks xmlns:a="http://schemas.openxmlformats.org/drawingml/2006/main" noGrp="1"/>
+          </p:cNvSpPr>
+          <p:nvPr>
+            <p:ph type="title" idx="0"/>
+          </p:nvPr>
+        </p:nvSpPr>
+        <p:spPr>
+          <a:xfrm xmlns:a="http://schemas.openxmlformats.org/drawingml/2006/main">
+            <a:off x="1219200" y="2590800"/>
+            <a:ext cx="9753600" cy="990600"/>
+          </a:xfrm>
+          <a:prstGeom xmlns:a="http://schemas.openxmlformats.org/drawingml/2006/main" prst="rect">
+            <a:avLst/>
+          </a:prstGeom>
+          <a:noFill xmlns:a="http://schemas.openxmlformats.org/drawingml/2006/main"/>
+          <a:ln xmlns:a="http://schemas.openxmlformats.org/drawingml/2006/main">
+            <a:noFill/>
+            <a:prstDash val="solid"/>
+          </a:ln>
+        </p:spPr>
+        <p:txBody>
+          <a:bodyPr xmlns:a="http://schemas.openxmlformats.org/drawingml/2006/main" wrap="square" lIns="0" tIns="0" rIns="0" bIns="0" anchor="ctr">
+            <a:normAutofit/>
+          </a:bodyPr>
+          <a:lstStyle xmlns:a="http://schemas.openxmlformats.org/drawingml/2006/main">
+            <a:defPPr algn="ctr">
+              <a:defRPr sz="4800" b="1">
+                <a:solidFill>
+                  <a:schemeClr val="tx1"/>
+                </a:solidFill>
+                <a:latin typeface="+mj-lt"/>
+                <a:ea typeface="+mj-lt"/>
+                <a:cs typeface="+mj-lt"/>
+              </a:defRPr>
+            </a:defPPr>
+            <a:lvl1pPr marL="0" indent="0">
+              <a:lnSpc>
+                <a:spcPct val="110000"/>
+              </a:lnSpc>
+              <a:spcBef>
+                <a:spcPts val="0"/>
+              </a:spcBef>
+              <a:spcAft>
+                <a:spcPts val="0"/>
+              </a:spcAft>
+              <a:buNone/>
+            </a:lvl1pPr>
+            <a:lvl2pPr marL="0" indent="0">
+              <a:lnSpc>
+                <a:spcPct val="110000"/>
+              </a:lnSpc>
+              <a:spcBef>
+                <a:spcPts val="0"/>
+              </a:spcBef>
+              <a:spcAft>
+                <a:spcPts val="0"/>
+              </a:spcAft>
+              <a:buNone/>
+            </a:lvl2pPr>
+            <a:lvl3pPr marL="0" indent="0">
+              <a:lnSpc>
+                <a:spcPct val="110000"/>
+              </a:lnSpc>
+              <a:spcBef>
+                <a:spcPts val="0"/>
+              </a:spcBef>
+              <a:spcAft>
+                <a:spcPts val="0"/>
+              </a:spcAft>
+              <a:buNone/>
+            </a:lvl3pPr>
+            <a:lvl4pPr marL="0" indent="0">
+              <a:lnSpc>
+                <a:spcPct val="110000"/>
+              </a:lnSpc>
+              <a:spcBef>
+                <a:spcPts val="0"/>
+              </a:spcBef>
+              <a:spcAft>
+                <a:spcPts val="0"/>
+              </a:spcAft>
+              <a:buNone/>
+            </a:lvl4pPr>
+            <a:lvl5pPr marL="0" indent="0">
+              <a:lnSpc>
+                <a:spcPct val="110000"/>
+              </a:lnSpc>
+              <a:spcBef>
+                <a:spcPts val="0"/>
+              </a:spcBef>
+              <a:spcAft>
+                <a:spcPts val="0"/>
+              </a:spcAft>
+              <a:buNone/>
+            </a:lvl5pPr>
+            <a:lvl6pPr marL="0" indent="0">
+              <a:lnSpc>
+                <a:spcPct val="110000"/>
+              </a:lnSpc>
+              <a:spcBef>
+                <a:spcPts val="0"/>
+              </a:spcBef>
+              <a:spcAft>
+                <a:spcPts val="0"/>
+              </a:spcAft>
+              <a:buNone/>
+            </a:lvl6pPr>
+            <a:lvl7pPr marL="0" indent="0">
+              <a:lnSpc>
+                <a:spcPct val="110000"/>
+              </a:lnSpc>
+              <a:spcBef>
+                <a:spcPts val="0"/>
+              </a:spcBef>
+              <a:spcAft>
+                <a:spcPts val="0"/>
+              </a:spcAft>
+              <a:buNone/>
+            </a:lvl7pPr>
+            <a:lvl8pPr marL="0" indent="0">
+              <a:lnSpc>
+                <a:spcPct val="110000"/>
+              </a:lnSpc>
+              <a:spcBef>
+                <a:spcPts val="0"/>
+              </a:spcBef>
+              <a:spcAft>
+                <a:spcPts val="0"/>
+              </a:spcAft>
+              <a:buNone/>
+            </a:lvl8pPr>
+            <a:lvl9pPr marL="0" indent="0">
+              <a:lnSpc>
+                <a:spcPct val="110000"/>
+              </a:lnSpc>
+              <a:spcBef>
+                <a:spcPts val="0"/>
+              </a:spcBef>
+              <a:spcAft>
+                <a:spcPts val="0"/>
+              </a:spcAft>
+              <a:buNone/>
+            </a:lvl9pPr>
+          </a:lstStyle>
+          <a:p xmlns:a="http://schemas.openxmlformats.org/drawingml/2006/main"/>
+        </p:txBody>
+      </p:sp>
+      <p:sp>
+        <p:nvSpPr>
+          <p:cNvPr id="2" name="Subtitle">
+            <a:extLst xmlns:a="http://schemas.openxmlformats.org/drawingml/2006/main">
+              <a:ext uri="{FF2B5EF4-FFF2-40B4-BE49-F238E27FC236}">
+                <a16:creationId xmlns:a16="http://schemas.microsoft.com/office/drawing/2014/main" id="{EB97ED20-721F-4456-9EF6-AAB3F922A425}"/>
+              </a:ext>
+            </a:extLst>
+          </p:cNvPr>
+          <p:cNvSpPr>
+            <a:spLocks xmlns:a="http://schemas.openxmlformats.org/drawingml/2006/main" noGrp="1"/>
+          </p:cNvSpPr>
+          <p:nvPr>
+            <p:ph type="subTitle" idx="1"/>
+          </p:nvPr>
+        </p:nvSpPr>
+        <p:spPr>
+          <a:xfrm xmlns:a="http://schemas.openxmlformats.org/drawingml/2006/main">
+            <a:off x="1828800" y="3771900"/>
+            <a:ext cx="8534400" cy="762000"/>
+          </a:xfrm>
+          <a:prstGeom xmlns:a="http://schemas.openxmlformats.org/drawingml/2006/main" prst="rect">
+            <a:avLst/>
+          </a:prstGeom>
+          <a:noFill xmlns:a="http://schemas.openxmlformats.org/drawingml/2006/main"/>
+          <a:ln xmlns:a="http://schemas.openxmlformats.org/drawingml/2006/main">
+            <a:noFill/>
+            <a:prstDash val="solid"/>
+          </a:ln>
+        </p:spPr>
+        <p:txBody>
+          <a:bodyPr xmlns:a="http://schemas.openxmlformats.org/drawingml/2006/main" wrap="square" lIns="0" tIns="0" rIns="0" bIns="0" anchor="ctr">
+            <a:normAutofit/>
+          </a:bodyPr>
+          <a:lstStyle xmlns:a="http://schemas.openxmlformats.org/drawingml/2006/main">
+            <a:defPPr algn="ctr">
+              <a:defRPr sz="2100" b="0">
+                <a:solidFill>
+                  <a:schemeClr val="tx1"/>
+                </a:solidFill>
+                <a:latin typeface="+mn-lt"/>
+                <a:ea typeface="+mn-lt"/>
+                <a:cs typeface="+mn-lt"/>
+              </a:defRPr>
+            </a:defPPr>
+            <a:lvl1pPr marL="0" indent="0">
+              <a:lnSpc>
+                <a:spcPct val="110000"/>
+              </a:lnSpc>
+              <a:spcBef>
+                <a:spcPts val="0"/>
+              </a:spcBef>
+              <a:spcAft>
+                <a:spcPts val="0"/>
+              </a:spcAft>
+              <a:buNone/>
+            </a:lvl1pPr>
+            <a:lvl2pPr marL="0" indent="0">
+              <a:lnSpc>
+                <a:spcPct val="110000"/>
+              </a:lnSpc>
+              <a:spcBef>
+                <a:spcPts val="0"/>
+              </a:spcBef>
+              <a:spcAft>
+                <a:spcPts val="0"/>
+              </a:spcAft>
+              <a:buNone/>
+            </a:lvl2pPr>
+            <a:lvl3pPr marL="0" indent="0">
+              <a:lnSpc>
+                <a:spcPct val="110000"/>
+              </a:lnSpc>
+              <a:spcBef>
+                <a:spcPts val="0"/>
+              </a:spcBef>
+              <a:spcAft>
+                <a:spcPts val="0"/>
+              </a:spcAft>
+              <a:buNone/>
+            </a:lvl3pPr>
+            <a:lvl4pPr marL="0" indent="0">
+              <a:lnSpc>
+                <a:spcPct val="110000"/>
+              </a:lnSpc>
+              <a:spcBef>
+                <a:spcPts val="0"/>
+              </a:spcBef>
+              <a:spcAft>
+                <a:spcPts val="0"/>
+              </a:spcAft>
+              <a:buNone/>
+            </a:lvl4pPr>
+            <a:lvl5pPr marL="0" indent="0">
+              <a:lnSpc>
+                <a:spcPct val="110000"/>
+              </a:lnSpc>
+              <a:spcBef>
+                <a:spcPts val="0"/>
+              </a:spcBef>
+              <a:spcAft>
+                <a:spcPts val="0"/>
+              </a:spcAft>
+              <a:buNone/>
+            </a:lvl5pPr>
+            <a:lvl6pPr marL="0" indent="0">
+              <a:lnSpc>
+                <a:spcPct val="110000"/>
+              </a:lnSpc>
+              <a:spcBef>
+                <a:spcPts val="0"/>
+              </a:spcBef>
+              <a:spcAft>
+                <a:spcPts val="0"/>
+              </a:spcAft>
+              <a:buNone/>
+            </a:lvl6pPr>
+            <a:lvl7pPr marL="0" indent="0">
+              <a:lnSpc>
+                <a:spcPct val="110000"/>
+              </a:lnSpc>
+              <a:spcBef>
+                <a:spcPts val="0"/>
+              </a:spcBef>
+              <a:spcAft>
+                <a:spcPts val="0"/>
+              </a:spcAft>
+              <a:buNone/>
+            </a:lvl7pPr>
+            <a:lvl8pPr marL="0" indent="0">
+              <a:lnSpc>
+                <a:spcPct val="110000"/>
+              </a:lnSpc>
+              <a:spcBef>
+                <a:spcPts val="0"/>
+              </a:spcBef>
+              <a:spcAft>
+                <a:spcPts val="0"/>
+              </a:spcAft>
+              <a:buNone/>
+            </a:lvl8pPr>
+            <a:lvl9pPr marL="0" indent="0">
+              <a:lnSpc>
+                <a:spcPct val="110000"/>
+              </a:lnSpc>
+              <a:spcBef>
+                <a:spcPts val="0"/>
+              </a:spcBef>
+              <a:spcAft>
+                <a:spcPts val="0"/>
+              </a:spcAft>
+              <a:buNone/>
+            </a:lvl9pPr>
+          </a:lstStyle>
+          <a:p xmlns:a="http://schemas.openxmlformats.org/drawingml/2006/main"/>
+        </p:txBody>
+      </p:sp>
+    </p:spTree>
+  </p:cSld>
+</p:sldLayout>
+</file>
+
+<file path=ppt/slideLayouts/slideLayout2.xml><?xml version="1.0" encoding="utf-8"?>
+<p:sldLayout xmlns:p="http://schemas.openxmlformats.org/presentationml/2006/main">
+  <p:cSld name="Section Header">
+    <p:spTree>
+      <p:nvGrpSpPr>
+        <p:cNvPr id="1" name=""/>
+        <p:cNvGrpSpPr/>
+        <p:nvPr/>
+      </p:nvGrpSpPr>
+      <p:grpSpPr>
+        <a:xfrm xmlns:a="http://schemas.openxmlformats.org/drawingml/2006/main"/>
+      </p:grpSpPr>
+      <p:sp>
+        <p:nvSpPr>
+          <p:cNvPr id="2" name="Section title">
+            <a:extLst xmlns:a="http://schemas.openxmlformats.org/drawingml/2006/main">
+              <a:ext uri="{FF2B5EF4-FFF2-40B4-BE49-F238E27FC236}">
+                <a16:creationId xmlns:a16="http://schemas.microsoft.com/office/drawing/2014/main" id="{21E69D2C-7D13-4127-8CB0-6AD63D5BBE45}"/>
+              </a:ext>
+            </a:extLst>
+          </p:cNvPr>
+          <p:cNvSpPr>
+            <a:spLocks xmlns:a="http://schemas.openxmlformats.org/drawingml/2006/main" noGrp="1"/>
+          </p:cNvSpPr>
+          <p:nvPr>
+            <p:ph type="title" idx="0"/>
+          </p:nvPr>
+        </p:nvSpPr>
+        <p:spPr>
+          <a:xfrm xmlns:a="http://schemas.openxmlformats.org/drawingml/2006/main">
+            <a:off x="1219200" y="2857500"/>
+            <a:ext cx="9753600" cy="1143000"/>
+          </a:xfrm>
+          <a:prstGeom xmlns:a="http://schemas.openxmlformats.org/drawingml/2006/main" prst="rect">
+            <a:avLst/>
+          </a:prstGeom>
+          <a:noFill xmlns:a="http://schemas.openxmlformats.org/drawingml/2006/main"/>
+          <a:ln xmlns:a="http://schemas.openxmlformats.org/drawingml/2006/main">
+            <a:noFill/>
+            <a:prstDash val="solid"/>
+          </a:ln>
+        </p:spPr>
+        <p:txBody>
+          <a:bodyPr xmlns:a="http://schemas.openxmlformats.org/drawingml/2006/main" wrap="square" lIns="0" tIns="0" rIns="0" bIns="0" anchor="ctr">
+            <a:normAutofit/>
+          </a:bodyPr>
+          <a:lstStyle xmlns:a="http://schemas.openxmlformats.org/drawingml/2006/main">
+            <a:defPPr algn="ctr">
+              <a:defRPr sz="4200" b="1">
+                <a:solidFill>
+                  <a:schemeClr val="tx1"/>
+                </a:solidFill>
+                <a:latin typeface="+mj-lt"/>
+                <a:ea typeface="+mj-lt"/>
+                <a:cs typeface="+mj-lt"/>
+              </a:defRPr>
+            </a:defPPr>
+            <a:lvl1pPr marL="0" indent="0">
+              <a:lnSpc>
+                <a:spcPct val="110000"/>
+              </a:lnSpc>
+              <a:spcBef>
+                <a:spcPts val="0"/>
+              </a:spcBef>
+              <a:spcAft>
+                <a:spcPts val="0"/>
+              </a:spcAft>
+              <a:buNone/>
+            </a:lvl1pPr>
+            <a:lvl2pPr marL="0" indent="0">
+              <a:lnSpc>
+                <a:spcPct val="110000"/>
+              </a:lnSpc>
+              <a:spcBef>
+                <a:spcPts val="0"/>
+              </a:spcBef>
+              <a:spcAft>
+                <a:spcPts val="0"/>
+              </a:spcAft>
+              <a:buNone/>
+            </a:lvl2pPr>
+            <a:lvl3pPr marL="0" indent="0">
+              <a:lnSpc>
+                <a:spcPct val="110000"/>
+              </a:lnSpc>
+              <a:spcBef>
+                <a:spcPts val="0"/>
+              </a:spcBef>
+              <a:spcAft>
+                <a:spcPts val="0"/>
+              </a:spcAft>
+              <a:buNone/>
+            </a:lvl3pPr>
+            <a:lvl4pPr marL="0" indent="0">
+              <a:lnSpc>
+                <a:spcPct val="110000"/>
+              </a:lnSpc>
+              <a:spcBef>
+                <a:spcPts val="0"/>
+              </a:spcBef>
+              <a:spcAft>
+                <a:spcPts val="0"/>
+              </a:spcAft>
+              <a:buNone/>
+            </a:lvl4pPr>
+            <a:lvl5pPr marL="0" indent="0">
+              <a:lnSpc>
+                <a:spcPct val="110000"/>
+              </a:lnSpc>
+              <a:spcBef>
+                <a:spcPts val="0"/>
+              </a:spcBef>
+              <a:spcAft>
+                <a:spcPts val="0"/>
+              </a:spcAft>
+              <a:buNone/>
+            </a:lvl5pPr>
+            <a:lvl6pPr marL="0" indent="0">
+              <a:lnSpc>
+                <a:spcPct val="110000"/>
+              </a:lnSpc>
+              <a:spcBef>
+                <a:spcPts val="0"/>
+              </a:spcBef>
+              <a:spcAft>
+                <a:spcPts val="0"/>
+              </a:spcAft>
+              <a:buNone/>
+            </a:lvl6pPr>
+            <a:lvl7pPr marL="0" indent="0">
+              <a:lnSpc>
+                <a:spcPct val="110000"/>
+              </a:lnSpc>
+              <a:spcBef>
+                <a:spcPts val="0"/>
+              </a:spcBef>
+              <a:spcAft>
+                <a:spcPts val="0"/>
+              </a:spcAft>
+              <a:buNone/>
+            </a:lvl7pPr>
+            <a:lvl8pPr marL="0" indent="0">
+              <a:lnSpc>
+                <a:spcPct val="110000"/>
+              </a:lnSpc>
+              <a:spcBef>
+                <a:spcPts val="0"/>
+              </a:spcBef>
+              <a:spcAft>
+                <a:spcPts val="0"/>
+              </a:spcAft>
+              <a:buNone/>
+            </a:lvl8pPr>
+            <a:lvl9pPr marL="0" indent="0">
+              <a:lnSpc>
+                <a:spcPct val="110000"/>
+              </a:lnSpc>
+              <a:spcBef>
+                <a:spcPts val="0"/>
+              </a:spcBef>
+              <a:spcAft>
+                <a:spcPts val="0"/>
+              </a:spcAft>
+              <a:buNone/>
+            </a:lvl9pPr>
+          </a:lstStyle>
+          <a:p xmlns:a="http://schemas.openxmlformats.org/drawingml/2006/main"/>
+        </p:txBody>
+      </p:sp>
+    </p:spTree>
+  </p:cSld>
+</p:sldLayout>
+</file>
+
+<file path=ppt/slideLayouts/slideLayout3.xml><?xml version="1.0" encoding="utf-8"?>
+<p:sldLayout xmlns:p="http://schemas.openxmlformats.org/presentationml/2006/main">
+  <p:cSld name="Title and Body">
+    <p:spTree>
+      <p:nvGrpSpPr>
+        <p:cNvPr id="1" name=""/>
+        <p:cNvGrpSpPr/>
+        <p:nvPr/>
+      </p:nvGrpSpPr>
+      <p:grpSpPr>
+        <a:xfrm xmlns:a="http://schemas.openxmlformats.org/drawingml/2006/main"/>
+      </p:grpSpPr>
+      <p:sp>
+        <p:nvSpPr>
+          <p:cNvPr id="3" name="Title">
+            <a:extLst xmlns:a="http://schemas.openxmlformats.org/drawingml/2006/main">
+              <a:ext uri="{FF2B5EF4-FFF2-40B4-BE49-F238E27FC236}">
+                <a16:creationId xmlns:a16="http://schemas.microsoft.com/office/drawing/2014/main" id="{87C1CB98-DBCE-4CAA-9B3F-2124C8673572}"/>
+              </a:ext>
+            </a:extLst>
+          </p:cNvPr>
+          <p:cNvSpPr>
+            <a:spLocks xmlns:a="http://schemas.openxmlformats.org/drawingml/2006/main" noGrp="1"/>
+          </p:cNvSpPr>
+          <p:nvPr>
+            <p:ph type="title" idx="0"/>
+          </p:nvPr>
+        </p:nvSpPr>
+        <p:spPr>
+          <a:xfrm xmlns:a="http://schemas.openxmlformats.org/drawingml/2006/main">
+            <a:off x="685800" y="533400"/>
+            <a:ext cx="10820400" cy="838200"/>
+          </a:xfrm>
+          <a:prstGeom xmlns:a="http://schemas.openxmlformats.org/drawingml/2006/main" prst="rect">
+            <a:avLst/>
+          </a:prstGeom>
+          <a:noFill xmlns:a="http://schemas.openxmlformats.org/drawingml/2006/main"/>
+          <a:ln xmlns:a="http://schemas.openxmlformats.org/drawingml/2006/main">
+            <a:noFill/>
+            <a:prstDash val="solid"/>
+          </a:ln>
+        </p:spPr>
+        <p:txBody>
+          <a:bodyPr xmlns:a="http://schemas.openxmlformats.org/drawingml/2006/main" wrap="square" lIns="0" tIns="0" rIns="0" bIns="0" anchor="t">
+            <a:normAutofit/>
+          </a:bodyPr>
+          <a:lstStyle xmlns:a="http://schemas.openxmlformats.org/drawingml/2006/main">
+            <a:defPPr algn="l">
+              <a:defRPr sz="3300" b="1">
+                <a:solidFill>
+                  <a:schemeClr val="tx1"/>
+                </a:solidFill>
+                <a:latin typeface="+mj-lt"/>
+                <a:ea typeface="+mj-lt"/>
+                <a:cs typeface="+mj-lt"/>
+              </a:defRPr>
+            </a:defPPr>
+            <a:lvl1pPr marL="0" indent="0">
+              <a:lnSpc>
+                <a:spcPct val="110000"/>
+              </a:lnSpc>
+              <a:spcBef>
+                <a:spcPts val="0"/>
+              </a:spcBef>
+              <a:spcAft>
+                <a:spcPts val="0"/>
+              </a:spcAft>
+              <a:buNone/>
+            </a:lvl1pPr>
+            <a:lvl2pPr marL="0" indent="0">
+              <a:lnSpc>
+                <a:spcPct val="110000"/>
+              </a:lnSpc>
+              <a:spcBef>
+                <a:spcPts val="0"/>
+              </a:spcBef>
+              <a:spcAft>
+                <a:spcPts val="0"/>
+              </a:spcAft>
+              <a:buNone/>
+            </a:lvl2pPr>
+            <a:lvl3pPr marL="0" indent="0">
+              <a:lnSpc>
+                <a:spcPct val="110000"/>
+              </a:lnSpc>
+              <a:spcBef>
+                <a:spcPts val="0"/>
+              </a:spcBef>
+              <a:spcAft>
+                <a:spcPts val="0"/>
+              </a:spcAft>
+              <a:buNone/>
+            </a:lvl3pPr>
+            <a:lvl4pPr marL="0" indent="0">
+              <a:lnSpc>
+                <a:spcPct val="110000"/>
+              </a:lnSpc>
+              <a:spcBef>
+                <a:spcPts val="0"/>
+              </a:spcBef>
+              <a:spcAft>
+                <a:spcPts val="0"/>
+              </a:spcAft>
+              <a:buNone/>
+            </a:lvl4pPr>
+            <a:lvl5pPr marL="0" indent="0">
+              <a:lnSpc>
+                <a:spcPct val="110000"/>
+              </a:lnSpc>
+              <a:spcBef>
+                <a:spcPts val="0"/>
+              </a:spcBef>
+              <a:spcAft>
+                <a:spcPts val="0"/>
+              </a:spcAft>
+              <a:buNone/>
+            </a:lvl5pPr>
+            <a:lvl6pPr marL="0" indent="0">
+              <a:lnSpc>
+                <a:spcPct val="110000"/>
+              </a:lnSpc>
+              <a:spcBef>
+                <a:spcPts val="0"/>
+              </a:spcBef>
+              <a:spcAft>
+                <a:spcPts val="0"/>
+              </a:spcAft>
+              <a:buNone/>
+            </a:lvl6pPr>
+            <a:lvl7pPr marL="0" indent="0">
+              <a:lnSpc>
+                <a:spcPct val="110000"/>
+              </a:lnSpc>
+              <a:spcBef>
+                <a:spcPts val="0"/>
+              </a:spcBef>
+              <a:spcAft>
+                <a:spcPts val="0"/>
+              </a:spcAft>
+              <a:buNone/>
+            </a:lvl7pPr>
+            <a:lvl8pPr marL="0" indent="0">
+              <a:lnSpc>
+                <a:spcPct val="110000"/>
+              </a:lnSpc>
+              <a:spcBef>
+                <a:spcPts val="0"/>
+              </a:spcBef>
+              <a:spcAft>
+                <a:spcPts val="0"/>
+              </a:spcAft>
+              <a:buNone/>
+            </a:lvl8pPr>
+            <a:lvl9pPr marL="0" indent="0">
+              <a:lnSpc>
+                <a:spcPct val="110000"/>
+              </a:lnSpc>
+              <a:spcBef>
+                <a:spcPts val="0"/>
+              </a:spcBef>
+              <a:spcAft>
+                <a:spcPts val="0"/>
+              </a:spcAft>
+              <a:buNone/>
+            </a:lvl9pPr>
+          </a:lstStyle>
+          <a:p xmlns:a="http://schemas.openxmlformats.org/drawingml/2006/main"/>
+        </p:txBody>
+      </p:sp>
+      <p:sp>
+        <p:nvSpPr>
+          <p:cNvPr id="2" name="Body">
+            <a:extLst xmlns:a="http://schemas.openxmlformats.org/drawingml/2006/main">
+              <a:ext uri="{FF2B5EF4-FFF2-40B4-BE49-F238E27FC236}">
+                <a16:creationId xmlns:a16="http://schemas.microsoft.com/office/drawing/2014/main" id="{22D664A7-73B6-4F07-8D0C-E2AC8DD10945}"/>
+              </a:ext>
+            </a:extLst>
+          </p:cNvPr>
+          <p:cNvSpPr>
+            <a:spLocks xmlns:a="http://schemas.openxmlformats.org/drawingml/2006/main" noGrp="1"/>
+          </p:cNvSpPr>
+          <p:nvPr>
+            <p:ph type="body" idx="1"/>
+          </p:nvPr>
+        </p:nvSpPr>
+        <p:spPr>
+          <a:xfrm xmlns:a="http://schemas.openxmlformats.org/drawingml/2006/main">
+            <a:off x="685800" y="1905000"/>
+            <a:ext cx="10820400" cy="4267200"/>
+          </a:xfrm>
+          <a:prstGeom xmlns:a="http://schemas.openxmlformats.org/drawingml/2006/main" prst="rect">
+            <a:avLst/>
+          </a:prstGeom>
+          <a:noFill xmlns:a="http://schemas.openxmlformats.org/drawingml/2006/main"/>
+          <a:ln xmlns:a="http://schemas.openxmlformats.org/drawingml/2006/main">
+            <a:noFill/>
+            <a:prstDash val="solid"/>
+          </a:ln>
+        </p:spPr>
+        <p:txBody>
+          <a:bodyPr xmlns:a="http://schemas.openxmlformats.org/drawingml/2006/main" wrap="square" lIns="0" tIns="0" rIns="0" bIns="0" anchor="t">
+            <a:normAutofit/>
+          </a:bodyPr>
+          <a:lstStyle xmlns:a="http://schemas.openxmlformats.org/drawingml/2006/main">
+            <a:defPPr algn="l">
+              <a:defRPr sz="2250" b="0">
+                <a:solidFill>
+                  <a:schemeClr val="tx1"/>
+                </a:solidFill>
+                <a:latin typeface="+mn-lt"/>
+                <a:ea typeface="+mn-lt"/>
+                <a:cs typeface="+mn-lt"/>
+              </a:defRPr>
+            </a:defPPr>
+            <a:lvl1pPr marL="228600" indent="-228600">
+              <a:lnSpc>
+                <a:spcPct val="110000"/>
+              </a:lnSpc>
+              <a:spcBef>
+                <a:spcPts val="0"/>
+              </a:spcBef>
+              <a:spcAft>
+                <a:spcPts val="1200"/>
+              </a:spcAft>
+              <a:buChar char="•"/>
+            </a:lvl1pPr>
+            <a:lvl2pPr marL="533400" indent="-228600">
+              <a:lnSpc>
+                <a:spcPct val="110000"/>
+              </a:lnSpc>
+              <a:spcBef>
+                <a:spcPts val="0"/>
+              </a:spcBef>
+              <a:spcAft>
+                <a:spcPts val="1200"/>
+              </a:spcAft>
+              <a:buChar char="•"/>
+            </a:lvl2pPr>
+            <a:lvl3pPr marL="838200" indent="-228600">
+              <a:lnSpc>
+                <a:spcPct val="110000"/>
+              </a:lnSpc>
+              <a:spcBef>
+                <a:spcPts val="0"/>
+              </a:spcBef>
+              <a:spcAft>
+                <a:spcPts val="1200"/>
+              </a:spcAft>
+              <a:buChar char="•"/>
+            </a:lvl3pPr>
+            <a:lvl4pPr marL="1143000" indent="-228600">
+              <a:lnSpc>
+                <a:spcPct val="110000"/>
+              </a:lnSpc>
+              <a:spcBef>
+                <a:spcPts val="0"/>
+              </a:spcBef>
+              <a:spcAft>
+                <a:spcPts val="1200"/>
+              </a:spcAft>
+              <a:buChar char="•"/>
+            </a:lvl4pPr>
+            <a:lvl5pPr marL="1447800" indent="-228600">
+              <a:lnSpc>
+                <a:spcPct val="110000"/>
+              </a:lnSpc>
+              <a:spcBef>
+                <a:spcPts val="0"/>
+              </a:spcBef>
+              <a:spcAft>
+                <a:spcPts val="1200"/>
+              </a:spcAft>
+              <a:buChar char="•"/>
+            </a:lvl5pPr>
+            <a:lvl6pPr marL="1752600" indent="-228600">
+              <a:lnSpc>
+                <a:spcPct val="110000"/>
+              </a:lnSpc>
+              <a:spcBef>
+                <a:spcPts val="0"/>
+              </a:spcBef>
+              <a:spcAft>
+                <a:spcPts val="1200"/>
+              </a:spcAft>
+              <a:buChar char="•"/>
+            </a:lvl6pPr>
+            <a:lvl7pPr marL="2057400" indent="-228600">
+              <a:lnSpc>
+                <a:spcPct val="110000"/>
+              </a:lnSpc>
+              <a:spcBef>
+                <a:spcPts val="0"/>
+              </a:spcBef>
+              <a:spcAft>
+                <a:spcPts val="1200"/>
+              </a:spcAft>
+              <a:buChar char="•"/>
+            </a:lvl7pPr>
+            <a:lvl8pPr marL="2362200" indent="-228600">
+              <a:lnSpc>
+                <a:spcPct val="110000"/>
+              </a:lnSpc>
+              <a:spcBef>
+                <a:spcPts val="0"/>
+              </a:spcBef>
+              <a:spcAft>
+                <a:spcPts val="1200"/>
+              </a:spcAft>
+              <a:buChar char="•"/>
+            </a:lvl8pPr>
+            <a:lvl9pPr marL="2667000" indent="-228600">
+              <a:lnSpc>
+                <a:spcPct val="110000"/>
+              </a:lnSpc>
+              <a:spcBef>
+                <a:spcPts val="0"/>
+              </a:spcBef>
+              <a:spcAft>
+                <a:spcPts val="1200"/>
+              </a:spcAft>
+              <a:buChar char="•"/>
+            </a:lvl9pPr>
+          </a:lstStyle>
+          <a:p xmlns:a="http://schemas.openxmlformats.org/drawingml/2006/main"/>
+        </p:txBody>
+      </p:sp>
+    </p:spTree>
+  </p:cSld>
+</p:sldLayout>
+</file>
+
+<file path=ppt/slideLayouts/slideLayout4.xml><?xml version="1.0" encoding="utf-8"?>
+<p:sldLayout xmlns:p="http://schemas.openxmlformats.org/presentationml/2006/main">
+  <p:cSld name="Title and Two Column">
+    <p:spTree>
+      <p:nvGrpSpPr>
+        <p:cNvPr id="1" name=""/>
+        <p:cNvGrpSpPr/>
+        <p:nvPr/>
+      </p:nvGrpSpPr>
+      <p:grpSpPr>
+        <a:xfrm xmlns:a="http://schemas.openxmlformats.org/drawingml/2006/main"/>
+      </p:grpSpPr>
+      <p:sp>
+        <p:nvSpPr>
+          <p:cNvPr id="4" name="Title">
+            <a:extLst xmlns:a="http://schemas.openxmlformats.org/drawingml/2006/main">
+              <a:ext uri="{FF2B5EF4-FFF2-40B4-BE49-F238E27FC236}">
+                <a16:creationId xmlns:a16="http://schemas.microsoft.com/office/drawing/2014/main" id="{B4949B8E-FEF1-47BE-BD26-07609B839552}"/>
+              </a:ext>
+            </a:extLst>
+          </p:cNvPr>
+          <p:cNvSpPr>
+            <a:spLocks xmlns:a="http://schemas.openxmlformats.org/drawingml/2006/main" noGrp="1"/>
+          </p:cNvSpPr>
+          <p:nvPr>
+            <p:ph type="title" idx="0"/>
+          </p:nvPr>
+        </p:nvSpPr>
+        <p:spPr>
+          <a:xfrm xmlns:a="http://schemas.openxmlformats.org/drawingml/2006/main">
+            <a:off x="685800" y="533400"/>
+            <a:ext cx="10820400" cy="838200"/>
+          </a:xfrm>
+          <a:prstGeom xmlns:a="http://schemas.openxmlformats.org/drawingml/2006/main" prst="rect">
+            <a:avLst/>
+          </a:prstGeom>
+          <a:noFill xmlns:a="http://schemas.openxmlformats.org/drawingml/2006/main"/>
+          <a:ln xmlns:a="http://schemas.openxmlformats.org/drawingml/2006/main">
+            <a:noFill/>
+            <a:prstDash val="solid"/>
+          </a:ln>
+        </p:spPr>
+        <p:txBody>
+          <a:bodyPr xmlns:a="http://schemas.openxmlformats.org/drawingml/2006/main" wrap="square" lIns="0" tIns="0" rIns="0" bIns="0" anchor="t">
+            <a:normAutofit/>
+          </a:bodyPr>
+          <a:lstStyle xmlns:a="http://schemas.openxmlformats.org/drawingml/2006/main">
+            <a:defPPr algn="l">
+              <a:defRPr sz="3300" b="1">
+                <a:solidFill>
+                  <a:schemeClr val="tx1"/>
+                </a:solidFill>
+                <a:latin typeface="+mj-lt"/>
+                <a:ea typeface="+mj-lt"/>
+                <a:cs typeface="+mj-lt"/>
+              </a:defRPr>
+            </a:defPPr>
+            <a:lvl1pPr marL="0" indent="0">
+              <a:lnSpc>
+                <a:spcPct val="110000"/>
+              </a:lnSpc>
+              <a:spcBef>
+                <a:spcPts val="0"/>
+              </a:spcBef>
+              <a:spcAft>
+                <a:spcPts val="0"/>
+              </a:spcAft>
+              <a:buNone/>
+            </a:lvl1pPr>
+            <a:lvl2pPr marL="0" indent="0">
+              <a:lnSpc>
+                <a:spcPct val="110000"/>
+              </a:lnSpc>
+              <a:spcBef>
+                <a:spcPts val="0"/>
+              </a:spcBef>
+              <a:spcAft>
+                <a:spcPts val="0"/>
+              </a:spcAft>
+              <a:buNone/>
+            </a:lvl2pPr>
+            <a:lvl3pPr marL="0" indent="0">
+              <a:lnSpc>
+                <a:spcPct val="110000"/>
+              </a:lnSpc>
+              <a:spcBef>
+                <a:spcPts val="0"/>
+              </a:spcBef>
+              <a:spcAft>
+                <a:spcPts val="0"/>
+              </a:spcAft>
+              <a:buNone/>
+            </a:lvl3pPr>
+            <a:lvl4pPr marL="0" indent="0">
+              <a:lnSpc>
+                <a:spcPct val="110000"/>
+              </a:lnSpc>
+              <a:spcBef>
+                <a:spcPts val="0"/>
+              </a:spcBef>
+              <a:spcAft>
+                <a:spcPts val="0"/>
+              </a:spcAft>
+              <a:buNone/>
+            </a:lvl4pPr>
+            <a:lvl5pPr marL="0" indent="0">
+              <a:lnSpc>
+                <a:spcPct val="110000"/>
+              </a:lnSpc>
+              <a:spcBef>
+                <a:spcPts val="0"/>
+              </a:spcBef>
+              <a:spcAft>
+                <a:spcPts val="0"/>
+              </a:spcAft>
+              <a:buNone/>
+            </a:lvl5pPr>
+            <a:lvl6pPr marL="0" indent="0">
+              <a:lnSpc>
+                <a:spcPct val="110000"/>
+              </a:lnSpc>
+              <a:spcBef>
+                <a:spcPts val="0"/>
+              </a:spcBef>
+              <a:spcAft>
+                <a:spcPts val="0"/>
+              </a:spcAft>
+              <a:buNone/>
+            </a:lvl6pPr>
+            <a:lvl7pPr marL="0" indent="0">
+              <a:lnSpc>
+                <a:spcPct val="110000"/>
+              </a:lnSpc>
+              <a:spcBef>
+                <a:spcPts val="0"/>
+              </a:spcBef>
+              <a:spcAft>
+                <a:spcPts val="0"/>
+              </a:spcAft>
+              <a:buNone/>
+            </a:lvl7pPr>
+            <a:lvl8pPr marL="0" indent="0">
+              <a:lnSpc>
+                <a:spcPct val="110000"/>
+              </a:lnSpc>
+              <a:spcBef>
+                <a:spcPts val="0"/>
+              </a:spcBef>
+              <a:spcAft>
+                <a:spcPts val="0"/>
+              </a:spcAft>
+              <a:buNone/>
+            </a:lvl8pPr>
+            <a:lvl9pPr marL="0" indent="0">
+              <a:lnSpc>
+                <a:spcPct val="110000"/>
+              </a:lnSpc>
+              <a:spcBef>
+                <a:spcPts val="0"/>
+              </a:spcBef>
+              <a:spcAft>
+                <a:spcPts val="0"/>
+              </a:spcAft>
+              <a:buNone/>
+            </a:lvl9pPr>
+          </a:lstStyle>
+          <a:p xmlns:a="http://schemas.openxmlformats.org/drawingml/2006/main"/>
+        </p:txBody>
+      </p:sp>
+      <p:sp>
+        <p:nvSpPr>
+          <p:cNvPr id="2" name="Left column">
+            <a:extLst xmlns:a="http://schemas.openxmlformats.org/drawingml/2006/main">
+              <a:ext uri="{FF2B5EF4-FFF2-40B4-BE49-F238E27FC236}">
+                <a16:creationId xmlns:a16="http://schemas.microsoft.com/office/drawing/2014/main" id="{FE496C65-D2AF-4EDB-BBC7-2A07CBE7720E}"/>
+              </a:ext>
+            </a:extLst>
+          </p:cNvPr>
+          <p:cNvSpPr>
+            <a:spLocks xmlns:a="http://schemas.openxmlformats.org/drawingml/2006/main" noGrp="1"/>
+          </p:cNvSpPr>
+          <p:nvPr>
+            <p:ph type="body" idx="1"/>
+          </p:nvPr>
+        </p:nvSpPr>
+        <p:spPr>
+          <a:xfrm xmlns:a="http://schemas.openxmlformats.org/drawingml/2006/main">
+            <a:off x="685800" y="1905000"/>
+            <a:ext cx="5029200" cy="4267200"/>
+          </a:xfrm>
+          <a:prstGeom xmlns:a="http://schemas.openxmlformats.org/drawingml/2006/main" prst="rect">
+            <a:avLst/>
+          </a:prstGeom>
+          <a:noFill xmlns:a="http://schemas.openxmlformats.org/drawingml/2006/main"/>
+          <a:ln xmlns:a="http://schemas.openxmlformats.org/drawingml/2006/main">
+            <a:noFill/>
+            <a:prstDash val="solid"/>
+          </a:ln>
+        </p:spPr>
+        <p:txBody>
+          <a:bodyPr xmlns:a="http://schemas.openxmlformats.org/drawingml/2006/main" wrap="square" lIns="0" tIns="0" rIns="0" bIns="0" anchor="t">
+            <a:normAutofit/>
+          </a:bodyPr>
+          <a:lstStyle xmlns:a="http://schemas.openxmlformats.org/drawingml/2006/main">
+            <a:defPPr algn="l">
+              <a:defRPr sz="2100" b="0">
+                <a:solidFill>
+                  <a:schemeClr val="tx1"/>
+                </a:solidFill>
+                <a:latin typeface="+mn-lt"/>
+                <a:ea typeface="+mn-lt"/>
+                <a:cs typeface="+mn-lt"/>
+              </a:defRPr>
+            </a:defPPr>
+            <a:lvl1pPr marL="228600" indent="-228600">
+              <a:lnSpc>
+                <a:spcPct val="110000"/>
+              </a:lnSpc>
+              <a:spcBef>
+                <a:spcPts val="0"/>
+              </a:spcBef>
+              <a:spcAft>
+                <a:spcPts val="1200"/>
+              </a:spcAft>
+              <a:buChar char="•"/>
+            </a:lvl1pPr>
+            <a:lvl2pPr marL="533400" indent="-228600">
+              <a:lnSpc>
+                <a:spcPct val="110000"/>
+              </a:lnSpc>
+              <a:spcBef>
+                <a:spcPts val="0"/>
+              </a:spcBef>
+              <a:spcAft>
+                <a:spcPts val="1200"/>
+              </a:spcAft>
+              <a:buChar char="•"/>
+            </a:lvl2pPr>
+            <a:lvl3pPr marL="838200" indent="-228600">
+              <a:lnSpc>
+                <a:spcPct val="110000"/>
+              </a:lnSpc>
+              <a:spcBef>
+                <a:spcPts val="0"/>
+              </a:spcBef>
+              <a:spcAft>
+                <a:spcPts val="1200"/>
+              </a:spcAft>
+              <a:buChar char="•"/>
+            </a:lvl3pPr>
+            <a:lvl4pPr marL="1143000" indent="-228600">
+              <a:lnSpc>
+                <a:spcPct val="110000"/>
+              </a:lnSpc>
+              <a:spcBef>
+                <a:spcPts val="0"/>
+              </a:spcBef>
+              <a:spcAft>
+                <a:spcPts val="1200"/>
+              </a:spcAft>
+              <a:buChar char="•"/>
+            </a:lvl4pPr>
+            <a:lvl5pPr marL="1447800" indent="-228600">
+              <a:lnSpc>
+                <a:spcPct val="110000"/>
+              </a:lnSpc>
+              <a:spcBef>
+                <a:spcPts val="0"/>
+              </a:spcBef>
+              <a:spcAft>
+                <a:spcPts val="1200"/>
+              </a:spcAft>
+              <a:buChar char="•"/>
+            </a:lvl5pPr>
+            <a:lvl6pPr marL="1752600" indent="-228600">
+              <a:lnSpc>
+                <a:spcPct val="110000"/>
+              </a:lnSpc>
+              <a:spcBef>
+                <a:spcPts val="0"/>
+              </a:spcBef>
+              <a:spcAft>
+                <a:spcPts val="1200"/>
+              </a:spcAft>
+              <a:buChar char="•"/>
+            </a:lvl6pPr>
+            <a:lvl7pPr marL="2057400" indent="-228600">
+              <a:lnSpc>
+                <a:spcPct val="110000"/>
+              </a:lnSpc>
+              <a:spcBef>
+                <a:spcPts val="0"/>
+              </a:spcBef>
+              <a:spcAft>
+                <a:spcPts val="1200"/>
+              </a:spcAft>
+              <a:buChar char="•"/>
+            </a:lvl7pPr>
+            <a:lvl8pPr marL="2362200" indent="-228600">
+              <a:lnSpc>
+                <a:spcPct val="110000"/>
+              </a:lnSpc>
+              <a:spcBef>
+                <a:spcPts val="0"/>
+              </a:spcBef>
+              <a:spcAft>
+                <a:spcPts val="1200"/>
+              </a:spcAft>
+              <a:buChar char="•"/>
+            </a:lvl8pPr>
+            <a:lvl9pPr marL="2667000" indent="-228600">
+              <a:lnSpc>
+                <a:spcPct val="110000"/>
+              </a:lnSpc>
+              <a:spcBef>
+                <a:spcPts val="0"/>
+              </a:spcBef>
+              <a:spcAft>
+                <a:spcPts val="1200"/>
+              </a:spcAft>
+              <a:buChar char="•"/>
+            </a:lvl9pPr>
+          </a:lstStyle>
+          <a:p xmlns:a="http://schemas.openxmlformats.org/drawingml/2006/main"/>
+        </p:txBody>
+      </p:sp>
+      <p:sp>
+        <p:nvSpPr>
+          <p:cNvPr id="3" name="Right column">
+            <a:extLst xmlns:a="http://schemas.openxmlformats.org/drawingml/2006/main">
+              <a:ext uri="{FF2B5EF4-FFF2-40B4-BE49-F238E27FC236}">
+                <a16:creationId xmlns:a16="http://schemas.microsoft.com/office/drawing/2014/main" id="{00659552-5A28-4E8C-9058-999643CBA3C7}"/>
+              </a:ext>
+            </a:extLst>
+          </p:cNvPr>
+          <p:cNvSpPr>
+            <a:spLocks xmlns:a="http://schemas.openxmlformats.org/drawingml/2006/main" noGrp="1"/>
+          </p:cNvSpPr>
+          <p:nvPr>
+            <p:ph type="body" idx="2"/>
+          </p:nvPr>
+        </p:nvSpPr>
+        <p:spPr>
+          <a:xfrm xmlns:a="http://schemas.openxmlformats.org/drawingml/2006/main">
+            <a:off x="6477000" y="1905000"/>
+            <a:ext cx="5029200" cy="4267200"/>
+          </a:xfrm>
+          <a:prstGeom xmlns:a="http://schemas.openxmlformats.org/drawingml/2006/main" prst="rect">
+            <a:avLst/>
+          </a:prstGeom>
+          <a:noFill xmlns:a="http://schemas.openxmlformats.org/drawingml/2006/main"/>
+          <a:ln xmlns:a="http://schemas.openxmlformats.org/drawingml/2006/main">
+            <a:noFill/>
+            <a:prstDash val="solid"/>
+          </a:ln>
+        </p:spPr>
+        <p:txBody>
+          <a:bodyPr xmlns:a="http://schemas.openxmlformats.org/drawingml/2006/main" wrap="square" lIns="0" tIns="0" rIns="0" bIns="0" anchor="t">
+            <a:normAutofit/>
+          </a:bodyPr>
+          <a:lstStyle xmlns:a="http://schemas.openxmlformats.org/drawingml/2006/main">
+            <a:defPPr algn="l">
+              <a:defRPr sz="2100" b="0">
+                <a:solidFill>
+                  <a:schemeClr val="tx1"/>
+                </a:solidFill>
+                <a:latin typeface="+mn-lt"/>
+                <a:ea typeface="+mn-lt"/>
+                <a:cs typeface="+mn-lt"/>
+              </a:defRPr>
+            </a:defPPr>
+            <a:lvl1pPr marL="228600" indent="-228600">
+              <a:lnSpc>
+                <a:spcPct val="110000"/>
+              </a:lnSpc>
+              <a:spcBef>
+                <a:spcPts val="0"/>
+              </a:spcBef>
+              <a:spcAft>
+                <a:spcPts val="1200"/>
+              </a:spcAft>
+              <a:buChar char="•"/>
+            </a:lvl1pPr>
+            <a:lvl2pPr marL="533400" indent="-228600">
+              <a:lnSpc>
+                <a:spcPct val="110000"/>
+              </a:lnSpc>
+              <a:spcBef>
+                <a:spcPts val="0"/>
+              </a:spcBef>
+              <a:spcAft>
+                <a:spcPts val="1200"/>
+              </a:spcAft>
+              <a:buChar char="•"/>
+            </a:lvl2pPr>
+            <a:lvl3pPr marL="838200" indent="-228600">
+              <a:lnSpc>
+                <a:spcPct val="110000"/>
+              </a:lnSpc>
+              <a:spcBef>
+                <a:spcPts val="0"/>
+              </a:spcBef>
+              <a:spcAft>
+                <a:spcPts val="1200"/>
+              </a:spcAft>
+              <a:buChar char="•"/>
+            </a:lvl3pPr>
+            <a:lvl4pPr marL="1143000" indent="-228600">
+              <a:lnSpc>
+                <a:spcPct val="110000"/>
+              </a:lnSpc>
+              <a:spcBef>
+                <a:spcPts val="0"/>
+              </a:spcBef>
+              <a:spcAft>
+                <a:spcPts val="1200"/>
+              </a:spcAft>
+              <a:buChar char="•"/>
+            </a:lvl4pPr>
+            <a:lvl5pPr marL="1447800" indent="-228600">
+              <a:lnSpc>
+                <a:spcPct val="110000"/>
+              </a:lnSpc>
+              <a:spcBef>
+                <a:spcPts val="0"/>
+              </a:spcBef>
+              <a:spcAft>
+                <a:spcPts val="1200"/>
+              </a:spcAft>
+              <a:buChar char="•"/>
+            </a:lvl5pPr>
+            <a:lvl6pPr marL="1752600" indent="-228600">
+              <a:lnSpc>
+                <a:spcPct val="110000"/>
+              </a:lnSpc>
+              <a:spcBef>
+                <a:spcPts val="0"/>
+              </a:spcBef>
+              <a:spcAft>
+                <a:spcPts val="1200"/>
+              </a:spcAft>
+              <a:buChar char="•"/>
+            </a:lvl6pPr>
+            <a:lvl7pPr marL="2057400" indent="-228600">
+              <a:lnSpc>
+                <a:spcPct val="110000"/>
+              </a:lnSpc>
+              <a:spcBef>
+                <a:spcPts val="0"/>
+              </a:spcBef>
+              <a:spcAft>
+                <a:spcPts val="1200"/>
+              </a:spcAft>
+              <a:buChar char="•"/>
+            </a:lvl7pPr>
+            <a:lvl8pPr marL="2362200" indent="-228600">
+              <a:lnSpc>
+                <a:spcPct val="110000"/>
+              </a:lnSpc>
+              <a:spcBef>
+                <a:spcPts val="0"/>
+              </a:spcBef>
+              <a:spcAft>
+                <a:spcPts val="1200"/>
+              </a:spcAft>
+              <a:buChar char="•"/>
+            </a:lvl8pPr>
+            <a:lvl9pPr marL="2667000" indent="-228600">
+              <a:lnSpc>
+                <a:spcPct val="110000"/>
+              </a:lnSpc>
+              <a:spcBef>
+                <a:spcPts val="0"/>
+              </a:spcBef>
+              <a:spcAft>
+                <a:spcPts val="1200"/>
+              </a:spcAft>
+              <a:buChar char="•"/>
+            </a:lvl9pPr>
+          </a:lstStyle>
+          <a:p xmlns:a="http://schemas.openxmlformats.org/drawingml/2006/main"/>
+        </p:txBody>
+      </p:sp>
+    </p:spTree>
+  </p:cSld>
+</p:sldLayout>
+</file>
+
+<file path=ppt/slideLayouts/slideLayout5.xml><?xml version="1.0" encoding="utf-8"?>
+<p:sldLayout xmlns:p="http://schemas.openxmlformats.org/presentationml/2006/main">
+  <p:cSld name="Title and One Column">
+    <p:spTree>
+      <p:nvGrpSpPr>
+        <p:cNvPr id="1" name=""/>
+        <p:cNvGrpSpPr/>
+        <p:nvPr/>
+      </p:nvGrpSpPr>
+      <p:grpSpPr>
+        <a:xfrm xmlns:a="http://schemas.openxmlformats.org/drawingml/2006/main"/>
+      </p:grpSpPr>
+      <p:sp>
+        <p:nvSpPr>
+          <p:cNvPr id="3" name="Title">
+            <a:extLst xmlns:a="http://schemas.openxmlformats.org/drawingml/2006/main">
+              <a:ext uri="{FF2B5EF4-FFF2-40B4-BE49-F238E27FC236}">
+                <a16:creationId xmlns:a16="http://schemas.microsoft.com/office/drawing/2014/main" id="{4D4AF2C7-D03E-4727-A8C2-0D82EDC0278C}"/>
+              </a:ext>
+            </a:extLst>
+          </p:cNvPr>
+          <p:cNvSpPr>
+            <a:spLocks xmlns:a="http://schemas.openxmlformats.org/drawingml/2006/main" noGrp="1"/>
+          </p:cNvSpPr>
+          <p:nvPr>
+            <p:ph type="title" idx="0"/>
+          </p:nvPr>
+        </p:nvSpPr>
+        <p:spPr>
+          <a:xfrm xmlns:a="http://schemas.openxmlformats.org/drawingml/2006/main">
+            <a:off x="685800" y="533400"/>
+            <a:ext cx="10820400" cy="838200"/>
+          </a:xfrm>
+          <a:prstGeom xmlns:a="http://schemas.openxmlformats.org/drawingml/2006/main" prst="rect">
+            <a:avLst/>
+          </a:prstGeom>
+          <a:noFill xmlns:a="http://schemas.openxmlformats.org/drawingml/2006/main"/>
+          <a:ln xmlns:a="http://schemas.openxmlformats.org/drawingml/2006/main">
+            <a:noFill/>
+            <a:prstDash val="solid"/>
+          </a:ln>
+        </p:spPr>
+        <p:txBody>
+          <a:bodyPr xmlns:a="http://schemas.openxmlformats.org/drawingml/2006/main" wrap="square" lIns="0" tIns="0" rIns="0" bIns="0" anchor="t">
+            <a:normAutofit/>
+          </a:bodyPr>
+          <a:lstStyle xmlns:a="http://schemas.openxmlformats.org/drawingml/2006/main">
+            <a:defPPr algn="l">
+              <a:defRPr sz="3300" b="1">
+                <a:solidFill>
+                  <a:schemeClr val="tx1"/>
+                </a:solidFill>
+                <a:latin typeface="+mj-lt"/>
+                <a:ea typeface="+mj-lt"/>
+                <a:cs typeface="+mj-lt"/>
+              </a:defRPr>
+            </a:defPPr>
+            <a:lvl1pPr marL="0" indent="0">
+              <a:lnSpc>
+                <a:spcPct val="110000"/>
+              </a:lnSpc>
+              <a:spcBef>
+                <a:spcPts val="0"/>
+              </a:spcBef>
+              <a:spcAft>
+                <a:spcPts val="0"/>
+              </a:spcAft>
+              <a:buNone/>
+            </a:lvl1pPr>
+            <a:lvl2pPr marL="0" indent="0">
+              <a:lnSpc>
+                <a:spcPct val="110000"/>
+              </a:lnSpc>
+              <a:spcBef>
+                <a:spcPts val="0"/>
+              </a:spcBef>
+              <a:spcAft>
+                <a:spcPts val="0"/>
+              </a:spcAft>
+              <a:buNone/>
+            </a:lvl2pPr>
+            <a:lvl3pPr marL="0" indent="0">
+              <a:lnSpc>
+                <a:spcPct val="110000"/>
+              </a:lnSpc>
+              <a:spcBef>
+                <a:spcPts val="0"/>
+              </a:spcBef>
+              <a:spcAft>
+                <a:spcPts val="0"/>
+              </a:spcAft>
+              <a:buNone/>
+            </a:lvl3pPr>
+            <a:lvl4pPr marL="0" indent="0">
+              <a:lnSpc>
+                <a:spcPct val="110000"/>
+              </a:lnSpc>
+              <a:spcBef>
+                <a:spcPts val="0"/>
+              </a:spcBef>
+              <a:spcAft>
+                <a:spcPts val="0"/>
+              </a:spcAft>
+              <a:buNone/>
+            </a:lvl4pPr>
+            <a:lvl5pPr marL="0" indent="0">
+              <a:lnSpc>
+                <a:spcPct val="110000"/>
+              </a:lnSpc>
+              <a:spcBef>
+                <a:spcPts val="0"/>
+              </a:spcBef>
+              <a:spcAft>
+                <a:spcPts val="0"/>
+              </a:spcAft>
+              <a:buNone/>
+            </a:lvl5pPr>
+            <a:lvl6pPr marL="0" indent="0">
+              <a:lnSpc>
+                <a:spcPct val="110000"/>
+              </a:lnSpc>
+              <a:spcBef>
+                <a:spcPts val="0"/>
+              </a:spcBef>
+              <a:spcAft>
+                <a:spcPts val="0"/>
+              </a:spcAft>
+              <a:buNone/>
+            </a:lvl6pPr>
+            <a:lvl7pPr marL="0" indent="0">
+              <a:lnSpc>
+                <a:spcPct val="110000"/>
+              </a:lnSpc>
+              <a:spcBef>
+                <a:spcPts val="0"/>
+              </a:spcBef>
+              <a:spcAft>
+                <a:spcPts val="0"/>
+              </a:spcAft>
+              <a:buNone/>
+            </a:lvl7pPr>
+            <a:lvl8pPr marL="0" indent="0">
+              <a:lnSpc>
+                <a:spcPct val="110000"/>
+              </a:lnSpc>
+              <a:spcBef>
+                <a:spcPts val="0"/>
+              </a:spcBef>
+              <a:spcAft>
+                <a:spcPts val="0"/>
+              </a:spcAft>
+              <a:buNone/>
+            </a:lvl8pPr>
+            <a:lvl9pPr marL="0" indent="0">
+              <a:lnSpc>
+                <a:spcPct val="110000"/>
+              </a:lnSpc>
+              <a:spcBef>
+                <a:spcPts val="0"/>
+              </a:spcBef>
+              <a:spcAft>
+                <a:spcPts val="0"/>
+              </a:spcAft>
+              <a:buNone/>
+            </a:lvl9pPr>
+          </a:lstStyle>
+          <a:p xmlns:a="http://schemas.openxmlformats.org/drawingml/2006/main"/>
+        </p:txBody>
+      </p:sp>
+      <p:sp>
+        <p:nvSpPr>
+          <p:cNvPr id="2" name="Left column">
+            <a:extLst xmlns:a="http://schemas.openxmlformats.org/drawingml/2006/main">
+              <a:ext uri="{FF2B5EF4-FFF2-40B4-BE49-F238E27FC236}">
+                <a16:creationId xmlns:a16="http://schemas.microsoft.com/office/drawing/2014/main" id="{D4C43F8F-116B-401A-93A0-DE790C31D9E5}"/>
+              </a:ext>
+            </a:extLst>
+          </p:cNvPr>
+          <p:cNvSpPr>
+            <a:spLocks xmlns:a="http://schemas.openxmlformats.org/drawingml/2006/main" noGrp="1"/>
+          </p:cNvSpPr>
+          <p:nvPr>
+            <p:ph type="body" idx="1"/>
+          </p:nvPr>
+        </p:nvSpPr>
+        <p:spPr>
+          <a:xfrm xmlns:a="http://schemas.openxmlformats.org/drawingml/2006/main">
+            <a:off x="685800" y="1905000"/>
+            <a:ext cx="5029200" cy="4267200"/>
+          </a:xfrm>
+          <a:prstGeom xmlns:a="http://schemas.openxmlformats.org/drawingml/2006/main" prst="rect">
+            <a:avLst/>
+          </a:prstGeom>
+          <a:noFill xmlns:a="http://schemas.openxmlformats.org/drawingml/2006/main"/>
+          <a:ln xmlns:a="http://schemas.openxmlformats.org/drawingml/2006/main">
+            <a:noFill/>
+            <a:prstDash val="solid"/>
+          </a:ln>
+        </p:spPr>
+        <p:txBody>
+          <a:bodyPr xmlns:a="http://schemas.openxmlformats.org/drawingml/2006/main" wrap="square" lIns="0" tIns="0" rIns="0" bIns="0" anchor="t">
+            <a:normAutofit/>
+          </a:bodyPr>
+          <a:lstStyle xmlns:a="http://schemas.openxmlformats.org/drawingml/2006/main">
+            <a:defPPr algn="l">
+              <a:defRPr sz="2250" b="0">
+                <a:solidFill>
+                  <a:schemeClr val="tx1"/>
+                </a:solidFill>
+                <a:latin typeface="+mn-lt"/>
+                <a:ea typeface="+mn-lt"/>
+                <a:cs typeface="+mn-lt"/>
+              </a:defRPr>
+            </a:defPPr>
+            <a:lvl1pPr marL="228600" indent="-228600">
+              <a:lnSpc>
+                <a:spcPct val="110000"/>
+              </a:lnSpc>
+              <a:spcBef>
+                <a:spcPts val="0"/>
+              </a:spcBef>
+              <a:spcAft>
+                <a:spcPts val="1200"/>
+              </a:spcAft>
+              <a:buChar char="•"/>
+            </a:lvl1pPr>
+            <a:lvl2pPr marL="533400" indent="-228600">
+              <a:lnSpc>
+                <a:spcPct val="110000"/>
+              </a:lnSpc>
+              <a:spcBef>
+                <a:spcPts val="0"/>
+              </a:spcBef>
+              <a:spcAft>
+                <a:spcPts val="1200"/>
+              </a:spcAft>
+              <a:buChar char="•"/>
+            </a:lvl2pPr>
+            <a:lvl3pPr marL="838200" indent="-228600">
+              <a:lnSpc>
+                <a:spcPct val="110000"/>
+              </a:lnSpc>
+              <a:spcBef>
+                <a:spcPts val="0"/>
+              </a:spcBef>
+              <a:spcAft>
+                <a:spcPts val="1200"/>
+              </a:spcAft>
+              <a:buChar char="•"/>
+            </a:lvl3pPr>
+            <a:lvl4pPr marL="1143000" indent="-228600">
+              <a:lnSpc>
+                <a:spcPct val="110000"/>
+              </a:lnSpc>
+              <a:spcBef>
+                <a:spcPts val="0"/>
+              </a:spcBef>
+              <a:spcAft>
+                <a:spcPts val="1200"/>
+              </a:spcAft>
+              <a:buChar char="•"/>
+            </a:lvl4pPr>
+            <a:lvl5pPr marL="1447800" indent="-228600">
+              <a:lnSpc>
+                <a:spcPct val="110000"/>
+              </a:lnSpc>
+              <a:spcBef>
+                <a:spcPts val="0"/>
+              </a:spcBef>
+              <a:spcAft>
+                <a:spcPts val="1200"/>
+              </a:spcAft>
+              <a:buChar char="•"/>
+            </a:lvl5pPr>
+            <a:lvl6pPr marL="1752600" indent="-228600">
+              <a:lnSpc>
+                <a:spcPct val="110000"/>
+              </a:lnSpc>
+              <a:spcBef>
+                <a:spcPts val="0"/>
+              </a:spcBef>
+              <a:spcAft>
+                <a:spcPts val="1200"/>
+              </a:spcAft>
+              <a:buChar char="•"/>
+            </a:lvl6pPr>
+            <a:lvl7pPr marL="2057400" indent="-228600">
+              <a:lnSpc>
+                <a:spcPct val="110000"/>
+              </a:lnSpc>
+              <a:spcBef>
+                <a:spcPts val="0"/>
+              </a:spcBef>
+              <a:spcAft>
+                <a:spcPts val="1200"/>
+              </a:spcAft>
+              <a:buChar char="•"/>
+            </a:lvl7pPr>
+            <a:lvl8pPr marL="2362200" indent="-228600">
+              <a:lnSpc>
+                <a:spcPct val="110000"/>
+              </a:lnSpc>
+              <a:spcBef>
+                <a:spcPts val="0"/>
+              </a:spcBef>
+              <a:spcAft>
+                <a:spcPts val="1200"/>
+              </a:spcAft>
+              <a:buChar char="•"/>
+            </a:lvl8pPr>
+            <a:lvl9pPr marL="2667000" indent="-228600">
+              <a:lnSpc>
+                <a:spcPct val="110000"/>
+              </a:lnSpc>
+              <a:spcBef>
+                <a:spcPts val="0"/>
+              </a:spcBef>
+              <a:spcAft>
+                <a:spcPts val="1200"/>
+              </a:spcAft>
+              <a:buChar char="•"/>
+            </a:lvl9pPr>
+          </a:lstStyle>
+          <a:p xmlns:a="http://schemas.openxmlformats.org/drawingml/2006/main"/>
+        </p:txBody>
+      </p:sp>
+    </p:spTree>
+  </p:cSld>
+</p:sldLayout>
+</file>
+
+<file path=ppt/slideLayouts/slideLayout6.xml><?xml version="1.0" encoding="utf-8"?>
+<p:sldLayout xmlns:p="http://schemas.openxmlformats.org/presentationml/2006/main" type="blank">
+  <p:cSld name="Blank">
+    <p:spTree>
+      <p:nvGrpSpPr>
+        <p:cNvPr id="1" name=""/>
+        <p:cNvGrpSpPr/>
+        <p:nvPr/>
+      </p:nvGrpSpPr>
+      <p:grpSpPr>
+        <a:xfrm xmlns:a="http://schemas.openxmlformats.org/drawingml/2006/main"/>
+      </p:grpSpPr>
     </p:spTree>
   </p:cSld>
 </p:sldLayout>
@@ -6265,7 +7935,12 @@
   </p:cSld>
   <p:clrMap bg1="lt1" tx1="dk1" bg2="lt2" tx2="dk2" accent1="accent1" accent2="accent2" accent3="accent3" accent4="accent4" accent5="accent5" accent6="accent6" hlink="hlink" folHlink="folHlink"/>
   <p:sldLayoutIdLst>
-    <p:sldLayoutId xmlns:r="http://schemas.openxmlformats.org/officeDocument/2006/relationships" id="2147483649" r:id="R4087482ac4d142e9"/>
+    <p:sldLayoutId xmlns:r="http://schemas.openxmlformats.org/officeDocument/2006/relationships" id="2147483649" r:id="R993123b85a0e4f5c"/>
+    <p:sldLayoutId xmlns:r="http://schemas.openxmlformats.org/officeDocument/2006/relationships" id="2147483650" r:id="R3a3f1234a1fb44d2"/>
+    <p:sldLayoutId xmlns:r="http://schemas.openxmlformats.org/officeDocument/2006/relationships" id="2147483651" r:id="R181eac3131e64f79"/>
+    <p:sldLayoutId xmlns:r="http://schemas.openxmlformats.org/officeDocument/2006/relationships" id="2147483652" r:id="R0d59b3a4b6bc410b"/>
+    <p:sldLayoutId xmlns:r="http://schemas.openxmlformats.org/officeDocument/2006/relationships" id="2147483653" r:id="R3f7458d9d86c4db9"/>
+    <p:sldLayoutId xmlns:r="http://schemas.openxmlformats.org/officeDocument/2006/relationships" id="2147483654" r:id="Rf05275f26be242e1"/>
   </p:sldLayoutIdLst>
   <p:txStyles>
     <p:titleStyle>
@@ -6588,16 +8263,16 @@
         <a:srgbClr val="96607D"/>
       </a:folHlink>
     </a:clrScheme>
-    <a:fontScheme name="Office">
+    <a:fontScheme name="">
       <a:majorFont>
-        <a:latin typeface="Calibri Light"/>
-        <a:ea typeface="Calibri Light"/>
-        <a:cs typeface="Calibri Light"/>
+        <a:latin typeface="Aptos"/>
+        <a:ea typeface=""/>
+        <a:cs typeface=""/>
       </a:majorFont>
       <a:minorFont>
-        <a:latin typeface="Calibri"/>
-        <a:ea typeface="Calibri"/>
-        <a:cs typeface="Calibri"/>
+        <a:latin typeface="Aptos"/>
+        <a:ea typeface=""/>
+        <a:cs typeface=""/>
       </a:minorFont>
     </a:fontScheme>
     <a:fmtScheme name="ChatGPT">
@@ -6806,14 +8481,20 @@
       </p:grpSpPr>
       <p:pic>
         <p:nvPicPr>
-          <p:cNvPr id="2" name=""/>
+          <p:cNvPr id="2" name="">
+            <a:extLst xmlns:a="http://schemas.openxmlformats.org/drawingml/2006/main">
+              <a:ext uri="{FF2B5EF4-FFF2-40B4-BE49-F238E27FC236}">
+                <a16:creationId xmlns:a16="http://schemas.microsoft.com/office/drawing/2014/main" id="{BD8B37AF-B78B-49C0-A9A2-13419C0A17B7}"/>
+              </a:ext>
+            </a:extLst>
+          </p:cNvPr>
           <p:cNvPicPr>
             <a:picLocks xmlns:a="http://schemas.openxmlformats.org/drawingml/2006/main" noChangeAspect="1"/>
           </p:cNvPicPr>
           <p:nvPr/>
         </p:nvPicPr>
         <p:blipFill>
-          <a:blip xmlns:r="http://schemas.openxmlformats.org/officeDocument/2006/relationships" xmlns:a="http://schemas.openxmlformats.org/drawingml/2006/main" r:embed="R19209e166b2446da"/>
+          <a:blip xmlns:r="http://schemas.openxmlformats.org/officeDocument/2006/relationships" xmlns:a="http://schemas.openxmlformats.org/drawingml/2006/main" r:embed="Rbb46262849b84706"/>
           <a:stretch xmlns:a="http://schemas.openxmlformats.org/drawingml/2006/main"/>
         </p:blipFill>
         <p:spPr>
@@ -6829,7 +8510,7 @@
     </p:spTree>
     <p:extLst>
       <p:ext uri="{BB962C8B-B14F-4D97-AF65-F5344CB8AC3E}">
-        <p14:creationId xmlns:p14="http://schemas.microsoft.com/office/powerpoint/2010/main" val="1004676899"/>
+        <p14:creationId xmlns:p14="http://schemas.microsoft.com/office/powerpoint/2010/main" val="313451091"/>
       </p:ext>
     </p:extLst>
   </p:cSld>
@@ -6850,14 +8531,20 @@
       </p:grpSpPr>
       <p:pic>
         <p:nvPicPr>
-          <p:cNvPr id="2" name=""/>
+          <p:cNvPr id="2" name="">
+            <a:extLst xmlns:a="http://schemas.openxmlformats.org/drawingml/2006/main">
+              <a:ext uri="{FF2B5EF4-FFF2-40B4-BE49-F238E27FC236}">
+                <a16:creationId xmlns:a16="http://schemas.microsoft.com/office/drawing/2014/main" id="{1CC4072B-8CC8-4464-AE58-834A6F7DAF2F}"/>
+              </a:ext>
+            </a:extLst>
+          </p:cNvPr>
           <p:cNvPicPr>
             <a:picLocks xmlns:a="http://schemas.openxmlformats.org/drawingml/2006/main" noChangeAspect="1"/>
           </p:cNvPicPr>
           <p:nvPr/>
         </p:nvPicPr>
         <p:blipFill>
-          <a:blip xmlns:r="http://schemas.openxmlformats.org/officeDocument/2006/relationships" xmlns:a="http://schemas.openxmlformats.org/drawingml/2006/main" r:embed="R6f78218eb959474d"/>
+          <a:blip xmlns:r="http://schemas.openxmlformats.org/officeDocument/2006/relationships" xmlns:a="http://schemas.openxmlformats.org/drawingml/2006/main" r:embed="R41071d6058994cd6"/>
           <a:stretch xmlns:a="http://schemas.openxmlformats.org/drawingml/2006/main"/>
         </p:blipFill>
         <p:spPr>
@@ -6873,7 +8560,7 @@
     </p:spTree>
     <p:extLst>
       <p:ext uri="{BB962C8B-B14F-4D97-AF65-F5344CB8AC3E}">
-        <p14:creationId xmlns:p14="http://schemas.microsoft.com/office/powerpoint/2010/main" val="173006748"/>
+        <p14:creationId xmlns:p14="http://schemas.microsoft.com/office/powerpoint/2010/main" val="1789259560"/>
       </p:ext>
     </p:extLst>
   </p:cSld>
@@ -6894,14 +8581,20 @@
       </p:grpSpPr>
       <p:pic>
         <p:nvPicPr>
-          <p:cNvPr id="2" name=""/>
+          <p:cNvPr id="2" name="">
+            <a:extLst xmlns:a="http://schemas.openxmlformats.org/drawingml/2006/main">
+              <a:ext uri="{FF2B5EF4-FFF2-40B4-BE49-F238E27FC236}">
+                <a16:creationId xmlns:a16="http://schemas.microsoft.com/office/drawing/2014/main" id="{FD969A6D-94F6-4C07-97ED-3A4FF1DC9808}"/>
+              </a:ext>
+            </a:extLst>
+          </p:cNvPr>
           <p:cNvPicPr>
             <a:picLocks xmlns:a="http://schemas.openxmlformats.org/drawingml/2006/main" noChangeAspect="1"/>
           </p:cNvPicPr>
           <p:nvPr/>
         </p:nvPicPr>
         <p:blipFill>
-          <a:blip xmlns:r="http://schemas.openxmlformats.org/officeDocument/2006/relationships" xmlns:a="http://schemas.openxmlformats.org/drawingml/2006/main" r:embed="Rfac238d41d114cab"/>
+          <a:blip xmlns:r="http://schemas.openxmlformats.org/officeDocument/2006/relationships" xmlns:a="http://schemas.openxmlformats.org/drawingml/2006/main" r:embed="Ra2b1140000d2447a"/>
           <a:stretch xmlns:a="http://schemas.openxmlformats.org/drawingml/2006/main"/>
         </p:blipFill>
         <p:spPr>
@@ -6917,7 +8610,7 @@
     </p:spTree>
     <p:extLst>
       <p:ext uri="{BB962C8B-B14F-4D97-AF65-F5344CB8AC3E}">
-        <p14:creationId xmlns:p14="http://schemas.microsoft.com/office/powerpoint/2010/main" val="663881826"/>
+        <p14:creationId xmlns:p14="http://schemas.microsoft.com/office/powerpoint/2010/main" val="24793959"/>
       </p:ext>
     </p:extLst>
   </p:cSld>
@@ -6938,14 +8631,20 @@
       </p:grpSpPr>
       <p:pic>
         <p:nvPicPr>
-          <p:cNvPr id="2" name=""/>
+          <p:cNvPr id="2" name="">
+            <a:extLst xmlns:a="http://schemas.openxmlformats.org/drawingml/2006/main">
+              <a:ext uri="{FF2B5EF4-FFF2-40B4-BE49-F238E27FC236}">
+                <a16:creationId xmlns:a16="http://schemas.microsoft.com/office/drawing/2014/main" id="{5CE3DE90-B3E9-4CD0-B811-E9515239E5BE}"/>
+              </a:ext>
+            </a:extLst>
+          </p:cNvPr>
           <p:cNvPicPr>
             <a:picLocks xmlns:a="http://schemas.openxmlformats.org/drawingml/2006/main" noChangeAspect="1"/>
           </p:cNvPicPr>
           <p:nvPr/>
         </p:nvPicPr>
         <p:blipFill>
-          <a:blip xmlns:r="http://schemas.openxmlformats.org/officeDocument/2006/relationships" xmlns:a="http://schemas.openxmlformats.org/drawingml/2006/main" r:embed="R32d8cd28f29a42d8"/>
+          <a:blip xmlns:r="http://schemas.openxmlformats.org/officeDocument/2006/relationships" xmlns:a="http://schemas.openxmlformats.org/drawingml/2006/main" r:embed="R16d53b35fa2c4e9f"/>
           <a:stretch xmlns:a="http://schemas.openxmlformats.org/drawingml/2006/main"/>
         </p:blipFill>
         <p:spPr>
@@ -6961,7 +8660,7 @@
     </p:spTree>
     <p:extLst>
       <p:ext uri="{BB962C8B-B14F-4D97-AF65-F5344CB8AC3E}">
-        <p14:creationId xmlns:p14="http://schemas.microsoft.com/office/powerpoint/2010/main" val="358143088"/>
+        <p14:creationId xmlns:p14="http://schemas.microsoft.com/office/powerpoint/2010/main" val="1920499250"/>
       </p:ext>
     </p:extLst>
   </p:cSld>
@@ -6982,14 +8681,20 @@
       </p:grpSpPr>
       <p:pic>
         <p:nvPicPr>
-          <p:cNvPr id="2" name=""/>
+          <p:cNvPr id="2" name="">
+            <a:extLst xmlns:a="http://schemas.openxmlformats.org/drawingml/2006/main">
+              <a:ext uri="{FF2B5EF4-FFF2-40B4-BE49-F238E27FC236}">
+                <a16:creationId xmlns:a16="http://schemas.microsoft.com/office/drawing/2014/main" id="{0A9A1485-9D65-46BB-9937-C9EAEFDCFDF8}"/>
+              </a:ext>
+            </a:extLst>
+          </p:cNvPr>
           <p:cNvPicPr>
             <a:picLocks xmlns:a="http://schemas.openxmlformats.org/drawingml/2006/main" noChangeAspect="1"/>
           </p:cNvPicPr>
           <p:nvPr/>
         </p:nvPicPr>
         <p:blipFill>
-          <a:blip xmlns:r="http://schemas.openxmlformats.org/officeDocument/2006/relationships" xmlns:a="http://schemas.openxmlformats.org/drawingml/2006/main" r:embed="R6a3cac71aad44e8f"/>
+          <a:blip xmlns:r="http://schemas.openxmlformats.org/officeDocument/2006/relationships" xmlns:a="http://schemas.openxmlformats.org/drawingml/2006/main" r:embed="R3a985466f01841e3"/>
           <a:stretch xmlns:a="http://schemas.openxmlformats.org/drawingml/2006/main"/>
         </p:blipFill>
         <p:spPr>
@@ -7005,7 +8710,7 @@
     </p:spTree>
     <p:extLst>
       <p:ext uri="{BB962C8B-B14F-4D97-AF65-F5344CB8AC3E}">
-        <p14:creationId xmlns:p14="http://schemas.microsoft.com/office/powerpoint/2010/main" val="1104241893"/>
+        <p14:creationId xmlns:p14="http://schemas.microsoft.com/office/powerpoint/2010/main" val="473697502"/>
       </p:ext>
     </p:extLst>
   </p:cSld>
@@ -7026,14 +8731,20 @@
       </p:grpSpPr>
       <p:pic>
         <p:nvPicPr>
-          <p:cNvPr id="2" name=""/>
+          <p:cNvPr id="2" name="">
+            <a:extLst xmlns:a="http://schemas.openxmlformats.org/drawingml/2006/main">
+              <a:ext uri="{FF2B5EF4-FFF2-40B4-BE49-F238E27FC236}">
+                <a16:creationId xmlns:a16="http://schemas.microsoft.com/office/drawing/2014/main" id="{7F64133C-4C73-49F8-A6B5-3761065ACEAB}"/>
+              </a:ext>
+            </a:extLst>
+          </p:cNvPr>
           <p:cNvPicPr>
             <a:picLocks xmlns:a="http://schemas.openxmlformats.org/drawingml/2006/main" noChangeAspect="1"/>
           </p:cNvPicPr>
           <p:nvPr/>
         </p:nvPicPr>
         <p:blipFill>
-          <a:blip xmlns:r="http://schemas.openxmlformats.org/officeDocument/2006/relationships" xmlns:a="http://schemas.openxmlformats.org/drawingml/2006/main" r:embed="R73980ee4d3b44b22"/>
+          <a:blip xmlns:r="http://schemas.openxmlformats.org/officeDocument/2006/relationships" xmlns:a="http://schemas.openxmlformats.org/drawingml/2006/main" r:embed="R89f1a6b85ea74832"/>
           <a:stretch xmlns:a="http://schemas.openxmlformats.org/drawingml/2006/main"/>
         </p:blipFill>
         <p:spPr>
@@ -7049,7 +8760,7 @@
     </p:spTree>
     <p:extLst>
       <p:ext uri="{BB962C8B-B14F-4D97-AF65-F5344CB8AC3E}">
-        <p14:creationId xmlns:p14="http://schemas.microsoft.com/office/powerpoint/2010/main" val="1966682690"/>
+        <p14:creationId xmlns:p14="http://schemas.microsoft.com/office/powerpoint/2010/main" val="109820369"/>
       </p:ext>
     </p:extLst>
   </p:cSld>
@@ -7070,14 +8781,20 @@
       </p:grpSpPr>
       <p:pic>
         <p:nvPicPr>
-          <p:cNvPr id="2" name=""/>
+          <p:cNvPr id="2" name="">
+            <a:extLst xmlns:a="http://schemas.openxmlformats.org/drawingml/2006/main">
+              <a:ext uri="{FF2B5EF4-FFF2-40B4-BE49-F238E27FC236}">
+                <a16:creationId xmlns:a16="http://schemas.microsoft.com/office/drawing/2014/main" id="{5A88BC7A-32B1-44F8-8FE7-851C15914A4F}"/>
+              </a:ext>
+            </a:extLst>
+          </p:cNvPr>
           <p:cNvPicPr>
             <a:picLocks xmlns:a="http://schemas.openxmlformats.org/drawingml/2006/main" noChangeAspect="1"/>
           </p:cNvPicPr>
           <p:nvPr/>
         </p:nvPicPr>
         <p:blipFill>
-          <a:blip xmlns:r="http://schemas.openxmlformats.org/officeDocument/2006/relationships" xmlns:a="http://schemas.openxmlformats.org/drawingml/2006/main" r:embed="Rc31f3f006e434098"/>
+          <a:blip xmlns:r="http://schemas.openxmlformats.org/officeDocument/2006/relationships" xmlns:a="http://schemas.openxmlformats.org/drawingml/2006/main" r:embed="R832872eaaeee445e"/>
           <a:stretch xmlns:a="http://schemas.openxmlformats.org/drawingml/2006/main"/>
         </p:blipFill>
         <p:spPr>
@@ -7093,7 +8810,7 @@
     </p:spTree>
     <p:extLst>
       <p:ext uri="{BB962C8B-B14F-4D97-AF65-F5344CB8AC3E}">
-        <p14:creationId xmlns:p14="http://schemas.microsoft.com/office/powerpoint/2010/main" val="2068918430"/>
+        <p14:creationId xmlns:p14="http://schemas.microsoft.com/office/powerpoint/2010/main" val="433298950"/>
       </p:ext>
     </p:extLst>
   </p:cSld>
@@ -7114,14 +8831,20 @@
       </p:grpSpPr>
       <p:pic>
         <p:nvPicPr>
-          <p:cNvPr id="2" name=""/>
+          <p:cNvPr id="2" name="">
+            <a:extLst xmlns:a="http://schemas.openxmlformats.org/drawingml/2006/main">
+              <a:ext uri="{FF2B5EF4-FFF2-40B4-BE49-F238E27FC236}">
+                <a16:creationId xmlns:a16="http://schemas.microsoft.com/office/drawing/2014/main" id="{98260FB4-7498-43E4-AEC5-0089BA670501}"/>
+              </a:ext>
+            </a:extLst>
+          </p:cNvPr>
           <p:cNvPicPr>
             <a:picLocks xmlns:a="http://schemas.openxmlformats.org/drawingml/2006/main" noChangeAspect="1"/>
           </p:cNvPicPr>
           <p:nvPr/>
         </p:nvPicPr>
         <p:blipFill>
-          <a:blip xmlns:r="http://schemas.openxmlformats.org/officeDocument/2006/relationships" xmlns:a="http://schemas.openxmlformats.org/drawingml/2006/main" r:embed="R48f35e6596cb425e"/>
+          <a:blip xmlns:r="http://schemas.openxmlformats.org/officeDocument/2006/relationships" xmlns:a="http://schemas.openxmlformats.org/drawingml/2006/main" r:embed="R5a4428f7545d4ff1"/>
           <a:stretch xmlns:a="http://schemas.openxmlformats.org/drawingml/2006/main"/>
         </p:blipFill>
         <p:spPr>
@@ -7137,7 +8860,7 @@
     </p:spTree>
     <p:extLst>
       <p:ext uri="{BB962C8B-B14F-4D97-AF65-F5344CB8AC3E}">
-        <p14:creationId xmlns:p14="http://schemas.microsoft.com/office/powerpoint/2010/main" val="413373545"/>
+        <p14:creationId xmlns:p14="http://schemas.microsoft.com/office/powerpoint/2010/main" val="2005783004"/>
       </p:ext>
     </p:extLst>
   </p:cSld>
@@ -7158,14 +8881,20 @@
       </p:grpSpPr>
       <p:pic>
         <p:nvPicPr>
-          <p:cNvPr id="2" name=""/>
+          <p:cNvPr id="2" name="">
+            <a:extLst xmlns:a="http://schemas.openxmlformats.org/drawingml/2006/main">
+              <a:ext uri="{FF2B5EF4-FFF2-40B4-BE49-F238E27FC236}">
+                <a16:creationId xmlns:a16="http://schemas.microsoft.com/office/drawing/2014/main" id="{2D1A63D5-21CE-4BFA-9731-7D828923D9CA}"/>
+              </a:ext>
+            </a:extLst>
+          </p:cNvPr>
           <p:cNvPicPr>
             <a:picLocks xmlns:a="http://schemas.openxmlformats.org/drawingml/2006/main" noChangeAspect="1"/>
           </p:cNvPicPr>
           <p:nvPr/>
         </p:nvPicPr>
         <p:blipFill>
-          <a:blip xmlns:r="http://schemas.openxmlformats.org/officeDocument/2006/relationships" xmlns:a="http://schemas.openxmlformats.org/drawingml/2006/main" r:embed="R96f61085ed824667"/>
+          <a:blip xmlns:r="http://schemas.openxmlformats.org/officeDocument/2006/relationships" xmlns:a="http://schemas.openxmlformats.org/drawingml/2006/main" r:embed="Reb7020168af849af"/>
           <a:stretch xmlns:a="http://schemas.openxmlformats.org/drawingml/2006/main"/>
         </p:blipFill>
         <p:spPr>
@@ -7181,7 +8910,7 @@
     </p:spTree>
     <p:extLst>
       <p:ext uri="{BB962C8B-B14F-4D97-AF65-F5344CB8AC3E}">
-        <p14:creationId xmlns:p14="http://schemas.microsoft.com/office/powerpoint/2010/main" val="372227651"/>
+        <p14:creationId xmlns:p14="http://schemas.microsoft.com/office/powerpoint/2010/main" val="314707190"/>
       </p:ext>
     </p:extLst>
   </p:cSld>
@@ -7202,14 +8931,20 @@
       </p:grpSpPr>
       <p:pic>
         <p:nvPicPr>
-          <p:cNvPr id="2" name=""/>
+          <p:cNvPr id="2" name="">
+            <a:extLst xmlns:a="http://schemas.openxmlformats.org/drawingml/2006/main">
+              <a:ext uri="{FF2B5EF4-FFF2-40B4-BE49-F238E27FC236}">
+                <a16:creationId xmlns:a16="http://schemas.microsoft.com/office/drawing/2014/main" id="{E8BB0F12-3217-4740-91DD-BEA4D4EBAE1E}"/>
+              </a:ext>
+            </a:extLst>
+          </p:cNvPr>
           <p:cNvPicPr>
             <a:picLocks xmlns:a="http://schemas.openxmlformats.org/drawingml/2006/main" noChangeAspect="1"/>
           </p:cNvPicPr>
           <p:nvPr/>
         </p:nvPicPr>
         <p:blipFill>
-          <a:blip xmlns:r="http://schemas.openxmlformats.org/officeDocument/2006/relationships" xmlns:a="http://schemas.openxmlformats.org/drawingml/2006/main" r:embed="R5f528c5a708a4fe2"/>
+          <a:blip xmlns:r="http://schemas.openxmlformats.org/officeDocument/2006/relationships" xmlns:a="http://schemas.openxmlformats.org/drawingml/2006/main" r:embed="Rb7240615763f4bff"/>
           <a:stretch xmlns:a="http://schemas.openxmlformats.org/drawingml/2006/main"/>
         </p:blipFill>
         <p:spPr>
@@ -7225,7 +8960,7 @@
     </p:spTree>
     <p:extLst>
       <p:ext uri="{BB962C8B-B14F-4D97-AF65-F5344CB8AC3E}">
-        <p14:creationId xmlns:p14="http://schemas.microsoft.com/office/powerpoint/2010/main" val="1291754884"/>
+        <p14:creationId xmlns:p14="http://schemas.microsoft.com/office/powerpoint/2010/main" val="907264934"/>
       </p:ext>
     </p:extLst>
   </p:cSld>
@@ -7246,14 +8981,20 @@
       </p:grpSpPr>
       <p:pic>
         <p:nvPicPr>
-          <p:cNvPr id="2" name=""/>
+          <p:cNvPr id="2" name="">
+            <a:extLst xmlns:a="http://schemas.openxmlformats.org/drawingml/2006/main">
+              <a:ext uri="{FF2B5EF4-FFF2-40B4-BE49-F238E27FC236}">
+                <a16:creationId xmlns:a16="http://schemas.microsoft.com/office/drawing/2014/main" id="{AFA878CE-2A77-4A5F-9C0C-FFDB093A1E40}"/>
+              </a:ext>
+            </a:extLst>
+          </p:cNvPr>
           <p:cNvPicPr>
             <a:picLocks xmlns:a="http://schemas.openxmlformats.org/drawingml/2006/main" noChangeAspect="1"/>
           </p:cNvPicPr>
           <p:nvPr/>
         </p:nvPicPr>
         <p:blipFill>
-          <a:blip xmlns:r="http://schemas.openxmlformats.org/officeDocument/2006/relationships" xmlns:a="http://schemas.openxmlformats.org/drawingml/2006/main" r:embed="Rf5d29d4084f54658"/>
+          <a:blip xmlns:r="http://schemas.openxmlformats.org/officeDocument/2006/relationships" xmlns:a="http://schemas.openxmlformats.org/drawingml/2006/main" r:embed="Re2c768de877049ec"/>
           <a:stretch xmlns:a="http://schemas.openxmlformats.org/drawingml/2006/main"/>
         </p:blipFill>
         <p:spPr>
@@ -7269,7 +9010,7 @@
     </p:spTree>
     <p:extLst>
       <p:ext uri="{BB962C8B-B14F-4D97-AF65-F5344CB8AC3E}">
-        <p14:creationId xmlns:p14="http://schemas.microsoft.com/office/powerpoint/2010/main" val="974646465"/>
+        <p14:creationId xmlns:p14="http://schemas.microsoft.com/office/powerpoint/2010/main" val="26763594"/>
       </p:ext>
     </p:extLst>
   </p:cSld>
@@ -7290,14 +9031,20 @@
       </p:grpSpPr>
       <p:pic>
         <p:nvPicPr>
-          <p:cNvPr id="2" name=""/>
+          <p:cNvPr id="2" name="">
+            <a:extLst xmlns:a="http://schemas.openxmlformats.org/drawingml/2006/main">
+              <a:ext uri="{FF2B5EF4-FFF2-40B4-BE49-F238E27FC236}">
+                <a16:creationId xmlns:a16="http://schemas.microsoft.com/office/drawing/2014/main" id="{F71370B2-B9B8-409F-AD73-D35F1B1C8B1F}"/>
+              </a:ext>
+            </a:extLst>
+          </p:cNvPr>
           <p:cNvPicPr>
             <a:picLocks xmlns:a="http://schemas.openxmlformats.org/drawingml/2006/main" noChangeAspect="1"/>
           </p:cNvPicPr>
           <p:nvPr/>
         </p:nvPicPr>
         <p:blipFill>
-          <a:blip xmlns:r="http://schemas.openxmlformats.org/officeDocument/2006/relationships" xmlns:a="http://schemas.openxmlformats.org/drawingml/2006/main" r:embed="R5b3331a3f2664105"/>
+          <a:blip xmlns:r="http://schemas.openxmlformats.org/officeDocument/2006/relationships" xmlns:a="http://schemas.openxmlformats.org/drawingml/2006/main" r:embed="R3c2cba6e96a64238"/>
           <a:stretch xmlns:a="http://schemas.openxmlformats.org/drawingml/2006/main"/>
         </p:blipFill>
         <p:spPr>
@@ -7313,7 +9060,7 @@
     </p:spTree>
     <p:extLst>
       <p:ext uri="{BB962C8B-B14F-4D97-AF65-F5344CB8AC3E}">
-        <p14:creationId xmlns:p14="http://schemas.microsoft.com/office/powerpoint/2010/main" val="83621247"/>
+        <p14:creationId xmlns:p14="http://schemas.microsoft.com/office/powerpoint/2010/main" val="746949740"/>
       </p:ext>
     </p:extLst>
   </p:cSld>
@@ -7334,14 +9081,20 @@
       </p:grpSpPr>
       <p:pic>
         <p:nvPicPr>
-          <p:cNvPr id="2" name=""/>
+          <p:cNvPr id="2" name="">
+            <a:extLst xmlns:a="http://schemas.openxmlformats.org/drawingml/2006/main">
+              <a:ext uri="{FF2B5EF4-FFF2-40B4-BE49-F238E27FC236}">
+                <a16:creationId xmlns:a16="http://schemas.microsoft.com/office/drawing/2014/main" id="{6B8BF895-B705-40F4-9D6C-09FABDDC1352}"/>
+              </a:ext>
+            </a:extLst>
+          </p:cNvPr>
           <p:cNvPicPr>
             <a:picLocks xmlns:a="http://schemas.openxmlformats.org/drawingml/2006/main" noChangeAspect="1"/>
           </p:cNvPicPr>
           <p:nvPr/>
         </p:nvPicPr>
         <p:blipFill>
-          <a:blip xmlns:r="http://schemas.openxmlformats.org/officeDocument/2006/relationships" xmlns:a="http://schemas.openxmlformats.org/drawingml/2006/main" r:embed="Rb059737d3ad04674"/>
+          <a:blip xmlns:r="http://schemas.openxmlformats.org/officeDocument/2006/relationships" xmlns:a="http://schemas.openxmlformats.org/drawingml/2006/main" r:embed="Rd9361e1f28834e19"/>
           <a:stretch xmlns:a="http://schemas.openxmlformats.org/drawingml/2006/main"/>
         </p:blipFill>
         <p:spPr>
@@ -7357,7 +9110,7 @@
     </p:spTree>
     <p:extLst>
       <p:ext uri="{BB962C8B-B14F-4D97-AF65-F5344CB8AC3E}">
-        <p14:creationId xmlns:p14="http://schemas.microsoft.com/office/powerpoint/2010/main" val="71453413"/>
+        <p14:creationId xmlns:p14="http://schemas.microsoft.com/office/powerpoint/2010/main" val="759582517"/>
       </p:ext>
     </p:extLst>
   </p:cSld>
@@ -7378,14 +9131,20 @@
       </p:grpSpPr>
       <p:pic>
         <p:nvPicPr>
-          <p:cNvPr id="2" name=""/>
+          <p:cNvPr id="2" name="">
+            <a:extLst xmlns:a="http://schemas.openxmlformats.org/drawingml/2006/main">
+              <a:ext uri="{FF2B5EF4-FFF2-40B4-BE49-F238E27FC236}">
+                <a16:creationId xmlns:a16="http://schemas.microsoft.com/office/drawing/2014/main" id="{6ABD9D92-4805-4DB6-9DD3-69FE93DFE866}"/>
+              </a:ext>
+            </a:extLst>
+          </p:cNvPr>
           <p:cNvPicPr>
             <a:picLocks xmlns:a="http://schemas.openxmlformats.org/drawingml/2006/main" noChangeAspect="1"/>
           </p:cNvPicPr>
           <p:nvPr/>
         </p:nvPicPr>
         <p:blipFill>
-          <a:blip xmlns:r="http://schemas.openxmlformats.org/officeDocument/2006/relationships" xmlns:a="http://schemas.openxmlformats.org/drawingml/2006/main" r:embed="R131dc00d7a2f4302"/>
+          <a:blip xmlns:r="http://schemas.openxmlformats.org/officeDocument/2006/relationships" xmlns:a="http://schemas.openxmlformats.org/drawingml/2006/main" r:embed="R391b21aff4294127"/>
           <a:stretch xmlns:a="http://schemas.openxmlformats.org/drawingml/2006/main"/>
         </p:blipFill>
         <p:spPr>
@@ -7401,7 +9160,7 @@
     </p:spTree>
     <p:extLst>
       <p:ext uri="{BB962C8B-B14F-4D97-AF65-F5344CB8AC3E}">
-        <p14:creationId xmlns:p14="http://schemas.microsoft.com/office/powerpoint/2010/main" val="622768438"/>
+        <p14:creationId xmlns:p14="http://schemas.microsoft.com/office/powerpoint/2010/main" val="195910990"/>
       </p:ext>
     </p:extLst>
   </p:cSld>
@@ -7422,14 +9181,20 @@
       </p:grpSpPr>
       <p:pic>
         <p:nvPicPr>
-          <p:cNvPr id="2" name=""/>
+          <p:cNvPr id="2" name="">
+            <a:extLst xmlns:a="http://schemas.openxmlformats.org/drawingml/2006/main">
+              <a:ext uri="{FF2B5EF4-FFF2-40B4-BE49-F238E27FC236}">
+                <a16:creationId xmlns:a16="http://schemas.microsoft.com/office/drawing/2014/main" id="{BE5470A9-82F6-4481-8BD6-A8D78667A1C8}"/>
+              </a:ext>
+            </a:extLst>
+          </p:cNvPr>
           <p:cNvPicPr>
             <a:picLocks xmlns:a="http://schemas.openxmlformats.org/drawingml/2006/main" noChangeAspect="1"/>
           </p:cNvPicPr>
           <p:nvPr/>
         </p:nvPicPr>
         <p:blipFill>
-          <a:blip xmlns:r="http://schemas.openxmlformats.org/officeDocument/2006/relationships" xmlns:a="http://schemas.openxmlformats.org/drawingml/2006/main" r:embed="R81fb117c711c4d40"/>
+          <a:blip xmlns:r="http://schemas.openxmlformats.org/officeDocument/2006/relationships" xmlns:a="http://schemas.openxmlformats.org/drawingml/2006/main" r:embed="Rb0668f2a63464124"/>
           <a:stretch xmlns:a="http://schemas.openxmlformats.org/drawingml/2006/main"/>
         </p:blipFill>
         <p:spPr>
@@ -7445,7 +9210,7 @@
     </p:spTree>
     <p:extLst>
       <p:ext uri="{BB962C8B-B14F-4D97-AF65-F5344CB8AC3E}">
-        <p14:creationId xmlns:p14="http://schemas.microsoft.com/office/powerpoint/2010/main" val="1740875916"/>
+        <p14:creationId xmlns:p14="http://schemas.microsoft.com/office/powerpoint/2010/main" val="1376008937"/>
       </p:ext>
     </p:extLst>
   </p:cSld>
@@ -7466,14 +9231,20 @@
       </p:grpSpPr>
       <p:pic>
         <p:nvPicPr>
-          <p:cNvPr id="2" name=""/>
+          <p:cNvPr id="2" name="">
+            <a:extLst xmlns:a="http://schemas.openxmlformats.org/drawingml/2006/main">
+              <a:ext uri="{FF2B5EF4-FFF2-40B4-BE49-F238E27FC236}">
+                <a16:creationId xmlns:a16="http://schemas.microsoft.com/office/drawing/2014/main" id="{F04A2062-6B5F-4FFE-9306-052B86296460}"/>
+              </a:ext>
+            </a:extLst>
+          </p:cNvPr>
           <p:cNvPicPr>
             <a:picLocks xmlns:a="http://schemas.openxmlformats.org/drawingml/2006/main" noChangeAspect="1"/>
           </p:cNvPicPr>
           <p:nvPr/>
         </p:nvPicPr>
         <p:blipFill>
-          <a:blip xmlns:r="http://schemas.openxmlformats.org/officeDocument/2006/relationships" xmlns:a="http://schemas.openxmlformats.org/drawingml/2006/main" r:embed="Red2615ef9d514b46"/>
+          <a:blip xmlns:r="http://schemas.openxmlformats.org/officeDocument/2006/relationships" xmlns:a="http://schemas.openxmlformats.org/drawingml/2006/main" r:embed="R98411cf2ebe4494f"/>
           <a:stretch xmlns:a="http://schemas.openxmlformats.org/drawingml/2006/main"/>
         </p:blipFill>
         <p:spPr>
@@ -7489,7 +9260,7 @@
     </p:spTree>
     <p:extLst>
       <p:ext uri="{BB962C8B-B14F-4D97-AF65-F5344CB8AC3E}">
-        <p14:creationId xmlns:p14="http://schemas.microsoft.com/office/powerpoint/2010/main" val="1422464299"/>
+        <p14:creationId xmlns:p14="http://schemas.microsoft.com/office/powerpoint/2010/main" val="2131692364"/>
       </p:ext>
     </p:extLst>
   </p:cSld>
@@ -7510,14 +9281,20 @@
       </p:grpSpPr>
       <p:pic>
         <p:nvPicPr>
-          <p:cNvPr id="2" name=""/>
+          <p:cNvPr id="2" name="">
+            <a:extLst xmlns:a="http://schemas.openxmlformats.org/drawingml/2006/main">
+              <a:ext uri="{FF2B5EF4-FFF2-40B4-BE49-F238E27FC236}">
+                <a16:creationId xmlns:a16="http://schemas.microsoft.com/office/drawing/2014/main" id="{CF0D9EF0-4E17-4CB9-9DA4-DE547713E62A}"/>
+              </a:ext>
+            </a:extLst>
+          </p:cNvPr>
           <p:cNvPicPr>
             <a:picLocks xmlns:a="http://schemas.openxmlformats.org/drawingml/2006/main" noChangeAspect="1"/>
           </p:cNvPicPr>
           <p:nvPr/>
         </p:nvPicPr>
         <p:blipFill>
-          <a:blip xmlns:r="http://schemas.openxmlformats.org/officeDocument/2006/relationships" xmlns:a="http://schemas.openxmlformats.org/drawingml/2006/main" r:embed="R87f30c52078c4b39"/>
+          <a:blip xmlns:r="http://schemas.openxmlformats.org/officeDocument/2006/relationships" xmlns:a="http://schemas.openxmlformats.org/drawingml/2006/main" r:embed="Rc62c905525674fa9"/>
           <a:stretch xmlns:a="http://schemas.openxmlformats.org/drawingml/2006/main"/>
         </p:blipFill>
         <p:spPr>
@@ -7533,7 +9310,7 @@
     </p:spTree>
     <p:extLst>
       <p:ext uri="{BB962C8B-B14F-4D97-AF65-F5344CB8AC3E}">
-        <p14:creationId xmlns:p14="http://schemas.microsoft.com/office/powerpoint/2010/main" val="1530078415"/>
+        <p14:creationId xmlns:p14="http://schemas.microsoft.com/office/powerpoint/2010/main" val="958919207"/>
       </p:ext>
     </p:extLst>
   </p:cSld>
@@ -7554,14 +9331,20 @@
       </p:grpSpPr>
       <p:pic>
         <p:nvPicPr>
-          <p:cNvPr id="2" name=""/>
+          <p:cNvPr id="2" name="">
+            <a:extLst xmlns:a="http://schemas.openxmlformats.org/drawingml/2006/main">
+              <a:ext uri="{FF2B5EF4-FFF2-40B4-BE49-F238E27FC236}">
+                <a16:creationId xmlns:a16="http://schemas.microsoft.com/office/drawing/2014/main" id="{98062197-3BF8-4436-AA46-627017783A43}"/>
+              </a:ext>
+            </a:extLst>
+          </p:cNvPr>
           <p:cNvPicPr>
             <a:picLocks xmlns:a="http://schemas.openxmlformats.org/drawingml/2006/main" noChangeAspect="1"/>
           </p:cNvPicPr>
           <p:nvPr/>
         </p:nvPicPr>
         <p:blipFill>
-          <a:blip xmlns:r="http://schemas.openxmlformats.org/officeDocument/2006/relationships" xmlns:a="http://schemas.openxmlformats.org/drawingml/2006/main" r:embed="Rc0bf13665473491f"/>
+          <a:blip xmlns:r="http://schemas.openxmlformats.org/officeDocument/2006/relationships" xmlns:a="http://schemas.openxmlformats.org/drawingml/2006/main" r:embed="R220d00dd108e4dfa"/>
           <a:stretch xmlns:a="http://schemas.openxmlformats.org/drawingml/2006/main"/>
         </p:blipFill>
         <p:spPr>
@@ -7577,7 +9360,7 @@
     </p:spTree>
     <p:extLst>
       <p:ext uri="{BB962C8B-B14F-4D97-AF65-F5344CB8AC3E}">
-        <p14:creationId xmlns:p14="http://schemas.microsoft.com/office/powerpoint/2010/main" val="945601134"/>
+        <p14:creationId xmlns:p14="http://schemas.microsoft.com/office/powerpoint/2010/main" val="594366154"/>
       </p:ext>
     </p:extLst>
   </p:cSld>
@@ -7598,14 +9381,20 @@
       </p:grpSpPr>
       <p:pic>
         <p:nvPicPr>
-          <p:cNvPr id="2" name=""/>
+          <p:cNvPr id="2" name="">
+            <a:extLst xmlns:a="http://schemas.openxmlformats.org/drawingml/2006/main">
+              <a:ext uri="{FF2B5EF4-FFF2-40B4-BE49-F238E27FC236}">
+                <a16:creationId xmlns:a16="http://schemas.microsoft.com/office/drawing/2014/main" id="{4D618F52-C95E-4063-A4AE-344BFB249BEA}"/>
+              </a:ext>
+            </a:extLst>
+          </p:cNvPr>
           <p:cNvPicPr>
             <a:picLocks xmlns:a="http://schemas.openxmlformats.org/drawingml/2006/main" noChangeAspect="1"/>
           </p:cNvPicPr>
           <p:nvPr/>
         </p:nvPicPr>
         <p:blipFill>
-          <a:blip xmlns:r="http://schemas.openxmlformats.org/officeDocument/2006/relationships" xmlns:a="http://schemas.openxmlformats.org/drawingml/2006/main" r:embed="Rd4e8c0f53e81410d"/>
+          <a:blip xmlns:r="http://schemas.openxmlformats.org/officeDocument/2006/relationships" xmlns:a="http://schemas.openxmlformats.org/drawingml/2006/main" r:embed="Rc8733343b0c446e8"/>
           <a:stretch xmlns:a="http://schemas.openxmlformats.org/drawingml/2006/main"/>
         </p:blipFill>
         <p:spPr>
@@ -7621,7 +9410,7 @@
     </p:spTree>
     <p:extLst>
       <p:ext uri="{BB962C8B-B14F-4D97-AF65-F5344CB8AC3E}">
-        <p14:creationId xmlns:p14="http://schemas.microsoft.com/office/powerpoint/2010/main" val="1439741292"/>
+        <p14:creationId xmlns:p14="http://schemas.microsoft.com/office/powerpoint/2010/main" val="721193569"/>
       </p:ext>
     </p:extLst>
   </p:cSld>
@@ -7642,14 +9431,20 @@
       </p:grpSpPr>
       <p:pic>
         <p:nvPicPr>
-          <p:cNvPr id="2" name=""/>
+          <p:cNvPr id="2" name="">
+            <a:extLst xmlns:a="http://schemas.openxmlformats.org/drawingml/2006/main">
+              <a:ext uri="{FF2B5EF4-FFF2-40B4-BE49-F238E27FC236}">
+                <a16:creationId xmlns:a16="http://schemas.microsoft.com/office/drawing/2014/main" id="{543B677F-3DA7-43CA-8DFF-8C8636B443E0}"/>
+              </a:ext>
+            </a:extLst>
+          </p:cNvPr>
           <p:cNvPicPr>
             <a:picLocks xmlns:a="http://schemas.openxmlformats.org/drawingml/2006/main" noChangeAspect="1"/>
           </p:cNvPicPr>
           <p:nvPr/>
         </p:nvPicPr>
         <p:blipFill>
-          <a:blip xmlns:r="http://schemas.openxmlformats.org/officeDocument/2006/relationships" xmlns:a="http://schemas.openxmlformats.org/drawingml/2006/main" r:embed="Radbf11c479da4e9c"/>
+          <a:blip xmlns:r="http://schemas.openxmlformats.org/officeDocument/2006/relationships" xmlns:a="http://schemas.openxmlformats.org/drawingml/2006/main" r:embed="R37ef48ce68524bed"/>
           <a:stretch xmlns:a="http://schemas.openxmlformats.org/drawingml/2006/main"/>
         </p:blipFill>
         <p:spPr>
@@ -7665,7 +9460,7 @@
     </p:spTree>
     <p:extLst>
       <p:ext uri="{BB962C8B-B14F-4D97-AF65-F5344CB8AC3E}">
-        <p14:creationId xmlns:p14="http://schemas.microsoft.com/office/powerpoint/2010/main" val="1664908471"/>
+        <p14:creationId xmlns:p14="http://schemas.microsoft.com/office/powerpoint/2010/main" val="735208747"/>
       </p:ext>
     </p:extLst>
   </p:cSld>
@@ -7686,14 +9481,20 @@
       </p:grpSpPr>
       <p:pic>
         <p:nvPicPr>
-          <p:cNvPr id="2" name=""/>
+          <p:cNvPr id="2" name="">
+            <a:extLst xmlns:a="http://schemas.openxmlformats.org/drawingml/2006/main">
+              <a:ext uri="{FF2B5EF4-FFF2-40B4-BE49-F238E27FC236}">
+                <a16:creationId xmlns:a16="http://schemas.microsoft.com/office/drawing/2014/main" id="{599E1086-BB1D-4EF8-A8BD-583D54516C59}"/>
+              </a:ext>
+            </a:extLst>
+          </p:cNvPr>
           <p:cNvPicPr>
             <a:picLocks xmlns:a="http://schemas.openxmlformats.org/drawingml/2006/main" noChangeAspect="1"/>
           </p:cNvPicPr>
           <p:nvPr/>
         </p:nvPicPr>
         <p:blipFill>
-          <a:blip xmlns:r="http://schemas.openxmlformats.org/officeDocument/2006/relationships" xmlns:a="http://schemas.openxmlformats.org/drawingml/2006/main" r:embed="R39ea768e5a944c1f"/>
+          <a:blip xmlns:r="http://schemas.openxmlformats.org/officeDocument/2006/relationships" xmlns:a="http://schemas.openxmlformats.org/drawingml/2006/main" r:embed="Rcf7b4eb12e614b09"/>
           <a:stretch xmlns:a="http://schemas.openxmlformats.org/drawingml/2006/main"/>
         </p:blipFill>
         <p:spPr>
@@ -7709,7 +9510,7 @@
     </p:spTree>
     <p:extLst>
       <p:ext uri="{BB962C8B-B14F-4D97-AF65-F5344CB8AC3E}">
-        <p14:creationId xmlns:p14="http://schemas.microsoft.com/office/powerpoint/2010/main" val="1111308363"/>
+        <p14:creationId xmlns:p14="http://schemas.microsoft.com/office/powerpoint/2010/main" val="1985277921"/>
       </p:ext>
     </p:extLst>
   </p:cSld>
@@ -7730,14 +9531,20 @@
       </p:grpSpPr>
       <p:pic>
         <p:nvPicPr>
-          <p:cNvPr id="2" name=""/>
+          <p:cNvPr id="2" name="">
+            <a:extLst xmlns:a="http://schemas.openxmlformats.org/drawingml/2006/main">
+              <a:ext uri="{FF2B5EF4-FFF2-40B4-BE49-F238E27FC236}">
+                <a16:creationId xmlns:a16="http://schemas.microsoft.com/office/drawing/2014/main" id="{5549EA0C-F307-46F9-9646-AB2C02097C3A}"/>
+              </a:ext>
+            </a:extLst>
+          </p:cNvPr>
           <p:cNvPicPr>
             <a:picLocks xmlns:a="http://schemas.openxmlformats.org/drawingml/2006/main" noChangeAspect="1"/>
           </p:cNvPicPr>
           <p:nvPr/>
         </p:nvPicPr>
         <p:blipFill>
-          <a:blip xmlns:r="http://schemas.openxmlformats.org/officeDocument/2006/relationships" xmlns:a="http://schemas.openxmlformats.org/drawingml/2006/main" r:embed="Ra189893051d248b5"/>
+          <a:blip xmlns:r="http://schemas.openxmlformats.org/officeDocument/2006/relationships" xmlns:a="http://schemas.openxmlformats.org/drawingml/2006/main" r:embed="R159e7c596f66431b"/>
           <a:stretch xmlns:a="http://schemas.openxmlformats.org/drawingml/2006/main"/>
         </p:blipFill>
         <p:spPr>
@@ -7753,7 +9560,7 @@
     </p:spTree>
     <p:extLst>
       <p:ext uri="{BB962C8B-B14F-4D97-AF65-F5344CB8AC3E}">
-        <p14:creationId xmlns:p14="http://schemas.microsoft.com/office/powerpoint/2010/main" val="1751840914"/>
+        <p14:creationId xmlns:p14="http://schemas.microsoft.com/office/powerpoint/2010/main" val="1251642669"/>
       </p:ext>
     </p:extLst>
   </p:cSld>
@@ -7774,14 +9581,20 @@
       </p:grpSpPr>
       <p:pic>
         <p:nvPicPr>
-          <p:cNvPr id="2" name=""/>
+          <p:cNvPr id="2" name="">
+            <a:extLst xmlns:a="http://schemas.openxmlformats.org/drawingml/2006/main">
+              <a:ext uri="{FF2B5EF4-FFF2-40B4-BE49-F238E27FC236}">
+                <a16:creationId xmlns:a16="http://schemas.microsoft.com/office/drawing/2014/main" id="{B7940315-FB69-42D5-A16A-8CB06B1B809C}"/>
+              </a:ext>
+            </a:extLst>
+          </p:cNvPr>
           <p:cNvPicPr>
             <a:picLocks xmlns:a="http://schemas.openxmlformats.org/drawingml/2006/main" noChangeAspect="1"/>
           </p:cNvPicPr>
           <p:nvPr/>
         </p:nvPicPr>
         <p:blipFill>
-          <a:blip xmlns:r="http://schemas.openxmlformats.org/officeDocument/2006/relationships" xmlns:a="http://schemas.openxmlformats.org/drawingml/2006/main" r:embed="R9d606b5eb47e42e3"/>
+          <a:blip xmlns:r="http://schemas.openxmlformats.org/officeDocument/2006/relationships" xmlns:a="http://schemas.openxmlformats.org/drawingml/2006/main" r:embed="R102df909fa924b9f"/>
           <a:stretch xmlns:a="http://schemas.openxmlformats.org/drawingml/2006/main"/>
         </p:blipFill>
         <p:spPr>
@@ -7797,7 +9610,7 @@
     </p:spTree>
     <p:extLst>
       <p:ext uri="{BB962C8B-B14F-4D97-AF65-F5344CB8AC3E}">
-        <p14:creationId xmlns:p14="http://schemas.microsoft.com/office/powerpoint/2010/main" val="239656520"/>
+        <p14:creationId xmlns:p14="http://schemas.microsoft.com/office/powerpoint/2010/main" val="408653640"/>
       </p:ext>
     </p:extLst>
   </p:cSld>
@@ -7818,14 +9631,20 @@
       </p:grpSpPr>
       <p:pic>
         <p:nvPicPr>
-          <p:cNvPr id="2" name=""/>
+          <p:cNvPr id="2" name="">
+            <a:extLst xmlns:a="http://schemas.openxmlformats.org/drawingml/2006/main">
+              <a:ext uri="{FF2B5EF4-FFF2-40B4-BE49-F238E27FC236}">
+                <a16:creationId xmlns:a16="http://schemas.microsoft.com/office/drawing/2014/main" id="{5FA916B9-5C68-4211-B69B-D31ACC272208}"/>
+              </a:ext>
+            </a:extLst>
+          </p:cNvPr>
           <p:cNvPicPr>
             <a:picLocks xmlns:a="http://schemas.openxmlformats.org/drawingml/2006/main" noChangeAspect="1"/>
           </p:cNvPicPr>
           <p:nvPr/>
         </p:nvPicPr>
         <p:blipFill>
-          <a:blip xmlns:r="http://schemas.openxmlformats.org/officeDocument/2006/relationships" xmlns:a="http://schemas.openxmlformats.org/drawingml/2006/main" r:embed="R7f21f2289da64e8e"/>
+          <a:blip xmlns:r="http://schemas.openxmlformats.org/officeDocument/2006/relationships" xmlns:a="http://schemas.openxmlformats.org/drawingml/2006/main" r:embed="Rbecb1690039f4b0d"/>
           <a:stretch xmlns:a="http://schemas.openxmlformats.org/drawingml/2006/main"/>
         </p:blipFill>
         <p:spPr>
@@ -7841,7 +9660,7 @@
     </p:spTree>
     <p:extLst>
       <p:ext uri="{BB962C8B-B14F-4D97-AF65-F5344CB8AC3E}">
-        <p14:creationId xmlns:p14="http://schemas.microsoft.com/office/powerpoint/2010/main" val="1081785164"/>
+        <p14:creationId xmlns:p14="http://schemas.microsoft.com/office/powerpoint/2010/main" val="1883381828"/>
       </p:ext>
     </p:extLst>
   </p:cSld>
@@ -7862,14 +9681,20 @@
       </p:grpSpPr>
       <p:pic>
         <p:nvPicPr>
-          <p:cNvPr id="2" name=""/>
+          <p:cNvPr id="2" name="">
+            <a:extLst xmlns:a="http://schemas.openxmlformats.org/drawingml/2006/main">
+              <a:ext uri="{FF2B5EF4-FFF2-40B4-BE49-F238E27FC236}">
+                <a16:creationId xmlns:a16="http://schemas.microsoft.com/office/drawing/2014/main" id="{877EEC1B-34AC-4409-AEE7-272D4A503CDE}"/>
+              </a:ext>
+            </a:extLst>
+          </p:cNvPr>
           <p:cNvPicPr>
             <a:picLocks xmlns:a="http://schemas.openxmlformats.org/drawingml/2006/main" noChangeAspect="1"/>
           </p:cNvPicPr>
           <p:nvPr/>
         </p:nvPicPr>
         <p:blipFill>
-          <a:blip xmlns:r="http://schemas.openxmlformats.org/officeDocument/2006/relationships" xmlns:a="http://schemas.openxmlformats.org/drawingml/2006/main" r:embed="R0f00c436891a4f49"/>
+          <a:blip xmlns:r="http://schemas.openxmlformats.org/officeDocument/2006/relationships" xmlns:a="http://schemas.openxmlformats.org/drawingml/2006/main" r:embed="Rc6951bc5b0334fcc"/>
           <a:stretch xmlns:a="http://schemas.openxmlformats.org/drawingml/2006/main"/>
         </p:blipFill>
         <p:spPr>
@@ -7885,7 +9710,7 @@
     </p:spTree>
     <p:extLst>
       <p:ext uri="{BB962C8B-B14F-4D97-AF65-F5344CB8AC3E}">
-        <p14:creationId xmlns:p14="http://schemas.microsoft.com/office/powerpoint/2010/main" val="1479217963"/>
+        <p14:creationId xmlns:p14="http://schemas.microsoft.com/office/powerpoint/2010/main" val="639803548"/>
       </p:ext>
     </p:extLst>
   </p:cSld>
@@ -7906,14 +9731,20 @@
       </p:grpSpPr>
       <p:pic>
         <p:nvPicPr>
-          <p:cNvPr id="2" name=""/>
+          <p:cNvPr id="2" name="">
+            <a:extLst xmlns:a="http://schemas.openxmlformats.org/drawingml/2006/main">
+              <a:ext uri="{FF2B5EF4-FFF2-40B4-BE49-F238E27FC236}">
+                <a16:creationId xmlns:a16="http://schemas.microsoft.com/office/drawing/2014/main" id="{E4008207-CA50-47EC-B2C2-7F9BC208FDAF}"/>
+              </a:ext>
+            </a:extLst>
+          </p:cNvPr>
           <p:cNvPicPr>
             <a:picLocks xmlns:a="http://schemas.openxmlformats.org/drawingml/2006/main" noChangeAspect="1"/>
           </p:cNvPicPr>
           <p:nvPr/>
         </p:nvPicPr>
         <p:blipFill>
-          <a:blip xmlns:r="http://schemas.openxmlformats.org/officeDocument/2006/relationships" xmlns:a="http://schemas.openxmlformats.org/drawingml/2006/main" r:embed="Ra2ce5149afbe4d00"/>
+          <a:blip xmlns:r="http://schemas.openxmlformats.org/officeDocument/2006/relationships" xmlns:a="http://schemas.openxmlformats.org/drawingml/2006/main" r:embed="R8c20807ada83451d"/>
           <a:stretch xmlns:a="http://schemas.openxmlformats.org/drawingml/2006/main"/>
         </p:blipFill>
         <p:spPr>
@@ -7929,7 +9760,7 @@
     </p:spTree>
     <p:extLst>
       <p:ext uri="{BB962C8B-B14F-4D97-AF65-F5344CB8AC3E}">
-        <p14:creationId xmlns:p14="http://schemas.microsoft.com/office/powerpoint/2010/main" val="477941256"/>
+        <p14:creationId xmlns:p14="http://schemas.microsoft.com/office/powerpoint/2010/main" val="1482577691"/>
       </p:ext>
     </p:extLst>
   </p:cSld>
@@ -7977,16 +9808,16 @@
         <a:srgbClr val="96607D"/>
       </a:folHlink>
     </a:clrScheme>
-    <a:fontScheme name="Office">
+    <a:fontScheme name="">
       <a:majorFont>
-        <a:latin typeface="Calibri Light"/>
-        <a:ea typeface="Calibri Light"/>
-        <a:cs typeface="Calibri Light"/>
+        <a:latin typeface="Aptos"/>
+        <a:ea typeface=""/>
+        <a:cs typeface=""/>
       </a:majorFont>
       <a:minorFont>
-        <a:latin typeface="Calibri"/>
-        <a:ea typeface="Calibri"/>
-        <a:cs typeface="Calibri"/>
+        <a:latin typeface="Aptos"/>
+        <a:ea typeface=""/>
+        <a:cs typeface=""/>
       </a:minorFont>
     </a:fontScheme>
     <a:fmtScheme name="ChatGPT">

</xml_diff>